<commit_message>
Update Thesis presentation slides
</commit_message>
<xml_diff>
--- a/cross_encoder/thesis/Thesis_presentation.pptx
+++ b/cross_encoder/thesis/Thesis_presentation.pptx
@@ -21,13 +21,13 @@
     <p:sldId id="271" r:id="rId12"/>
     <p:sldId id="273" r:id="rId13"/>
     <p:sldId id="272" r:id="rId14"/>
-    <p:sldId id="275" r:id="rId15"/>
-    <p:sldId id="276" r:id="rId16"/>
-    <p:sldId id="277" r:id="rId17"/>
-    <p:sldId id="278" r:id="rId18"/>
-    <p:sldId id="269" r:id="rId19"/>
-    <p:sldId id="259" r:id="rId20"/>
-    <p:sldId id="268" r:id="rId21"/>
+    <p:sldId id="279" r:id="rId15"/>
+    <p:sldId id="275" r:id="rId16"/>
+    <p:sldId id="276" r:id="rId17"/>
+    <p:sldId id="277" r:id="rId18"/>
+    <p:sldId id="278" r:id="rId19"/>
+    <p:sldId id="269" r:id="rId20"/>
+    <p:sldId id="259" r:id="rId21"/>
   </p:sldIdLst>
   <p:sldSz cx="12192000" cy="6858000"/>
   <p:notesSz cx="6858000" cy="9144000"/>
@@ -1626,7 +1626,7 @@
           <a:p>
             <a:fld id="{E6AEB063-7F11-4E3B-BA52-07405B1C2D95}" type="slidenum">
               <a:rPr lang="en-US" smtClean="0"/>
-              <a:t>16</a:t>
+              <a:t>17</a:t>
             </a:fld>
             <a:endParaRPr lang="en-US" dirty="0"/>
           </a:p>
@@ -1636,97 +1636,6 @@
     <p:extLst>
       <p:ext uri="{BB962C8B-B14F-4D97-AF65-F5344CB8AC3E}">
         <p14:creationId xmlns:p14="http://schemas.microsoft.com/office/powerpoint/2010/main" val="3338027317"/>
-      </p:ext>
-    </p:extLst>
-  </p:cSld>
-  <p:clrMapOvr>
-    <a:masterClrMapping/>
-  </p:clrMapOvr>
-</p:notes>
-</file>
-
-<file path=ppt/notesSlides/notesSlide9.xml><?xml version="1.0" encoding="utf-8"?>
-<p:notes xmlns:a="http://schemas.openxmlformats.org/drawingml/2006/main" xmlns:r="http://schemas.openxmlformats.org/officeDocument/2006/relationships" xmlns:p="http://schemas.openxmlformats.org/presentationml/2006/main">
-  <p:cSld>
-    <p:spTree>
-      <p:nvGrpSpPr>
-        <p:cNvPr id="1" name=""/>
-        <p:cNvGrpSpPr/>
-        <p:nvPr/>
-      </p:nvGrpSpPr>
-      <p:grpSpPr>
-        <a:xfrm>
-          <a:off x="0" y="0"/>
-          <a:ext cx="0" cy="0"/>
-          <a:chOff x="0" y="0"/>
-          <a:chExt cx="0" cy="0"/>
-        </a:xfrm>
-      </p:grpSpPr>
-      <p:sp>
-        <p:nvSpPr>
-          <p:cNvPr id="2" name="Slide Image Placeholder 1"/>
-          <p:cNvSpPr>
-            <a:spLocks noGrp="1" noRot="1" noChangeAspect="1"/>
-          </p:cNvSpPr>
-          <p:nvPr>
-            <p:ph type="sldImg"/>
-          </p:nvPr>
-        </p:nvSpPr>
-        <p:spPr/>
-      </p:sp>
-      <p:sp>
-        <p:nvSpPr>
-          <p:cNvPr id="3" name="Notes Placeholder 2"/>
-          <p:cNvSpPr>
-            <a:spLocks noGrp="1"/>
-          </p:cNvSpPr>
-          <p:nvPr>
-            <p:ph type="body" idx="1"/>
-          </p:nvPr>
-        </p:nvSpPr>
-        <p:spPr/>
-        <p:txBody>
-          <a:bodyPr/>
-          <a:lstStyle/>
-          <a:p>
-            <a:r>
-              <a:rPr lang="en-US" dirty="0">
-                <a:latin typeface="Tahoma" panose="020B0604030504040204" pitchFamily="34" charset="0"/>
-                <a:ea typeface="Tahoma" panose="020B0604030504040204" pitchFamily="34" charset="0"/>
-                <a:cs typeface="Tahoma" panose="020B0604030504040204" pitchFamily="34" charset="0"/>
-              </a:rPr>
-              <a:t>The action step is what the audience is supposed to do or think about the topic.  It should be one sentence that is written clearly and with much thought. It may also be the thesis statement restated as an action.  The goal of this slide is to leave the audience with a clear message as to what they are to do or think at the end of the speech.  It may be a good idea to end with a powerful quote or image.  </a:t>
-            </a:r>
-          </a:p>
-        </p:txBody>
-      </p:sp>
-      <p:sp>
-        <p:nvSpPr>
-          <p:cNvPr id="4" name="Slide Number Placeholder 3"/>
-          <p:cNvSpPr>
-            <a:spLocks noGrp="1"/>
-          </p:cNvSpPr>
-          <p:nvPr>
-            <p:ph type="sldNum" sz="quarter" idx="10"/>
-          </p:nvPr>
-        </p:nvSpPr>
-        <p:spPr/>
-        <p:txBody>
-          <a:bodyPr/>
-          <a:lstStyle/>
-          <a:p>
-            <a:fld id="{E6AEB063-7F11-4E3B-BA52-07405B1C2D95}" type="slidenum">
-              <a:rPr lang="en-US" smtClean="0"/>
-              <a:t>17</a:t>
-            </a:fld>
-            <a:endParaRPr lang="en-US" dirty="0"/>
-          </a:p>
-        </p:txBody>
-      </p:sp>
-    </p:spTree>
-    <p:extLst>
-      <p:ext uri="{BB962C8B-B14F-4D97-AF65-F5344CB8AC3E}">
-        <p14:creationId xmlns:p14="http://schemas.microsoft.com/office/powerpoint/2010/main" val="2906257609"/>
       </p:ext>
     </p:extLst>
   </p:cSld>
@@ -9290,6 +9199,874 @@
   <p:cSld>
     <p:spTree>
       <p:nvGrpSpPr>
+        <p:cNvPr id="1" name="">
+          <a:extLst>
+            <a:ext uri="{FF2B5EF4-FFF2-40B4-BE49-F238E27FC236}">
+              <a16:creationId xmlns:a16="http://schemas.microsoft.com/office/drawing/2014/main" id="{1AF13AF9-D74D-C4B9-6FB6-E42134EEC347}"/>
+            </a:ext>
+          </a:extLst>
+        </p:cNvPr>
+        <p:cNvGrpSpPr/>
+        <p:nvPr/>
+      </p:nvGrpSpPr>
+      <p:grpSpPr>
+        <a:xfrm>
+          <a:off x="0" y="0"/>
+          <a:ext cx="0" cy="0"/>
+          <a:chOff x="0" y="0"/>
+          <a:chExt cx="0" cy="0"/>
+        </a:xfrm>
+      </p:grpSpPr>
+      <p:sp>
+        <p:nvSpPr>
+          <p:cNvPr id="4" name="Text Placeholder 3">
+            <a:extLst>
+              <a:ext uri="{FF2B5EF4-FFF2-40B4-BE49-F238E27FC236}">
+                <a16:creationId xmlns:a16="http://schemas.microsoft.com/office/drawing/2014/main" id="{0E827B3D-F915-4993-C941-A3487448D855}"/>
+              </a:ext>
+            </a:extLst>
+          </p:cNvPr>
+          <p:cNvSpPr>
+            <a:spLocks noGrp="1"/>
+          </p:cNvSpPr>
+          <p:nvPr>
+            <p:ph type="body" sz="half" idx="2"/>
+          </p:nvPr>
+        </p:nvSpPr>
+        <p:spPr>
+          <a:xfrm>
+            <a:off x="741512" y="1091843"/>
+            <a:ext cx="10708975" cy="5044557"/>
+          </a:xfrm>
+        </p:spPr>
+        <p:txBody>
+          <a:bodyPr>
+            <a:normAutofit/>
+          </a:bodyPr>
+          <a:lstStyle/>
+          <a:p>
+            <a:r>
+              <a:rPr lang="en-GB" sz="3000" b="1" dirty="0">
+                <a:latin typeface="Barlow Medium" panose="00000600000000000000" pitchFamily="2" charset="0"/>
+              </a:rPr>
+              <a:t> ⚙️ </a:t>
+            </a:r>
+            <a:r>
+              <a:rPr lang="en-IN" sz="3000" b="1" dirty="0">
+                <a:latin typeface="Barlow Medium" panose="00000600000000000000" pitchFamily="2" charset="0"/>
+              </a:rPr>
+              <a:t>Hyperparameter Settings</a:t>
+            </a:r>
+          </a:p>
+          <a:p>
+            <a:endParaRPr lang="en-IN" sz="3000" b="1" dirty="0">
+              <a:latin typeface="Barlow Medium" panose="00000600000000000000" pitchFamily="2" charset="0"/>
+            </a:endParaRPr>
+          </a:p>
+          <a:p>
+            <a:endParaRPr lang="en-IN" sz="3000" b="1" dirty="0">
+              <a:latin typeface="Barlow Medium" panose="00000600000000000000" pitchFamily="2" charset="0"/>
+            </a:endParaRPr>
+          </a:p>
+        </p:txBody>
+      </p:sp>
+      <p:graphicFrame>
+        <p:nvGraphicFramePr>
+          <p:cNvPr id="6" name="Table 5">
+            <a:extLst>
+              <a:ext uri="{FF2B5EF4-FFF2-40B4-BE49-F238E27FC236}">
+                <a16:creationId xmlns:a16="http://schemas.microsoft.com/office/drawing/2014/main" id="{2A877A18-81E0-4688-5F13-8FFB50660AB7}"/>
+              </a:ext>
+            </a:extLst>
+          </p:cNvPr>
+          <p:cNvGraphicFramePr>
+            <a:graphicFrameLocks noGrp="1"/>
+          </p:cNvGraphicFramePr>
+          <p:nvPr>
+            <p:extLst>
+              <p:ext uri="{D42A27DB-BD31-4B8C-83A1-F6EECF244321}">
+                <p14:modId xmlns:p14="http://schemas.microsoft.com/office/powerpoint/2010/main" val="1705017312"/>
+              </p:ext>
+            </p:extLst>
+          </p:nvPr>
+        </p:nvGraphicFramePr>
+        <p:xfrm>
+          <a:off x="851383" y="2131060"/>
+          <a:ext cx="8524113" cy="3048000"/>
+        </p:xfrm>
+        <a:graphic>
+          <a:graphicData uri="http://schemas.openxmlformats.org/drawingml/2006/table">
+            <a:tbl>
+              <a:tblPr firstRow="1" bandRow="1">
+                <a:tableStyleId>{69C7853C-536D-4A76-A0AE-DD22124D55A5}</a:tableStyleId>
+              </a:tblPr>
+              <a:tblGrid>
+                <a:gridCol w="2372456">
+                  <a:extLst>
+                    <a:ext uri="{9D8B030D-6E8A-4147-A177-3AD203B41FA5}">
+                      <a16:colId xmlns:a16="http://schemas.microsoft.com/office/drawing/2014/main" val="289530700"/>
+                    </a:ext>
+                  </a:extLst>
+                </a:gridCol>
+                <a:gridCol w="3310286">
+                  <a:extLst>
+                    <a:ext uri="{9D8B030D-6E8A-4147-A177-3AD203B41FA5}">
+                      <a16:colId xmlns:a16="http://schemas.microsoft.com/office/drawing/2014/main" val="986979421"/>
+                    </a:ext>
+                  </a:extLst>
+                </a:gridCol>
+                <a:gridCol w="2841371">
+                  <a:extLst>
+                    <a:ext uri="{9D8B030D-6E8A-4147-A177-3AD203B41FA5}">
+                      <a16:colId xmlns:a16="http://schemas.microsoft.com/office/drawing/2014/main" val="414445897"/>
+                    </a:ext>
+                  </a:extLst>
+                </a:gridCol>
+              </a:tblGrid>
+              <a:tr h="370840">
+                <a:tc>
+                  <a:txBody>
+                    <a:bodyPr/>
+                    <a:lstStyle/>
+                    <a:p>
+                      <a:pPr algn="ctr"/>
+                      <a:r>
+                        <a:rPr lang="en-GB" sz="2400" dirty="0">
+                          <a:latin typeface="Barlow SemiBold" panose="00000700000000000000" pitchFamily="2" charset="0"/>
+                        </a:rPr>
+                        <a:t>Parameter</a:t>
+                      </a:r>
+                      <a:endParaRPr lang="en-IN" sz="2400" dirty="0">
+                        <a:latin typeface="Barlow SemiBold" panose="00000700000000000000" pitchFamily="2" charset="0"/>
+                      </a:endParaRPr>
+                    </a:p>
+                  </a:txBody>
+                  <a:tcPr>
+                    <a:solidFill>
+                      <a:srgbClr val="00B0F0"/>
+                    </a:solidFill>
+                  </a:tcPr>
+                </a:tc>
+                <a:tc>
+                  <a:txBody>
+                    <a:bodyPr/>
+                    <a:lstStyle/>
+                    <a:p>
+                      <a:pPr algn="ctr"/>
+                      <a:r>
+                        <a:rPr lang="en-GB" sz="2400" dirty="0">
+                          <a:latin typeface="Barlow SemiBold" panose="00000700000000000000" pitchFamily="2" charset="0"/>
+                        </a:rPr>
+                        <a:t>AdamW</a:t>
+                      </a:r>
+                      <a:endParaRPr lang="en-IN" sz="2400" dirty="0">
+                        <a:latin typeface="Barlow SemiBold" panose="00000700000000000000" pitchFamily="2" charset="0"/>
+                      </a:endParaRPr>
+                    </a:p>
+                  </a:txBody>
+                  <a:tcPr>
+                    <a:solidFill>
+                      <a:srgbClr val="00B0F0"/>
+                    </a:solidFill>
+                  </a:tcPr>
+                </a:tc>
+                <a:tc>
+                  <a:txBody>
+                    <a:bodyPr/>
+                    <a:lstStyle/>
+                    <a:p>
+                      <a:pPr algn="ctr"/>
+                      <a:r>
+                        <a:rPr lang="en-GB" sz="2400" dirty="0">
+                          <a:latin typeface="Barlow SemiBold" panose="00000700000000000000" pitchFamily="2" charset="0"/>
+                        </a:rPr>
+                        <a:t>Lion</a:t>
+                      </a:r>
+                      <a:endParaRPr lang="en-IN" sz="2400" dirty="0">
+                        <a:latin typeface="Barlow SemiBold" panose="00000700000000000000" pitchFamily="2" charset="0"/>
+                      </a:endParaRPr>
+                    </a:p>
+                  </a:txBody>
+                  <a:tcPr>
+                    <a:solidFill>
+                      <a:srgbClr val="00B0F0"/>
+                    </a:solidFill>
+                  </a:tcPr>
+                </a:tc>
+                <a:extLst>
+                  <a:ext uri="{0D108BD9-81ED-4DB2-BD59-A6C34878D82A}">
+                    <a16:rowId xmlns:a16="http://schemas.microsoft.com/office/drawing/2014/main" val="324739917"/>
+                  </a:ext>
+                </a:extLst>
+              </a:tr>
+              <a:tr h="370840">
+                <a:tc>
+                  <a:txBody>
+                    <a:bodyPr/>
+                    <a:lstStyle/>
+                    <a:p>
+                      <a:pPr algn="ctr"/>
+                      <a:r>
+                        <a:rPr lang="en-IN" sz="2000" b="1" dirty="0">
+                          <a:solidFill>
+                            <a:schemeClr val="tx1"/>
+                          </a:solidFill>
+                          <a:effectLst/>
+                          <a:latin typeface="Barlow" panose="00000500000000000000" pitchFamily="2" charset="0"/>
+                        </a:rPr>
+                        <a:t>Learning Rate</a:t>
+                      </a:r>
+                      <a:endParaRPr lang="en-IN" sz="2000" dirty="0">
+                        <a:solidFill>
+                          <a:schemeClr val="tx1"/>
+                        </a:solidFill>
+                        <a:effectLst/>
+                        <a:latin typeface="Barlow" panose="00000500000000000000" pitchFamily="2" charset="0"/>
+                      </a:endParaRPr>
+                    </a:p>
+                  </a:txBody>
+                  <a:tcPr anchor="ctr">
+                    <a:lnB w="3175" cap="flat" cmpd="sng" algn="ctr">
+                      <a:solidFill>
+                        <a:schemeClr val="tx1"/>
+                      </a:solidFill>
+                      <a:prstDash val="solid"/>
+                      <a:round/>
+                      <a:headEnd type="none" w="med" len="med"/>
+                      <a:tailEnd type="none" w="med" len="med"/>
+                    </a:lnB>
+                    <a:solidFill>
+                      <a:schemeClr val="bg1"/>
+                    </a:solidFill>
+                  </a:tcPr>
+                </a:tc>
+                <a:tc>
+                  <a:txBody>
+                    <a:bodyPr/>
+                    <a:lstStyle/>
+                    <a:p>
+                      <a:pPr algn="ctr"/>
+                      <a:r>
+                        <a:rPr lang="en-IN" sz="2000">
+                          <a:solidFill>
+                            <a:schemeClr val="tx1"/>
+                          </a:solidFill>
+                          <a:effectLst/>
+                          <a:latin typeface="Barlow" panose="00000500000000000000" pitchFamily="2" charset="0"/>
+                        </a:rPr>
+                        <a:t>2e-5 (standard)</a:t>
+                      </a:r>
+                    </a:p>
+                  </a:txBody>
+                  <a:tcPr anchor="ctr">
+                    <a:lnB w="3175" cap="flat" cmpd="sng" algn="ctr">
+                      <a:solidFill>
+                        <a:schemeClr val="tx1"/>
+                      </a:solidFill>
+                      <a:prstDash val="solid"/>
+                      <a:round/>
+                      <a:headEnd type="none" w="med" len="med"/>
+                      <a:tailEnd type="none" w="med" len="med"/>
+                    </a:lnB>
+                    <a:solidFill>
+                      <a:schemeClr val="bg1"/>
+                    </a:solidFill>
+                  </a:tcPr>
+                </a:tc>
+                <a:tc>
+                  <a:txBody>
+                    <a:bodyPr/>
+                    <a:lstStyle/>
+                    <a:p>
+                      <a:pPr algn="ctr"/>
+                      <a:r>
+                        <a:rPr lang="en-IN" sz="2000" dirty="0">
+                          <a:solidFill>
+                            <a:schemeClr val="tx1"/>
+                          </a:solidFill>
+                          <a:effectLst/>
+                          <a:latin typeface="Barlow" panose="00000500000000000000" pitchFamily="2" charset="0"/>
+                        </a:rPr>
+                        <a:t>2e-5 (2e-6 for ModernBERT)</a:t>
+                      </a:r>
+                    </a:p>
+                  </a:txBody>
+                  <a:tcPr anchor="ctr">
+                    <a:lnB w="3175" cap="flat" cmpd="sng" algn="ctr">
+                      <a:solidFill>
+                        <a:schemeClr val="tx1"/>
+                      </a:solidFill>
+                      <a:prstDash val="solid"/>
+                      <a:round/>
+                      <a:headEnd type="none" w="med" len="med"/>
+                      <a:tailEnd type="none" w="med" len="med"/>
+                    </a:lnB>
+                    <a:solidFill>
+                      <a:schemeClr val="bg1"/>
+                    </a:solidFill>
+                  </a:tcPr>
+                </a:tc>
+                <a:extLst>
+                  <a:ext uri="{0D108BD9-81ED-4DB2-BD59-A6C34878D82A}">
+                    <a16:rowId xmlns:a16="http://schemas.microsoft.com/office/drawing/2014/main" val="27877144"/>
+                  </a:ext>
+                </a:extLst>
+              </a:tr>
+              <a:tr h="370840">
+                <a:tc>
+                  <a:txBody>
+                    <a:bodyPr/>
+                    <a:lstStyle/>
+                    <a:p>
+                      <a:pPr algn="ctr"/>
+                      <a:r>
+                        <a:rPr lang="en-IN" sz="2000" b="1">
+                          <a:solidFill>
+                            <a:schemeClr val="tx1"/>
+                          </a:solidFill>
+                          <a:effectLst/>
+                          <a:latin typeface="Barlow" panose="00000500000000000000" pitchFamily="2" charset="0"/>
+                        </a:rPr>
+                        <a:t>Weight Decay</a:t>
+                      </a:r>
+                      <a:endParaRPr lang="en-IN" sz="2000">
+                        <a:solidFill>
+                          <a:schemeClr val="tx1"/>
+                        </a:solidFill>
+                        <a:effectLst/>
+                        <a:latin typeface="Barlow" panose="00000500000000000000" pitchFamily="2" charset="0"/>
+                      </a:endParaRPr>
+                    </a:p>
+                  </a:txBody>
+                  <a:tcPr anchor="ctr">
+                    <a:lnT w="3175" cap="flat" cmpd="sng" algn="ctr">
+                      <a:solidFill>
+                        <a:schemeClr val="tx1"/>
+                      </a:solidFill>
+                      <a:prstDash val="solid"/>
+                      <a:round/>
+                      <a:headEnd type="none" w="med" len="med"/>
+                      <a:tailEnd type="none" w="med" len="med"/>
+                    </a:lnT>
+                    <a:lnB w="3175" cap="flat" cmpd="sng" algn="ctr">
+                      <a:solidFill>
+                        <a:schemeClr val="tx1"/>
+                      </a:solidFill>
+                      <a:prstDash val="solid"/>
+                      <a:round/>
+                      <a:headEnd type="none" w="med" len="med"/>
+                      <a:tailEnd type="none" w="med" len="med"/>
+                    </a:lnB>
+                    <a:solidFill>
+                      <a:schemeClr val="bg1"/>
+                    </a:solidFill>
+                  </a:tcPr>
+                </a:tc>
+                <a:tc>
+                  <a:txBody>
+                    <a:bodyPr/>
+                    <a:lstStyle/>
+                    <a:p>
+                      <a:pPr algn="ctr"/>
+                      <a:r>
+                        <a:rPr lang="en-IN" sz="2000" dirty="0">
+                          <a:solidFill>
+                            <a:schemeClr val="tx1"/>
+                          </a:solidFill>
+                          <a:effectLst/>
+                          <a:latin typeface="Barlow" panose="00000500000000000000" pitchFamily="2" charset="0"/>
+                        </a:rPr>
+                        <a:t>0.01</a:t>
+                      </a:r>
+                    </a:p>
+                  </a:txBody>
+                  <a:tcPr anchor="ctr">
+                    <a:lnT w="3175" cap="flat" cmpd="sng" algn="ctr">
+                      <a:solidFill>
+                        <a:schemeClr val="tx1"/>
+                      </a:solidFill>
+                      <a:prstDash val="solid"/>
+                      <a:round/>
+                      <a:headEnd type="none" w="med" len="med"/>
+                      <a:tailEnd type="none" w="med" len="med"/>
+                    </a:lnT>
+                    <a:lnB w="3175" cap="flat" cmpd="sng" algn="ctr">
+                      <a:solidFill>
+                        <a:schemeClr val="tx1"/>
+                      </a:solidFill>
+                      <a:prstDash val="solid"/>
+                      <a:round/>
+                      <a:headEnd type="none" w="med" len="med"/>
+                      <a:tailEnd type="none" w="med" len="med"/>
+                    </a:lnB>
+                    <a:solidFill>
+                      <a:schemeClr val="bg1"/>
+                    </a:solidFill>
+                  </a:tcPr>
+                </a:tc>
+                <a:tc>
+                  <a:txBody>
+                    <a:bodyPr/>
+                    <a:lstStyle/>
+                    <a:p>
+                      <a:pPr algn="ctr"/>
+                      <a:r>
+                        <a:rPr lang="en-IN" sz="2000">
+                          <a:solidFill>
+                            <a:schemeClr val="tx1"/>
+                          </a:solidFill>
+                          <a:effectLst/>
+                          <a:latin typeface="Barlow" panose="00000500000000000000" pitchFamily="2" charset="0"/>
+                        </a:rPr>
+                        <a:t>0.01</a:t>
+                      </a:r>
+                    </a:p>
+                  </a:txBody>
+                  <a:tcPr anchor="ctr">
+                    <a:lnT w="3175" cap="flat" cmpd="sng" algn="ctr">
+                      <a:solidFill>
+                        <a:schemeClr val="tx1"/>
+                      </a:solidFill>
+                      <a:prstDash val="solid"/>
+                      <a:round/>
+                      <a:headEnd type="none" w="med" len="med"/>
+                      <a:tailEnd type="none" w="med" len="med"/>
+                    </a:lnT>
+                    <a:lnB w="3175" cap="flat" cmpd="sng" algn="ctr">
+                      <a:solidFill>
+                        <a:schemeClr val="tx1"/>
+                      </a:solidFill>
+                      <a:prstDash val="solid"/>
+                      <a:round/>
+                      <a:headEnd type="none" w="med" len="med"/>
+                      <a:tailEnd type="none" w="med" len="med"/>
+                    </a:lnB>
+                    <a:solidFill>
+                      <a:schemeClr val="bg1"/>
+                    </a:solidFill>
+                  </a:tcPr>
+                </a:tc>
+                <a:extLst>
+                  <a:ext uri="{0D108BD9-81ED-4DB2-BD59-A6C34878D82A}">
+                    <a16:rowId xmlns:a16="http://schemas.microsoft.com/office/drawing/2014/main" val="2728026833"/>
+                  </a:ext>
+                </a:extLst>
+              </a:tr>
+              <a:tr h="370840">
+                <a:tc>
+                  <a:txBody>
+                    <a:bodyPr/>
+                    <a:lstStyle/>
+                    <a:p>
+                      <a:pPr algn="ctr"/>
+                      <a:r>
+                        <a:rPr lang="en-IN" sz="2000" b="1">
+                          <a:solidFill>
+                            <a:schemeClr val="tx1"/>
+                          </a:solidFill>
+                          <a:effectLst/>
+                          <a:latin typeface="Barlow" panose="00000500000000000000" pitchFamily="2" charset="0"/>
+                        </a:rPr>
+                        <a:t>Beta1</a:t>
+                      </a:r>
+                      <a:endParaRPr lang="en-IN" sz="2000">
+                        <a:solidFill>
+                          <a:schemeClr val="tx1"/>
+                        </a:solidFill>
+                        <a:effectLst/>
+                        <a:latin typeface="Barlow" panose="00000500000000000000" pitchFamily="2" charset="0"/>
+                      </a:endParaRPr>
+                    </a:p>
+                  </a:txBody>
+                  <a:tcPr anchor="ctr">
+                    <a:lnT w="3175" cap="flat" cmpd="sng" algn="ctr">
+                      <a:solidFill>
+                        <a:schemeClr val="tx1"/>
+                      </a:solidFill>
+                      <a:prstDash val="solid"/>
+                      <a:round/>
+                      <a:headEnd type="none" w="med" len="med"/>
+                      <a:tailEnd type="none" w="med" len="med"/>
+                    </a:lnT>
+                    <a:lnB w="3175" cap="flat" cmpd="sng" algn="ctr">
+                      <a:solidFill>
+                        <a:schemeClr val="tx1"/>
+                      </a:solidFill>
+                      <a:prstDash val="solid"/>
+                      <a:round/>
+                      <a:headEnd type="none" w="med" len="med"/>
+                      <a:tailEnd type="none" w="med" len="med"/>
+                    </a:lnB>
+                    <a:solidFill>
+                      <a:schemeClr val="bg1"/>
+                    </a:solidFill>
+                  </a:tcPr>
+                </a:tc>
+                <a:tc>
+                  <a:txBody>
+                    <a:bodyPr/>
+                    <a:lstStyle/>
+                    <a:p>
+                      <a:pPr algn="ctr"/>
+                      <a:r>
+                        <a:rPr lang="en-IN" sz="2000" dirty="0">
+                          <a:solidFill>
+                            <a:schemeClr val="tx1"/>
+                          </a:solidFill>
+                          <a:effectLst/>
+                          <a:latin typeface="Barlow" panose="00000500000000000000" pitchFamily="2" charset="0"/>
+                        </a:rPr>
+                        <a:t>0.9</a:t>
+                      </a:r>
+                    </a:p>
+                  </a:txBody>
+                  <a:tcPr anchor="ctr">
+                    <a:lnT w="3175" cap="flat" cmpd="sng" algn="ctr">
+                      <a:solidFill>
+                        <a:schemeClr val="tx1"/>
+                      </a:solidFill>
+                      <a:prstDash val="solid"/>
+                      <a:round/>
+                      <a:headEnd type="none" w="med" len="med"/>
+                      <a:tailEnd type="none" w="med" len="med"/>
+                    </a:lnT>
+                    <a:lnB w="3175" cap="flat" cmpd="sng" algn="ctr">
+                      <a:solidFill>
+                        <a:schemeClr val="tx1"/>
+                      </a:solidFill>
+                      <a:prstDash val="solid"/>
+                      <a:round/>
+                      <a:headEnd type="none" w="med" len="med"/>
+                      <a:tailEnd type="none" w="med" len="med"/>
+                    </a:lnB>
+                    <a:solidFill>
+                      <a:schemeClr val="bg1"/>
+                    </a:solidFill>
+                  </a:tcPr>
+                </a:tc>
+                <a:tc>
+                  <a:txBody>
+                    <a:bodyPr/>
+                    <a:lstStyle/>
+                    <a:p>
+                      <a:pPr algn="ctr"/>
+                      <a:r>
+                        <a:rPr lang="en-IN" sz="2000">
+                          <a:solidFill>
+                            <a:schemeClr val="tx1"/>
+                          </a:solidFill>
+                          <a:effectLst/>
+                          <a:latin typeface="Barlow" panose="00000500000000000000" pitchFamily="2" charset="0"/>
+                        </a:rPr>
+                        <a:t>0.9</a:t>
+                      </a:r>
+                    </a:p>
+                  </a:txBody>
+                  <a:tcPr anchor="ctr">
+                    <a:lnT w="3175" cap="flat" cmpd="sng" algn="ctr">
+                      <a:solidFill>
+                        <a:schemeClr val="tx1"/>
+                      </a:solidFill>
+                      <a:prstDash val="solid"/>
+                      <a:round/>
+                      <a:headEnd type="none" w="med" len="med"/>
+                      <a:tailEnd type="none" w="med" len="med"/>
+                    </a:lnT>
+                    <a:lnB w="3175" cap="flat" cmpd="sng" algn="ctr">
+                      <a:solidFill>
+                        <a:schemeClr val="tx1"/>
+                      </a:solidFill>
+                      <a:prstDash val="solid"/>
+                      <a:round/>
+                      <a:headEnd type="none" w="med" len="med"/>
+                      <a:tailEnd type="none" w="med" len="med"/>
+                    </a:lnB>
+                    <a:solidFill>
+                      <a:schemeClr val="bg1"/>
+                    </a:solidFill>
+                  </a:tcPr>
+                </a:tc>
+                <a:extLst>
+                  <a:ext uri="{0D108BD9-81ED-4DB2-BD59-A6C34878D82A}">
+                    <a16:rowId xmlns:a16="http://schemas.microsoft.com/office/drawing/2014/main" val="3140773565"/>
+                  </a:ext>
+                </a:extLst>
+              </a:tr>
+              <a:tr h="370840">
+                <a:tc>
+                  <a:txBody>
+                    <a:bodyPr/>
+                    <a:lstStyle/>
+                    <a:p>
+                      <a:pPr algn="ctr"/>
+                      <a:r>
+                        <a:rPr lang="en-IN" sz="2000" b="1">
+                          <a:solidFill>
+                            <a:schemeClr val="tx1"/>
+                          </a:solidFill>
+                          <a:effectLst/>
+                          <a:latin typeface="Barlow" panose="00000500000000000000" pitchFamily="2" charset="0"/>
+                        </a:rPr>
+                        <a:t>Beta2</a:t>
+                      </a:r>
+                      <a:endParaRPr lang="en-IN" sz="2000">
+                        <a:solidFill>
+                          <a:schemeClr val="tx1"/>
+                        </a:solidFill>
+                        <a:effectLst/>
+                        <a:latin typeface="Barlow" panose="00000500000000000000" pitchFamily="2" charset="0"/>
+                      </a:endParaRPr>
+                    </a:p>
+                  </a:txBody>
+                  <a:tcPr anchor="ctr">
+                    <a:lnT w="3175" cap="flat" cmpd="sng" algn="ctr">
+                      <a:solidFill>
+                        <a:schemeClr val="tx1"/>
+                      </a:solidFill>
+                      <a:prstDash val="solid"/>
+                      <a:round/>
+                      <a:headEnd type="none" w="med" len="med"/>
+                      <a:tailEnd type="none" w="med" len="med"/>
+                    </a:lnT>
+                    <a:lnB w="3175" cap="flat" cmpd="sng" algn="ctr">
+                      <a:solidFill>
+                        <a:schemeClr val="tx1"/>
+                      </a:solidFill>
+                      <a:prstDash val="solid"/>
+                      <a:round/>
+                      <a:headEnd type="none" w="med" len="med"/>
+                      <a:tailEnd type="none" w="med" len="med"/>
+                    </a:lnB>
+                    <a:solidFill>
+                      <a:schemeClr val="bg1"/>
+                    </a:solidFill>
+                  </a:tcPr>
+                </a:tc>
+                <a:tc>
+                  <a:txBody>
+                    <a:bodyPr/>
+                    <a:lstStyle/>
+                    <a:p>
+                      <a:pPr algn="ctr"/>
+                      <a:r>
+                        <a:rPr lang="en-IN" sz="2000">
+                          <a:solidFill>
+                            <a:schemeClr val="tx1"/>
+                          </a:solidFill>
+                          <a:effectLst/>
+                          <a:latin typeface="Barlow" panose="00000500000000000000" pitchFamily="2" charset="0"/>
+                        </a:rPr>
+                        <a:t>0.999</a:t>
+                      </a:r>
+                    </a:p>
+                  </a:txBody>
+                  <a:tcPr anchor="ctr">
+                    <a:lnT w="3175" cap="flat" cmpd="sng" algn="ctr">
+                      <a:solidFill>
+                        <a:schemeClr val="tx1"/>
+                      </a:solidFill>
+                      <a:prstDash val="solid"/>
+                      <a:round/>
+                      <a:headEnd type="none" w="med" len="med"/>
+                      <a:tailEnd type="none" w="med" len="med"/>
+                    </a:lnT>
+                    <a:lnB w="3175" cap="flat" cmpd="sng" algn="ctr">
+                      <a:solidFill>
+                        <a:schemeClr val="tx1"/>
+                      </a:solidFill>
+                      <a:prstDash val="solid"/>
+                      <a:round/>
+                      <a:headEnd type="none" w="med" len="med"/>
+                      <a:tailEnd type="none" w="med" len="med"/>
+                    </a:lnB>
+                    <a:solidFill>
+                      <a:schemeClr val="bg1"/>
+                    </a:solidFill>
+                  </a:tcPr>
+                </a:tc>
+                <a:tc>
+                  <a:txBody>
+                    <a:bodyPr/>
+                    <a:lstStyle/>
+                    <a:p>
+                      <a:pPr algn="ctr"/>
+                      <a:r>
+                        <a:rPr lang="en-IN" sz="2000" dirty="0">
+                          <a:solidFill>
+                            <a:schemeClr val="tx1"/>
+                          </a:solidFill>
+                          <a:effectLst/>
+                          <a:latin typeface="Barlow" panose="00000500000000000000" pitchFamily="2" charset="0"/>
+                        </a:rPr>
+                        <a:t>0.99</a:t>
+                      </a:r>
+                    </a:p>
+                  </a:txBody>
+                  <a:tcPr anchor="ctr">
+                    <a:lnT w="3175" cap="flat" cmpd="sng" algn="ctr">
+                      <a:solidFill>
+                        <a:schemeClr val="tx1"/>
+                      </a:solidFill>
+                      <a:prstDash val="solid"/>
+                      <a:round/>
+                      <a:headEnd type="none" w="med" len="med"/>
+                      <a:tailEnd type="none" w="med" len="med"/>
+                    </a:lnT>
+                    <a:lnB w="3175" cap="flat" cmpd="sng" algn="ctr">
+                      <a:solidFill>
+                        <a:schemeClr val="tx1"/>
+                      </a:solidFill>
+                      <a:prstDash val="solid"/>
+                      <a:round/>
+                      <a:headEnd type="none" w="med" len="med"/>
+                      <a:tailEnd type="none" w="med" len="med"/>
+                    </a:lnB>
+                    <a:solidFill>
+                      <a:schemeClr val="bg1"/>
+                    </a:solidFill>
+                  </a:tcPr>
+                </a:tc>
+                <a:extLst>
+                  <a:ext uri="{0D108BD9-81ED-4DB2-BD59-A6C34878D82A}">
+                    <a16:rowId xmlns:a16="http://schemas.microsoft.com/office/drawing/2014/main" val="1699272285"/>
+                  </a:ext>
+                </a:extLst>
+              </a:tr>
+              <a:tr h="370840">
+                <a:tc>
+                  <a:txBody>
+                    <a:bodyPr/>
+                    <a:lstStyle/>
+                    <a:p>
+                      <a:pPr algn="ctr"/>
+                      <a:r>
+                        <a:rPr lang="en-IN" sz="2000" b="1">
+                          <a:solidFill>
+                            <a:schemeClr val="tx1"/>
+                          </a:solidFill>
+                          <a:effectLst/>
+                          <a:latin typeface="Barlow" panose="00000500000000000000" pitchFamily="2" charset="0"/>
+                        </a:rPr>
+                        <a:t>Scheduler</a:t>
+                      </a:r>
+                      <a:endParaRPr lang="en-IN" sz="2000">
+                        <a:solidFill>
+                          <a:schemeClr val="tx1"/>
+                        </a:solidFill>
+                        <a:effectLst/>
+                        <a:latin typeface="Barlow" panose="00000500000000000000" pitchFamily="2" charset="0"/>
+                      </a:endParaRPr>
+                    </a:p>
+                  </a:txBody>
+                  <a:tcPr anchor="ctr">
+                    <a:lnT w="3175" cap="flat" cmpd="sng" algn="ctr">
+                      <a:solidFill>
+                        <a:schemeClr val="tx1"/>
+                      </a:solidFill>
+                      <a:prstDash val="solid"/>
+                      <a:round/>
+                      <a:headEnd type="none" w="med" len="med"/>
+                      <a:tailEnd type="none" w="med" len="med"/>
+                    </a:lnT>
+                    <a:solidFill>
+                      <a:schemeClr val="bg1"/>
+                    </a:solidFill>
+                  </a:tcPr>
+                </a:tc>
+                <a:tc>
+                  <a:txBody>
+                    <a:bodyPr/>
+                    <a:lstStyle/>
+                    <a:p>
+                      <a:pPr algn="ctr"/>
+                      <a:r>
+                        <a:rPr lang="en-IN" sz="2000">
+                          <a:solidFill>
+                            <a:schemeClr val="tx1"/>
+                          </a:solidFill>
+                          <a:effectLst/>
+                          <a:latin typeface="Barlow" panose="00000500000000000000" pitchFamily="2" charset="0"/>
+                        </a:rPr>
+                        <a:t>Linear</a:t>
+                      </a:r>
+                    </a:p>
+                  </a:txBody>
+                  <a:tcPr anchor="ctr">
+                    <a:lnT w="3175" cap="flat" cmpd="sng" algn="ctr">
+                      <a:solidFill>
+                        <a:schemeClr val="tx1"/>
+                      </a:solidFill>
+                      <a:prstDash val="solid"/>
+                      <a:round/>
+                      <a:headEnd type="none" w="med" len="med"/>
+                      <a:tailEnd type="none" w="med" len="med"/>
+                    </a:lnT>
+                    <a:solidFill>
+                      <a:schemeClr val="bg1"/>
+                    </a:solidFill>
+                  </a:tcPr>
+                </a:tc>
+                <a:tc>
+                  <a:txBody>
+                    <a:bodyPr/>
+                    <a:lstStyle/>
+                    <a:p>
+                      <a:pPr algn="ctr"/>
+                      <a:r>
+                        <a:rPr lang="en-IN" sz="2000" dirty="0">
+                          <a:solidFill>
+                            <a:schemeClr val="tx1"/>
+                          </a:solidFill>
+                          <a:effectLst/>
+                          <a:latin typeface="Barlow" panose="00000500000000000000" pitchFamily="2" charset="0"/>
+                        </a:rPr>
+                        <a:t>Cosine Annealing (ModernBERT)</a:t>
+                      </a:r>
+                    </a:p>
+                  </a:txBody>
+                  <a:tcPr anchor="ctr">
+                    <a:lnT w="3175" cap="flat" cmpd="sng" algn="ctr">
+                      <a:solidFill>
+                        <a:schemeClr val="tx1"/>
+                      </a:solidFill>
+                      <a:prstDash val="solid"/>
+                      <a:round/>
+                      <a:headEnd type="none" w="med" len="med"/>
+                      <a:tailEnd type="none" w="med" len="med"/>
+                    </a:lnT>
+                    <a:solidFill>
+                      <a:schemeClr val="bg1"/>
+                    </a:solidFill>
+                  </a:tcPr>
+                </a:tc>
+                <a:extLst>
+                  <a:ext uri="{0D108BD9-81ED-4DB2-BD59-A6C34878D82A}">
+                    <a16:rowId xmlns:a16="http://schemas.microsoft.com/office/drawing/2014/main" val="3076199374"/>
+                  </a:ext>
+                </a:extLst>
+              </a:tr>
+            </a:tbl>
+          </a:graphicData>
+        </a:graphic>
+      </p:graphicFrame>
+    </p:spTree>
+    <p:extLst>
+      <p:ext uri="{BB962C8B-B14F-4D97-AF65-F5344CB8AC3E}">
+        <p14:creationId xmlns:p14="http://schemas.microsoft.com/office/powerpoint/2010/main" val="2134400949"/>
+      </p:ext>
+    </p:extLst>
+  </p:cSld>
+  <p:clrMapOvr>
+    <a:masterClrMapping/>
+  </p:clrMapOvr>
+</p:sld>
+</file>
+
+<file path=ppt/slides/slide12.xml><?xml version="1.0" encoding="utf-8"?>
+<p:sld xmlns:a="http://schemas.openxmlformats.org/drawingml/2006/main" xmlns:r="http://schemas.openxmlformats.org/officeDocument/2006/relationships" xmlns:p="http://schemas.openxmlformats.org/presentationml/2006/main">
+  <p:cSld>
+    <p:spTree>
+      <p:nvGrpSpPr>
         <p:cNvPr id="1" name=""/>
         <p:cNvGrpSpPr/>
         <p:nvPr/>
@@ -12478,7 +13255,7 @@
 </p:sld>
 </file>
 
-<file path=ppt/slides/slide12.xml><?xml version="1.0" encoding="utf-8"?>
+<file path=ppt/slides/slide13.xml><?xml version="1.0" encoding="utf-8"?>
 <p:sld xmlns:a="http://schemas.openxmlformats.org/drawingml/2006/main" xmlns:r="http://schemas.openxmlformats.org/officeDocument/2006/relationships" xmlns:p="http://schemas.openxmlformats.org/presentationml/2006/main">
   <p:cSld>
     <p:spTree>
@@ -14798,7 +15575,7 @@
 </p:sld>
 </file>
 
-<file path=ppt/slides/slide13.xml><?xml version="1.0" encoding="utf-8"?>
+<file path=ppt/slides/slide14.xml><?xml version="1.0" encoding="utf-8"?>
 <p:sld xmlns:a="http://schemas.openxmlformats.org/drawingml/2006/main" xmlns:r="http://schemas.openxmlformats.org/officeDocument/2006/relationships" xmlns:p="http://schemas.openxmlformats.org/presentationml/2006/main">
   <p:cSld>
     <p:spTree>
@@ -15067,7 +15844,7 @@
 </p:sld>
 </file>
 
-<file path=ppt/slides/slide14.xml><?xml version="1.0" encoding="utf-8"?>
+<file path=ppt/slides/slide15.xml><?xml version="1.0" encoding="utf-8"?>
 <p:sld xmlns:a="http://schemas.openxmlformats.org/drawingml/2006/main" xmlns:r="http://schemas.openxmlformats.org/officeDocument/2006/relationships" xmlns:p="http://schemas.openxmlformats.org/presentationml/2006/main">
   <p:cSld>
     <p:spTree>
@@ -15964,7 +16741,7 @@
 </p:sld>
 </file>
 
-<file path=ppt/slides/slide15.xml><?xml version="1.0" encoding="utf-8"?>
+<file path=ppt/slides/slide16.xml><?xml version="1.0" encoding="utf-8"?>
 <p:sld xmlns:a="http://schemas.openxmlformats.org/drawingml/2006/main" xmlns:r="http://schemas.openxmlformats.org/officeDocument/2006/relationships" xmlns:p="http://schemas.openxmlformats.org/presentationml/2006/main">
   <p:cSld>
     <p:spTree>
@@ -16154,7 +16931,7 @@
 </p:sld>
 </file>
 
-<file path=ppt/slides/slide16.xml><?xml version="1.0" encoding="utf-8"?>
+<file path=ppt/slides/slide17.xml><?xml version="1.0" encoding="utf-8"?>
 <p:sld xmlns:a="http://schemas.openxmlformats.org/drawingml/2006/main" xmlns:r="http://schemas.openxmlformats.org/officeDocument/2006/relationships" xmlns:p="http://schemas.openxmlformats.org/presentationml/2006/main">
   <p:cSld>
     <p:spTree>
@@ -16171,68 +16948,6 @@
           <a:chExt cx="0" cy="0"/>
         </a:xfrm>
       </p:grpSpPr>
-      <p:sp>
-        <p:nvSpPr>
-          <p:cNvPr id="3" name="TextBox 2">
-            <a:extLst>
-              <a:ext uri="{FF2B5EF4-FFF2-40B4-BE49-F238E27FC236}">
-                <a16:creationId xmlns:a16="http://schemas.microsoft.com/office/drawing/2014/main" id="{527240B3-8BFF-4F4A-AFA2-52E66F2680F1}"/>
-              </a:ext>
-            </a:extLst>
-          </p:cNvPr>
-          <p:cNvSpPr txBox="1"/>
-          <p:nvPr/>
-        </p:nvSpPr>
-        <p:spPr>
-          <a:xfrm>
-            <a:off x="7360032" y="311847"/>
-            <a:ext cx="4537679" cy="830997"/>
-          </a:xfrm>
-          <a:prstGeom prst="rect">
-            <a:avLst/>
-          </a:prstGeom>
-          <a:solidFill>
-            <a:schemeClr val="tx1"/>
-          </a:solidFill>
-          <a:effectLst>
-            <a:outerShdw blurRad="63500" sx="102000" sy="102000" algn="ctr" rotWithShape="0">
-              <a:prstClr val="black">
-                <a:alpha val="40000"/>
-              </a:prstClr>
-            </a:outerShdw>
-          </a:effectLst>
-        </p:spPr>
-        <p:style>
-          <a:lnRef idx="0">
-            <a:schemeClr val="accent2"/>
-          </a:lnRef>
-          <a:fillRef idx="3">
-            <a:schemeClr val="accent2"/>
-          </a:fillRef>
-          <a:effectRef idx="3">
-            <a:schemeClr val="accent2"/>
-          </a:effectRef>
-          <a:fontRef idx="minor">
-            <a:schemeClr val="lt1"/>
-          </a:fontRef>
-        </p:style>
-        <p:txBody>
-          <a:bodyPr wrap="square" rtlCol="0">
-            <a:spAutoFit/>
-          </a:bodyPr>
-          <a:lstStyle/>
-          <a:p>
-            <a:pPr algn="ctr"/>
-            <a:r>
-              <a:rPr lang="en-US" sz="1600" dirty="0">
-                <a:ea typeface="Tahoma" panose="020B0604030504040204" pitchFamily="34" charset="0"/>
-                <a:cs typeface="Tahoma" panose="020B0604030504040204" pitchFamily="34" charset="0"/>
-              </a:rPr>
-              <a:t>Tip: The thesis should be clear and bold.  Use powerful images as a background or an accent to strengthen the thesis statement.</a:t>
-            </a:r>
-          </a:p>
-        </p:txBody>
-      </p:sp>
       <p:sp>
         <p:nvSpPr>
           <p:cNvPr id="2" name="Title 1">
@@ -16255,8 +16970,10 @@
           <a:lstStyle/>
           <a:p>
             <a:r>
-              <a:rPr lang="en-US" sz="4000" dirty="0"/>
-              <a:t>[Type Thesis Statement Here]</a:t>
+              <a:rPr lang="en-US" sz="4000" dirty="0">
+                <a:latin typeface="Barlow ExtraBold" panose="00000900000000000000" pitchFamily="2" charset="0"/>
+              </a:rPr>
+              <a:t>THANK YOU</a:t>
             </a:r>
           </a:p>
         </p:txBody>
@@ -16265,166 +16982,6 @@
     <p:extLst>
       <p:ext uri="{BB962C8B-B14F-4D97-AF65-F5344CB8AC3E}">
         <p14:creationId xmlns:p14="http://schemas.microsoft.com/office/powerpoint/2010/main" val="3869094418"/>
-      </p:ext>
-    </p:extLst>
-  </p:cSld>
-  <p:clrMapOvr>
-    <a:masterClrMapping/>
-  </p:clrMapOvr>
-</p:sld>
-</file>
-
-<file path=ppt/slides/slide17.xml><?xml version="1.0" encoding="utf-8"?>
-<p:sld xmlns:a="http://schemas.openxmlformats.org/drawingml/2006/main" xmlns:r="http://schemas.openxmlformats.org/officeDocument/2006/relationships" xmlns:p="http://schemas.openxmlformats.org/presentationml/2006/main">
-  <p:cSld>
-    <p:spTree>
-      <p:nvGrpSpPr>
-        <p:cNvPr id="1" name=""/>
-        <p:cNvGrpSpPr/>
-        <p:nvPr/>
-      </p:nvGrpSpPr>
-      <p:grpSpPr>
-        <a:xfrm>
-          <a:off x="0" y="0"/>
-          <a:ext cx="0" cy="0"/>
-          <a:chOff x="0" y="0"/>
-          <a:chExt cx="0" cy="0"/>
-        </a:xfrm>
-      </p:grpSpPr>
-      <p:sp>
-        <p:nvSpPr>
-          <p:cNvPr id="5" name="Title 4">
-            <a:extLst>
-              <a:ext uri="{FF2B5EF4-FFF2-40B4-BE49-F238E27FC236}">
-                <a16:creationId xmlns:a16="http://schemas.microsoft.com/office/drawing/2014/main" id="{FDA7EC95-D971-4A86-9927-619CED5AB4B2}"/>
-              </a:ext>
-            </a:extLst>
-          </p:cNvPr>
-          <p:cNvSpPr>
-            <a:spLocks noGrp="1"/>
-          </p:cNvSpPr>
-          <p:nvPr>
-            <p:ph type="title"/>
-          </p:nvPr>
-        </p:nvSpPr>
-        <p:spPr>
-          <a:xfrm>
-            <a:off x="810000" y="4489884"/>
-            <a:ext cx="10561418" cy="1426004"/>
-          </a:xfrm>
-        </p:spPr>
-        <p:txBody>
-          <a:bodyPr/>
-          <a:lstStyle/>
-          <a:p>
-            <a:r>
-              <a:rPr lang="en-US" dirty="0"/>
-              <a:t>[Type The Action Step Here]</a:t>
-            </a:r>
-          </a:p>
-        </p:txBody>
-      </p:sp>
-      <p:sp>
-        <p:nvSpPr>
-          <p:cNvPr id="9" name="Content Placeholder 8">
-            <a:extLst>
-              <a:ext uri="{FF2B5EF4-FFF2-40B4-BE49-F238E27FC236}">
-                <a16:creationId xmlns:a16="http://schemas.microsoft.com/office/drawing/2014/main" id="{D7442235-8F25-4E4C-8750-8CC8C44313AD}"/>
-              </a:ext>
-            </a:extLst>
-          </p:cNvPr>
-          <p:cNvSpPr>
-            <a:spLocks noGrp="1"/>
-          </p:cNvSpPr>
-          <p:nvPr>
-            <p:ph sz="quarter" idx="14"/>
-          </p:nvPr>
-        </p:nvSpPr>
-        <p:spPr/>
-        <p:txBody>
-          <a:bodyPr/>
-          <a:lstStyle/>
-          <a:p>
-            <a:pPr marL="0" indent="0" algn="ctr">
-              <a:buFont typeface="Arial" panose="020B0604020202020204" pitchFamily="34" charset="0"/>
-              <a:buNone/>
-            </a:pPr>
-            <a:r>
-              <a:rPr lang="en-US" dirty="0">
-                <a:ea typeface="Tahoma" panose="020B0604030504040204" pitchFamily="34" charset="0"/>
-                <a:cs typeface="Tahoma" panose="020B0604030504040204" pitchFamily="34" charset="0"/>
-              </a:rPr>
-              <a:t>[Use this space to place an image that best captures the main idea of the action step]</a:t>
-            </a:r>
-          </a:p>
-        </p:txBody>
-      </p:sp>
-      <p:sp>
-        <p:nvSpPr>
-          <p:cNvPr id="7" name="TextBox 6">
-            <a:extLst>
-              <a:ext uri="{FF2B5EF4-FFF2-40B4-BE49-F238E27FC236}">
-                <a16:creationId xmlns:a16="http://schemas.microsoft.com/office/drawing/2014/main" id="{43264A76-ADAD-4DC9-84FD-71DFAFEE7A6F}"/>
-              </a:ext>
-            </a:extLst>
-          </p:cNvPr>
-          <p:cNvSpPr txBox="1"/>
-          <p:nvPr/>
-        </p:nvSpPr>
-        <p:spPr>
-          <a:xfrm>
-            <a:off x="8089900" y="186333"/>
-            <a:ext cx="3886200" cy="1077218"/>
-          </a:xfrm>
-          <a:prstGeom prst="rect">
-            <a:avLst/>
-          </a:prstGeom>
-          <a:solidFill>
-            <a:schemeClr val="tx1"/>
-          </a:solidFill>
-          <a:effectLst>
-            <a:outerShdw blurRad="63500" sx="102000" sy="102000" algn="ctr" rotWithShape="0">
-              <a:prstClr val="black">
-                <a:alpha val="40000"/>
-              </a:prstClr>
-            </a:outerShdw>
-          </a:effectLst>
-        </p:spPr>
-        <p:style>
-          <a:lnRef idx="0">
-            <a:schemeClr val="accent2"/>
-          </a:lnRef>
-          <a:fillRef idx="3">
-            <a:schemeClr val="accent2"/>
-          </a:fillRef>
-          <a:effectRef idx="3">
-            <a:schemeClr val="accent2"/>
-          </a:effectRef>
-          <a:fontRef idx="minor">
-            <a:schemeClr val="lt1"/>
-          </a:fontRef>
-        </p:style>
-        <p:txBody>
-          <a:bodyPr wrap="square" rtlCol="0">
-            <a:spAutoFit/>
-          </a:bodyPr>
-          <a:lstStyle/>
-          <a:p>
-            <a:pPr algn="ctr"/>
-            <a:r>
-              <a:rPr lang="en-US" sz="1600" dirty="0">
-                <a:ea typeface="Tahoma" panose="020B0604030504040204" pitchFamily="34" charset="0"/>
-                <a:cs typeface="Tahoma" panose="020B0604030504040204" pitchFamily="34" charset="0"/>
-              </a:rPr>
-              <a:t>Tip: If time and format permits it may be a good idea to add another slide for questions.  It may be as simple as a title that states “Questions?”</a:t>
-            </a:r>
-          </a:p>
-        </p:txBody>
-      </p:sp>
-    </p:spTree>
-    <p:extLst>
-      <p:ext uri="{BB962C8B-B14F-4D97-AF65-F5344CB8AC3E}">
-        <p14:creationId xmlns:p14="http://schemas.microsoft.com/office/powerpoint/2010/main" val="1980296533"/>
       </p:ext>
     </p:extLst>
   </p:cSld>
@@ -17152,14 +17709,14 @@
           <p:nvPr>
             <p:extLst>
               <p:ext uri="{D42A27DB-BD31-4B8C-83A1-F6EECF244321}">
-                <p14:modId xmlns:p14="http://schemas.microsoft.com/office/powerpoint/2010/main" val="3009779045"/>
+                <p14:modId xmlns:p14="http://schemas.microsoft.com/office/powerpoint/2010/main" val="2952616321"/>
               </p:ext>
             </p:extLst>
           </p:nvPr>
         </p:nvGraphicFramePr>
         <p:xfrm>
           <a:off x="782704" y="1812991"/>
-          <a:ext cx="10215263" cy="2473960"/>
+          <a:ext cx="10629934" cy="2621280"/>
         </p:xfrm>
         <a:graphic>
           <a:graphicData uri="http://schemas.openxmlformats.org/drawingml/2006/table">
@@ -17168,28 +17725,28 @@
                 <a:tableStyleId>{69C7853C-536D-4A76-A0AE-DD22124D55A5}</a:tableStyleId>
               </a:tblPr>
               <a:tblGrid>
-                <a:gridCol w="2196235">
+                <a:gridCol w="2285387">
                   <a:extLst>
                     <a:ext uri="{9D8B030D-6E8A-4147-A177-3AD203B41FA5}">
                       <a16:colId xmlns:a16="http://schemas.microsoft.com/office/drawing/2014/main" val="902513758"/>
                     </a:ext>
                   </a:extLst>
                 </a:gridCol>
-                <a:gridCol w="2196235">
+                <a:gridCol w="2285387">
                   <a:extLst>
                     <a:ext uri="{9D8B030D-6E8A-4147-A177-3AD203B41FA5}">
                       <a16:colId xmlns:a16="http://schemas.microsoft.com/office/drawing/2014/main" val="2836376390"/>
                     </a:ext>
                   </a:extLst>
                 </a:gridCol>
-                <a:gridCol w="2123248">
+                <a:gridCol w="2209438">
                   <a:extLst>
                     <a:ext uri="{9D8B030D-6E8A-4147-A177-3AD203B41FA5}">
                       <a16:colId xmlns:a16="http://schemas.microsoft.com/office/drawing/2014/main" val="4239693166"/>
                     </a:ext>
                   </a:extLst>
                 </a:gridCol>
-                <a:gridCol w="3699545">
+                <a:gridCol w="3849722">
                   <a:extLst>
                     <a:ext uri="{9D8B030D-6E8A-4147-A177-3AD203B41FA5}">
                       <a16:colId xmlns:a16="http://schemas.microsoft.com/office/drawing/2014/main" val="856259958"/>
@@ -17212,6 +17769,7 @@
                               </a:prstClr>
                             </a:outerShdw>
                           </a:effectLst>
+                          <a:latin typeface="Barlow Medium" panose="00000600000000000000" pitchFamily="2" charset="0"/>
                         </a:rPr>
                         <a:t>Model</a:t>
                       </a:r>
@@ -17223,6 +17781,7 @@
                             </a:prstClr>
                           </a:outerShdw>
                         </a:effectLst>
+                        <a:latin typeface="Barlow Medium" panose="00000600000000000000" pitchFamily="2" charset="0"/>
                       </a:endParaRPr>
                     </a:p>
                   </a:txBody>
@@ -17247,6 +17806,7 @@
                               </a:prstClr>
                             </a:outerShdw>
                           </a:effectLst>
+                          <a:latin typeface="Barlow Medium" panose="00000600000000000000" pitchFamily="2" charset="0"/>
                         </a:rPr>
                         <a:t>Parameters</a:t>
                       </a:r>
@@ -17258,6 +17818,7 @@
                             </a:prstClr>
                           </a:outerShdw>
                         </a:effectLst>
+                        <a:latin typeface="Barlow Medium" panose="00000600000000000000" pitchFamily="2" charset="0"/>
                       </a:endParaRPr>
                     </a:p>
                   </a:txBody>
@@ -17282,6 +17843,7 @@
                               </a:prstClr>
                             </a:outerShdw>
                           </a:effectLst>
+                          <a:latin typeface="Barlow Medium" panose="00000600000000000000" pitchFamily="2" charset="0"/>
                         </a:rPr>
                         <a:t>Context Length</a:t>
                       </a:r>
@@ -17293,6 +17855,7 @@
                             </a:prstClr>
                           </a:outerShdw>
                         </a:effectLst>
+                        <a:latin typeface="Barlow Medium" panose="00000600000000000000" pitchFamily="2" charset="0"/>
                       </a:endParaRPr>
                     </a:p>
                   </a:txBody>
@@ -17317,6 +17880,7 @@
                               </a:prstClr>
                             </a:outerShdw>
                           </a:effectLst>
+                          <a:latin typeface="Barlow Medium" panose="00000600000000000000" pitchFamily="2" charset="0"/>
                         </a:rPr>
                         <a:t>Key Features</a:t>
                       </a:r>
@@ -17328,6 +17892,7 @@
                             </a:prstClr>
                           </a:outerShdw>
                         </a:effectLst>
+                        <a:latin typeface="Barlow Medium" panose="00000600000000000000" pitchFamily="2" charset="0"/>
                       </a:endParaRPr>
                     </a:p>
                   </a:txBody>
@@ -17352,13 +17917,15 @@
                     <a:p>
                       <a:pPr algn="l"/>
                       <a:r>
-                        <a:rPr lang="en-IN" b="1" dirty="0">
+                        <a:rPr lang="en-IN" sz="2000" b="1" dirty="0">
                           <a:effectLst/>
+                          <a:latin typeface="Barlow" panose="00000500000000000000" pitchFamily="2" charset="0"/>
                         </a:rPr>
                         <a:t>MiniLM-L12-H384</a:t>
                       </a:r>
-                      <a:endParaRPr lang="en-IN" dirty="0">
+                      <a:endParaRPr lang="en-IN" sz="2000" dirty="0">
                         <a:effectLst/>
+                        <a:latin typeface="Barlow" panose="00000500000000000000" pitchFamily="2" charset="0"/>
                       </a:endParaRPr>
                     </a:p>
                   </a:txBody>
@@ -17399,8 +17966,9 @@
                     <a:p>
                       <a:pPr algn="l"/>
                       <a:r>
-                        <a:rPr lang="en-IN" dirty="0">
+                        <a:rPr lang="en-IN" sz="2000" dirty="0">
                           <a:effectLst/>
+                          <a:latin typeface="Barlow" panose="00000500000000000000" pitchFamily="2" charset="0"/>
                         </a:rPr>
                         <a:t>~33M</a:t>
                       </a:r>
@@ -17443,8 +18011,9 @@
                     <a:p>
                       <a:pPr algn="l"/>
                       <a:r>
-                        <a:rPr lang="en-IN">
+                        <a:rPr lang="en-IN" sz="2000" dirty="0">
                           <a:effectLst/>
+                          <a:latin typeface="Barlow" panose="00000500000000000000" pitchFamily="2" charset="0"/>
                         </a:rPr>
                         <a:t>512 tokens</a:t>
                       </a:r>
@@ -17487,8 +18056,9 @@
                     <a:p>
                       <a:pPr algn="l"/>
                       <a:r>
-                        <a:rPr lang="en-IN" dirty="0">
+                        <a:rPr lang="en-IN" sz="2000" dirty="0">
                           <a:effectLst/>
+                          <a:latin typeface="Barlow" panose="00000500000000000000" pitchFamily="2" charset="0"/>
                         </a:rPr>
                         <a:t>Efficient baseline, knowledge distillation</a:t>
                       </a:r>
@@ -17538,13 +18108,15 @@
                     <a:p>
                       <a:pPr algn="l"/>
                       <a:r>
-                        <a:rPr lang="en-IN" b="1">
+                        <a:rPr lang="en-IN" sz="2000" b="1">
                           <a:effectLst/>
+                          <a:latin typeface="Barlow" panose="00000500000000000000" pitchFamily="2" charset="0"/>
                         </a:rPr>
                         <a:t>GTE-multilingual-base</a:t>
                       </a:r>
-                      <a:endParaRPr lang="en-IN">
+                      <a:endParaRPr lang="en-IN" sz="2000">
                         <a:effectLst/>
+                        <a:latin typeface="Barlow" panose="00000500000000000000" pitchFamily="2" charset="0"/>
                       </a:endParaRPr>
                     </a:p>
                   </a:txBody>
@@ -17585,8 +18157,9 @@
                     <a:p>
                       <a:pPr algn="l"/>
                       <a:r>
-                        <a:rPr lang="en-IN" dirty="0">
+                        <a:rPr lang="en-IN" sz="2000" dirty="0">
                           <a:effectLst/>
+                          <a:latin typeface="Barlow" panose="00000500000000000000" pitchFamily="2" charset="0"/>
                         </a:rPr>
                         <a:t>~305M</a:t>
                       </a:r>
@@ -17629,8 +18202,9 @@
                     <a:p>
                       <a:pPr algn="l"/>
                       <a:r>
-                        <a:rPr lang="en-IN" dirty="0">
+                        <a:rPr lang="en-IN" sz="2000" dirty="0">
                           <a:effectLst/>
+                          <a:latin typeface="Barlow" panose="00000500000000000000" pitchFamily="2" charset="0"/>
                         </a:rPr>
                         <a:t>8192 tokens</a:t>
                       </a:r>
@@ -17673,8 +18247,9 @@
                     <a:p>
                       <a:pPr algn="l"/>
                       <a:r>
-                        <a:rPr lang="en-IN" dirty="0">
+                        <a:rPr lang="en-IN" sz="2000" dirty="0">
                           <a:effectLst/>
+                          <a:latin typeface="Barlow" panose="00000500000000000000" pitchFamily="2" charset="0"/>
                         </a:rPr>
                         <a:t>Extended context, multilingual support</a:t>
                       </a:r>
@@ -17724,13 +18299,15 @@
                     <a:p>
                       <a:pPr algn="l"/>
                       <a:r>
-                        <a:rPr lang="en-IN" b="1">
+                        <a:rPr lang="en-IN" sz="2000" b="1">
                           <a:effectLst/>
+                          <a:latin typeface="Barlow" panose="00000500000000000000" pitchFamily="2" charset="0"/>
                         </a:rPr>
                         <a:t>ModernBERT-base</a:t>
                       </a:r>
-                      <a:endParaRPr lang="en-IN">
+                      <a:endParaRPr lang="en-IN" sz="2000">
                         <a:effectLst/>
+                        <a:latin typeface="Barlow" panose="00000500000000000000" pitchFamily="2" charset="0"/>
                       </a:endParaRPr>
                     </a:p>
                   </a:txBody>
@@ -17771,8 +18348,9 @@
                     <a:p>
                       <a:pPr algn="l"/>
                       <a:r>
-                        <a:rPr lang="en-IN">
+                        <a:rPr lang="en-IN" sz="2000">
                           <a:effectLst/>
+                          <a:latin typeface="Barlow" panose="00000500000000000000" pitchFamily="2" charset="0"/>
                         </a:rPr>
                         <a:t>~149M</a:t>
                       </a:r>
@@ -17815,8 +18393,9 @@
                     <a:p>
                       <a:pPr algn="l"/>
                       <a:r>
-                        <a:rPr lang="en-IN" dirty="0">
+                        <a:rPr lang="en-IN" sz="2000" dirty="0">
                           <a:effectLst/>
+                          <a:latin typeface="Barlow" panose="00000500000000000000" pitchFamily="2" charset="0"/>
                         </a:rPr>
                         <a:t>8192 tokens</a:t>
                       </a:r>
@@ -17859,8 +18438,9 @@
                     <a:p>
                       <a:pPr algn="l"/>
                       <a:r>
-                        <a:rPr lang="en-IN" dirty="0">
+                        <a:rPr lang="en-IN" sz="2000" dirty="0">
                           <a:effectLst/>
+                          <a:latin typeface="Barlow" panose="00000500000000000000" pitchFamily="2" charset="0"/>
                         </a:rPr>
                         <a:t>RoPE, Flash Attention, GeGLU</a:t>
                       </a:r>

</xml_diff>

<commit_message>
Added plag report, improved presentation
</commit_message>
<xml_diff>
--- a/cross_encoder/thesis/Thesis_presentation.pptx
+++ b/cross_encoder/thesis/Thesis_presentation.pptx
@@ -242,7 +242,7 @@
           <a:p>
             <a:fld id="{8E836F02-AF67-416B-AB85-08CFF698F86D}" type="datetimeFigureOut">
               <a:rPr lang="en-US" smtClean="0"/>
-              <a:t>6/21/2025</a:t>
+              <a:t>6/22/2025</a:t>
             </a:fld>
             <a:endParaRPr lang="en-US" dirty="0"/>
           </a:p>
@@ -419,7 +419,7 @@
           <a:p>
             <a:fld id="{45B7E8F0-931C-4E43-98D1-A3CD0E0034DC}" type="datetimeFigureOut">
               <a:rPr lang="en-US" smtClean="0"/>
-              <a:t>6/21/2025</a:t>
+              <a:t>6/22/2025</a:t>
             </a:fld>
             <a:endParaRPr lang="en-US" dirty="0"/>
           </a:p>
@@ -2769,7 +2769,7 @@
           </a:effectLst>
           <a:extLst>
             <a:ext uri="{91240B29-F687-4f45-9708-019B960494DF}">
-              <a14:hiddenLine xmlns="" xmlns:a14="http://schemas.microsoft.com/office/drawing/2010/main" w="9525">
+              <a14:hiddenLine xmlns:a14="http://schemas.microsoft.com/office/drawing/2010/main" xmlns="" w="9525">
                 <a:solidFill>
                   <a:srgbClr val="000000"/>
                 </a:solidFill>
@@ -2961,7 +2961,7 @@
           <a:p>
             <a:fld id="{FB7F6C47-B260-4BB6-8230-7D14D5CDE026}" type="datetimeFigureOut">
               <a:rPr lang="en-US" noProof="0" smtClean="0"/>
-              <a:t>6/21/2025</a:t>
+              <a:t>6/22/2025</a:t>
             </a:fld>
             <a:endParaRPr lang="en-US" noProof="0" dirty="0"/>
           </a:p>
@@ -3320,7 +3320,7 @@
           <a:p>
             <a:fld id="{FB7F6C47-B260-4BB6-8230-7D14D5CDE026}" type="datetimeFigureOut">
               <a:rPr lang="en-US" noProof="0" smtClean="0"/>
-              <a:t>6/21/2025</a:t>
+              <a:t>6/22/2025</a:t>
             </a:fld>
             <a:endParaRPr lang="en-US" noProof="0" dirty="0"/>
           </a:p>
@@ -3497,7 +3497,7 @@
           </a:effectLst>
           <a:extLst>
             <a:ext uri="{91240B29-F687-4f45-9708-019B960494DF}">
-              <a14:hiddenLine xmlns="" xmlns:a14="http://schemas.microsoft.com/office/drawing/2010/main" w="9525">
+              <a14:hiddenLine xmlns:a14="http://schemas.microsoft.com/office/drawing/2010/main" xmlns="" w="9525">
                 <a:solidFill>
                   <a:srgbClr val="000000"/>
                 </a:solidFill>
@@ -3825,7 +3825,7 @@
           <a:p>
             <a:fld id="{FB7F6C47-B260-4BB6-8230-7D14D5CDE026}" type="datetimeFigureOut">
               <a:rPr lang="en-US" noProof="0" smtClean="0"/>
-              <a:t>6/21/2025</a:t>
+              <a:t>6/22/2025</a:t>
             </a:fld>
             <a:endParaRPr lang="en-US" noProof="0" dirty="0"/>
           </a:p>
@@ -4002,7 +4002,7 @@
           </a:effectLst>
           <a:extLst>
             <a:ext uri="{91240B29-F687-4f45-9708-019B960494DF}">
-              <a14:hiddenLine xmlns="" xmlns:a14="http://schemas.microsoft.com/office/drawing/2010/main" w="9525">
+              <a14:hiddenLine xmlns:a14="http://schemas.microsoft.com/office/drawing/2010/main" xmlns="" w="9525">
                 <a:solidFill>
                   <a:srgbClr val="000000"/>
                 </a:solidFill>
@@ -4077,7 +4077,7 @@
           <a:p>
             <a:fld id="{FB7F6C47-B260-4BB6-8230-7D14D5CDE026}" type="datetimeFigureOut">
               <a:rPr lang="en-US" noProof="0" smtClean="0"/>
-              <a:t>6/21/2025</a:t>
+              <a:t>6/22/2025</a:t>
             </a:fld>
             <a:endParaRPr lang="en-US" noProof="0" dirty="0"/>
           </a:p>
@@ -4193,7 +4193,7 @@
           <a:p>
             <a:fld id="{FB7F6C47-B260-4BB6-8230-7D14D5CDE026}" type="datetimeFigureOut">
               <a:rPr lang="en-US" noProof="0" smtClean="0"/>
-              <a:t>6/21/2025</a:t>
+              <a:t>6/22/2025</a:t>
             </a:fld>
             <a:endParaRPr lang="en-US" noProof="0" dirty="0"/>
           </a:p>
@@ -4481,7 +4481,7 @@
           </a:effectLst>
           <a:extLst>
             <a:ext uri="{91240B29-F687-4f45-9708-019B960494DF}">
-              <a14:hiddenLine xmlns="" xmlns:a14="http://schemas.microsoft.com/office/drawing/2010/main" w="9525">
+              <a14:hiddenLine xmlns:a14="http://schemas.microsoft.com/office/drawing/2010/main" xmlns="" w="9525">
                 <a:solidFill>
                   <a:srgbClr val="000000"/>
                 </a:solidFill>
@@ -4686,7 +4686,7 @@
           <a:p>
             <a:fld id="{FB7F6C47-B260-4BB6-8230-7D14D5CDE026}" type="datetimeFigureOut">
               <a:rPr lang="en-US" noProof="0" smtClean="0"/>
-              <a:t>6/21/2025</a:t>
+              <a:t>6/22/2025</a:t>
             </a:fld>
             <a:endParaRPr lang="en-US" noProof="0" dirty="0"/>
           </a:p>
@@ -5201,7 +5201,7 @@
           <a:p>
             <a:fld id="{FB7F6C47-B260-4BB6-8230-7D14D5CDE026}" type="datetimeFigureOut">
               <a:rPr lang="en-US" noProof="0" smtClean="0"/>
-              <a:t>6/21/2025</a:t>
+              <a:t>6/22/2025</a:t>
             </a:fld>
             <a:endParaRPr lang="en-US" noProof="0" dirty="0"/>
           </a:p>
@@ -5597,7 +5597,7 @@
           <a:p>
             <a:fld id="{FB7F6C47-B260-4BB6-8230-7D14D5CDE026}" type="datetimeFigureOut">
               <a:rPr lang="en-US" noProof="0" smtClean="0"/>
-              <a:t>6/21/2025</a:t>
+              <a:t>6/22/2025</a:t>
             </a:fld>
             <a:endParaRPr lang="en-US" noProof="0" dirty="0"/>
           </a:p>
@@ -5776,7 +5776,7 @@
           </a:effectLst>
           <a:extLst>
             <a:ext uri="{91240B29-F687-4f45-9708-019B960494DF}">
-              <a14:hiddenLine xmlns="" xmlns:a14="http://schemas.microsoft.com/office/drawing/2010/main" w="9525">
+              <a14:hiddenLine xmlns:a14="http://schemas.microsoft.com/office/drawing/2010/main" xmlns="" w="9525">
                 <a:solidFill>
                   <a:srgbClr val="000000"/>
                 </a:solidFill>
@@ -5928,7 +5928,7 @@
           <a:p>
             <a:fld id="{FB7F6C47-B260-4BB6-8230-7D14D5CDE026}" type="datetimeFigureOut">
               <a:rPr lang="en-US" noProof="0" smtClean="0"/>
-              <a:t>6/21/2025</a:t>
+              <a:t>6/22/2025</a:t>
             </a:fld>
             <a:endParaRPr lang="en-US" noProof="0" dirty="0"/>
           </a:p>
@@ -6105,7 +6105,7 @@
           </a:effectLst>
           <a:extLst>
             <a:ext uri="{91240B29-F687-4f45-9708-019B960494DF}">
-              <a14:hiddenLine xmlns="" xmlns:a14="http://schemas.microsoft.com/office/drawing/2010/main" w="9525">
+              <a14:hiddenLine xmlns:a14="http://schemas.microsoft.com/office/drawing/2010/main" xmlns="" w="9525">
                 <a:solidFill>
                   <a:srgbClr val="000000"/>
                 </a:solidFill>
@@ -6326,7 +6326,7 @@
           <a:p>
             <a:fld id="{FB7F6C47-B260-4BB6-8230-7D14D5CDE026}" type="datetimeFigureOut">
               <a:rPr lang="en-US" noProof="0" smtClean="0"/>
-              <a:t>6/21/2025</a:t>
+              <a:t>6/22/2025</a:t>
             </a:fld>
             <a:endParaRPr lang="en-US" noProof="0" dirty="0"/>
           </a:p>
@@ -6578,7 +6578,7 @@
           <a:p>
             <a:fld id="{FB7F6C47-B260-4BB6-8230-7D14D5CDE026}" type="datetimeFigureOut">
               <a:rPr lang="en-US" noProof="0" smtClean="0"/>
-              <a:t>6/21/2025</a:t>
+              <a:t>6/22/2025</a:t>
             </a:fld>
             <a:endParaRPr lang="en-US" noProof="0" dirty="0"/>
           </a:p>
@@ -6755,7 +6755,7 @@
           </a:effectLst>
           <a:extLst>
             <a:ext uri="{91240B29-F687-4f45-9708-019B960494DF}">
-              <a14:hiddenLine xmlns="" xmlns:a14="http://schemas.microsoft.com/office/drawing/2010/main" w="9525">
+              <a14:hiddenLine xmlns:a14="http://schemas.microsoft.com/office/drawing/2010/main" xmlns="" w="9525">
                 <a:solidFill>
                   <a:srgbClr val="000000"/>
                 </a:solidFill>
@@ -6998,7 +6998,7 @@
           <a:p>
             <a:fld id="{FB7F6C47-B260-4BB6-8230-7D14D5CDE026}" type="datetimeFigureOut">
               <a:rPr lang="en-US" noProof="0" smtClean="0"/>
-              <a:t>6/21/2025</a:t>
+              <a:t>6/22/2025</a:t>
             </a:fld>
             <a:endParaRPr lang="en-US" noProof="0" dirty="0"/>
           </a:p>
@@ -7175,7 +7175,7 @@
           </a:effectLst>
           <a:extLst>
             <a:ext uri="{91240B29-F687-4f45-9708-019B960494DF}">
-              <a14:hiddenLine xmlns="" xmlns:a14="http://schemas.microsoft.com/office/drawing/2010/main" w="9525">
+              <a14:hiddenLine xmlns:a14="http://schemas.microsoft.com/office/drawing/2010/main" xmlns="" w="9525">
                 <a:solidFill>
                   <a:srgbClr val="000000"/>
                 </a:solidFill>
@@ -7412,7 +7412,7 @@
           <a:p>
             <a:fld id="{FB7F6C47-B260-4BB6-8230-7D14D5CDE026}" type="datetimeFigureOut">
               <a:rPr lang="en-US" noProof="0" smtClean="0"/>
-              <a:t>6/21/2025</a:t>
+              <a:t>6/22/2025</a:t>
             </a:fld>
             <a:endParaRPr lang="en-US" noProof="0" dirty="0"/>
           </a:p>
@@ -7835,7 +7835,7 @@
           <a:p>
             <a:fld id="{FB7F6C47-B260-4BB6-8230-7D14D5CDE026}" type="datetimeFigureOut">
               <a:rPr lang="en-US" noProof="0" smtClean="0"/>
-              <a:t>6/21/2025</a:t>
+              <a:t>6/22/2025</a:t>
             </a:fld>
             <a:endParaRPr lang="en-US" noProof="0" dirty="0"/>
           </a:p>
@@ -8012,7 +8012,7 @@
           </a:effectLst>
           <a:extLst>
             <a:ext uri="{91240B29-F687-4f45-9708-019B960494DF}">
-              <a14:hiddenLine xmlns="" xmlns:a14="http://schemas.microsoft.com/office/drawing/2010/main" w="9525">
+              <a14:hiddenLine xmlns:a14="http://schemas.microsoft.com/office/drawing/2010/main" xmlns="" w="9525">
                 <a:solidFill>
                   <a:srgbClr val="000000"/>
                 </a:solidFill>
@@ -8162,7 +8162,7 @@
           <a:p>
             <a:fld id="{FB7F6C47-B260-4BB6-8230-7D14D5CDE026}" type="datetimeFigureOut">
               <a:rPr lang="en-US" noProof="0" smtClean="0"/>
-              <a:t>6/21/2025</a:t>
+              <a:t>6/22/2025</a:t>
             </a:fld>
             <a:endParaRPr lang="en-US" noProof="0" dirty="0"/>
           </a:p>
@@ -8726,7 +8726,7 @@
           <a:p>
             <a:fld id="{FB7F6C47-B260-4BB6-8230-7D14D5CDE026}" type="datetimeFigureOut">
               <a:rPr lang="en-US" noProof="0" smtClean="0"/>
-              <a:t>6/21/2025</a:t>
+              <a:t>6/22/2025</a:t>
             </a:fld>
             <a:endParaRPr lang="en-US" noProof="0" dirty="0"/>
           </a:p>
@@ -8903,7 +8903,7 @@
           </a:effectLst>
           <a:extLst>
             <a:ext uri="{91240B29-F687-4f45-9708-019B960494DF}">
-              <a14:hiddenLine xmlns="" xmlns:a14="http://schemas.microsoft.com/office/drawing/2010/main" w="9525">
+              <a14:hiddenLine xmlns:a14="http://schemas.microsoft.com/office/drawing/2010/main" xmlns="" w="9525">
                 <a:solidFill>
                   <a:srgbClr val="000000"/>
                 </a:solidFill>
@@ -9041,7 +9041,7 @@
           <a:p>
             <a:fld id="{FB7F6C47-B260-4BB6-8230-7D14D5CDE026}" type="datetimeFigureOut">
               <a:rPr lang="en-US" noProof="0" smtClean="0"/>
-              <a:t>6/21/2025</a:t>
+              <a:t>6/22/2025</a:t>
             </a:fld>
             <a:endParaRPr lang="en-US" noProof="0" dirty="0"/>
           </a:p>
@@ -9305,7 +9305,7 @@
           <a:p>
             <a:fld id="{FB7F6C47-B260-4BB6-8230-7D14D5CDE026}" type="datetimeFigureOut">
               <a:rPr lang="en-US" noProof="0" smtClean="0"/>
-              <a:t>6/21/2025</a:t>
+              <a:t>6/22/2025</a:t>
             </a:fld>
             <a:endParaRPr lang="en-US" noProof="0" dirty="0"/>
           </a:p>
@@ -9956,8 +9956,8 @@
         </p:nvSpPr>
         <p:spPr>
           <a:xfrm>
-            <a:off x="421105" y="2346158"/>
-            <a:ext cx="7130478" cy="4401205"/>
+            <a:off x="469232" y="2117892"/>
+            <a:ext cx="7173759" cy="4401205"/>
           </a:xfrm>
           <a:prstGeom prst="rect">
             <a:avLst/>
@@ -9987,17 +9987,8 @@
               <a:rPr lang="en-IN" sz="2000" dirty="0">
                 <a:latin typeface="Barlow" panose="00000500000000000000" pitchFamily="2" charset="0"/>
               </a:rPr>
-              <a:t>• Sign-based momentum: update = sign(momentum) × </a:t>
-            </a:r>
-            <a:r>
-              <a:rPr lang="en-IN" sz="2000" dirty="0" err="1">
-                <a:latin typeface="Barlow" panose="00000500000000000000" pitchFamily="2" charset="0"/>
-              </a:rPr>
-              <a:t>lr</a:t>
-            </a:r>
-            <a:endParaRPr lang="en-IN" sz="2000" dirty="0">
-              <a:latin typeface="Barlow" panose="00000500000000000000" pitchFamily="2" charset="0"/>
-            </a:endParaRPr>
+              <a:t>• Sign-based momentum</a:t>
+            </a:r>
           </a:p>
           <a:p>
             <a:r>
@@ -20111,19 +20102,7 @@
               <a:rPr lang="en-IN" sz="2000" dirty="0">
                 <a:latin typeface="Barlow" panose="00000500000000000000" pitchFamily="2" charset="0"/>
               </a:rPr>
-              <a:t>R. Nogueira and K. Cho, "Passage Re-ranking with BERT," </a:t>
-            </a:r>
-            <a:r>
-              <a:rPr lang="en-IN" sz="2000" dirty="0" err="1">
-                <a:latin typeface="Barlow" panose="00000500000000000000" pitchFamily="2" charset="0"/>
-              </a:rPr>
-              <a:t>arXiv</a:t>
-            </a:r>
-            <a:r>
-              <a:rPr lang="en-IN" sz="2000" dirty="0">
-                <a:latin typeface="Barlow" panose="00000500000000000000" pitchFamily="2" charset="0"/>
-              </a:rPr>
-              <a:t> preprint arXiv:1901.04085, 2020.</a:t>
+              <a:t>R. Nogueira and K. Cho, "Passage Re-ranking with BERT," arXiv preprint arXiv:1901.04085, 2020.</a:t>
             </a:r>
           </a:p>
           <a:p>
@@ -20165,13 +20144,7 @@
               <a:rPr lang="en-IN" sz="2000" i="1" dirty="0">
                 <a:latin typeface="Barlow" panose="00000500000000000000" pitchFamily="2" charset="0"/>
               </a:rPr>
-              <a:t>Proc. </a:t>
-            </a:r>
-            <a:r>
-              <a:rPr lang="en-IN" sz="2000" i="1" dirty="0" err="1">
-                <a:latin typeface="Barlow" panose="00000500000000000000" pitchFamily="2" charset="0"/>
-              </a:rPr>
-              <a:t>NeurIPS</a:t>
+              <a:t>Proc. NeurIPS</a:t>
             </a:r>
             <a:r>
               <a:rPr lang="en-IN" sz="2000" dirty="0">
@@ -20201,19 +20174,7 @@
               <a:rPr lang="en-IN" sz="2000" dirty="0">
                 <a:latin typeface="Barlow" panose="00000500000000000000" pitchFamily="2" charset="0"/>
               </a:rPr>
-              <a:t>Z. Zhang et al., "ModernBERT: Efficient Transformer for Language Understanding," </a:t>
-            </a:r>
-            <a:r>
-              <a:rPr lang="en-IN" sz="2000" dirty="0" err="1">
-                <a:latin typeface="Barlow" panose="00000500000000000000" pitchFamily="2" charset="0"/>
-              </a:rPr>
-              <a:t>arXiv</a:t>
-            </a:r>
-            <a:r>
-              <a:rPr lang="en-IN" sz="2000" dirty="0">
-                <a:latin typeface="Barlow" panose="00000500000000000000" pitchFamily="2" charset="0"/>
-              </a:rPr>
-              <a:t> preprint arXiv:2401.12345, 2024.</a:t>
+              <a:t>Z. Zhang et al., "ModernBERT: Efficient Transformer for Language Understanding," arXiv preprint arXiv:2401.12345, 2024.</a:t>
             </a:r>
           </a:p>
           <a:p>
@@ -20225,19 +20186,7 @@
               <a:rPr lang="en-IN" sz="2000" dirty="0">
                 <a:latin typeface="Barlow" panose="00000500000000000000" pitchFamily="2" charset="0"/>
               </a:rPr>
-              <a:t>H. Deng, X. Zhang, Y. Liu, J. Li, Y. Wu, and Y. Zhang, "GTE: General Text Embeddings from Large-Scale Multilingual Retrieval," </a:t>
-            </a:r>
-            <a:r>
-              <a:rPr lang="en-IN" sz="2000" dirty="0" err="1">
-                <a:latin typeface="Barlow" panose="00000500000000000000" pitchFamily="2" charset="0"/>
-              </a:rPr>
-              <a:t>arXiv</a:t>
-            </a:r>
-            <a:r>
-              <a:rPr lang="en-IN" sz="2000" dirty="0">
-                <a:latin typeface="Barlow" panose="00000500000000000000" pitchFamily="2" charset="0"/>
-              </a:rPr>
-              <a:t> preprint arXiv:2402.03620, 2024.</a:t>
+              <a:t>H. Deng, X. Zhang, Y. Liu, J. Li, Y. Wu, and Y. Zhang, "GTE: General Text Embeddings from Large-Scale Multilingual Retrieval," arXiv preprint arXiv:2402.03620, 2024.</a:t>
             </a:r>
           </a:p>
           <a:p>
@@ -20249,19 +20198,7 @@
               <a:rPr lang="en-IN" sz="2000" dirty="0">
                 <a:latin typeface="Barlow" panose="00000500000000000000" pitchFamily="2" charset="0"/>
               </a:rPr>
-              <a:t>C. Lin, B. Yang, D. Nogueira, J. Lin, and M. Ma, "The TREC 2019 Deep Learning Track Overview," in Proc. Text </a:t>
-            </a:r>
-            <a:r>
-              <a:rPr lang="en-IN" sz="2000" dirty="0" err="1">
-                <a:latin typeface="Barlow" panose="00000500000000000000" pitchFamily="2" charset="0"/>
-              </a:rPr>
-              <a:t>REtrieval</a:t>
-            </a:r>
-            <a:r>
-              <a:rPr lang="en-IN" sz="2000" dirty="0">
-                <a:latin typeface="Barlow" panose="00000500000000000000" pitchFamily="2" charset="0"/>
-              </a:rPr>
-              <a:t> Conference (TREC), Gaithersburg, MD, USA, 2019.</a:t>
+              <a:t>C. Lin, B. Yang, D. Nogueira, J. Lin, and M. Ma, "The TREC 2019 Deep Learning Track Overview," in Proc. Text REtrieval Conference (TREC), Gaithersburg, MD, USA, 2019.</a:t>
             </a:r>
           </a:p>
         </p:txBody>
@@ -20376,31 +20313,7 @@
               <a:rPr lang="en-IN" sz="2000" dirty="0">
                 <a:latin typeface="Barlow" panose="00000500000000000000" pitchFamily="2" charset="0"/>
               </a:rPr>
-              <a:t>T. Nguyen, M. Rosenberg, X. Song, J. Gao, S. Tiwary, R. Majumder, and L. Deng, "MS MARCO: A Human Generated </a:t>
-            </a:r>
-            <a:r>
-              <a:rPr lang="en-IN" sz="2000" dirty="0" err="1">
-                <a:latin typeface="Barlow" panose="00000500000000000000" pitchFamily="2" charset="0"/>
-              </a:rPr>
-              <a:t>MAchine</a:t>
-            </a:r>
-            <a:r>
-              <a:rPr lang="en-IN" sz="2000" dirty="0">
-                <a:latin typeface="Barlow" panose="00000500000000000000" pitchFamily="2" charset="0"/>
-              </a:rPr>
-              <a:t> Reading </a:t>
-            </a:r>
-            <a:r>
-              <a:rPr lang="en-IN" sz="2000" dirty="0" err="1">
-                <a:latin typeface="Barlow" panose="00000500000000000000" pitchFamily="2" charset="0"/>
-              </a:rPr>
-              <a:t>COmprehension</a:t>
-            </a:r>
-            <a:r>
-              <a:rPr lang="en-IN" sz="2000" dirty="0">
-                <a:latin typeface="Barlow" panose="00000500000000000000" pitchFamily="2" charset="0"/>
-              </a:rPr>
-              <a:t> Dataset," in Proc. Workshop on Cognitive Computing (WCC), 2016. [Online]. Available: </a:t>
+              <a:t>T. Nguyen, M. Rosenberg, X. Song, J. Gao, S. Tiwary, R. Majumder, and L. Deng, "MS MARCO: A Human Generated MAchine Reading COmprehension Dataset," in Proc. Workshop on Cognitive Computing (WCC), 2016. [Online]. Available: </a:t>
             </a:r>
             <a:r>
               <a:rPr lang="en-IN" sz="2000" dirty="0">
@@ -20446,31 +20359,7 @@
               <a:rPr lang="en-IN" sz="2000" dirty="0">
                 <a:latin typeface="Barlow" panose="00000500000000000000" pitchFamily="2" charset="0"/>
               </a:rPr>
-              <a:t>Z. Su, Y. Lu, A. Li, B. Li, D. Zhang, and L. Wang, "</a:t>
-            </a:r>
-            <a:r>
-              <a:rPr lang="en-IN" sz="2000" dirty="0" err="1">
-                <a:latin typeface="Barlow" panose="00000500000000000000" pitchFamily="2" charset="0"/>
-              </a:rPr>
-              <a:t>RoFormer</a:t>
-            </a:r>
-            <a:r>
-              <a:rPr lang="en-IN" sz="2000" dirty="0">
-                <a:latin typeface="Barlow" panose="00000500000000000000" pitchFamily="2" charset="0"/>
-              </a:rPr>
-              <a:t>: Enhanced Transformer with Rotary Position Embedding," </a:t>
-            </a:r>
-            <a:r>
-              <a:rPr lang="en-IN" sz="2000" dirty="0" err="1">
-                <a:latin typeface="Barlow" panose="00000500000000000000" pitchFamily="2" charset="0"/>
-              </a:rPr>
-              <a:t>arXiv</a:t>
-            </a:r>
-            <a:r>
-              <a:rPr lang="en-IN" sz="2000" dirty="0">
-                <a:latin typeface="Barlow" panose="00000500000000000000" pitchFamily="2" charset="0"/>
-              </a:rPr>
-              <a:t> preprint arXiv:2104.09864, 2021.</a:t>
+              <a:t>Z. Su, Y. Lu, A. Li, B. Li, D. Zhang, and L. Wang, "RoFormer: Enhanced Transformer with Rotary Position Embedding," arXiv preprint arXiv:2104.09864, 2021.</a:t>
             </a:r>
           </a:p>
           <a:p>
@@ -20482,43 +20371,7 @@
               <a:rPr lang="en-GB" sz="2000" dirty="0">
                 <a:latin typeface="Barlow" panose="00000500000000000000" pitchFamily="2" charset="0"/>
               </a:rPr>
-              <a:t>T. Dao, D. Y. Fu, S. Ermon, A. Rudra, and C. </a:t>
-            </a:r>
-            <a:r>
-              <a:rPr lang="en-GB" sz="2000" dirty="0" err="1">
-                <a:latin typeface="Barlow" panose="00000500000000000000" pitchFamily="2" charset="0"/>
-              </a:rPr>
-              <a:t>Ré</a:t>
-            </a:r>
-            <a:r>
-              <a:rPr lang="en-GB" sz="2000" dirty="0">
-                <a:latin typeface="Barlow" panose="00000500000000000000" pitchFamily="2" charset="0"/>
-              </a:rPr>
-              <a:t>, "</a:t>
-            </a:r>
-            <a:r>
-              <a:rPr lang="en-GB" sz="2000" dirty="0" err="1">
-                <a:latin typeface="Barlow" panose="00000500000000000000" pitchFamily="2" charset="0"/>
-              </a:rPr>
-              <a:t>FlashAttention</a:t>
-            </a:r>
-            <a:r>
-              <a:rPr lang="en-GB" sz="2000" dirty="0">
-                <a:latin typeface="Barlow" panose="00000500000000000000" pitchFamily="2" charset="0"/>
-              </a:rPr>
-              <a:t>: Fast and Memory-Efficient Exact Attention with IO-Awareness," in Advances in Neural Information Processing Systems (</a:t>
-            </a:r>
-            <a:r>
-              <a:rPr lang="en-GB" sz="2000" dirty="0" err="1">
-                <a:latin typeface="Barlow" panose="00000500000000000000" pitchFamily="2" charset="0"/>
-              </a:rPr>
-              <a:t>NeurIPS</a:t>
-            </a:r>
-            <a:r>
-              <a:rPr lang="en-GB" sz="2000" dirty="0">
-                <a:latin typeface="Barlow" panose="00000500000000000000" pitchFamily="2" charset="0"/>
-              </a:rPr>
-              <a:t>), vol. 35, pp. 16438–16453, 2022.</a:t>
+              <a:t>T. Dao, D. Y. Fu, S. Ermon, A. Rudra, and C. Ré, "FlashAttention: Fast and Memory-Efficient Exact Attention with IO-Awareness," in Advances in Neural Information Processing Systems (NeurIPS), vol. 35, pp. 16438–16453, 2022.</a:t>
             </a:r>
           </a:p>
           <a:p>
@@ -20530,31 +20383,7 @@
               <a:rPr lang="en-GB" sz="2000" dirty="0">
                 <a:latin typeface="Barlow" panose="00000500000000000000" pitchFamily="2" charset="0"/>
               </a:rPr>
-              <a:t>A. </a:t>
-            </a:r>
-            <a:r>
-              <a:rPr lang="en-GB" sz="2000" dirty="0" err="1">
-                <a:latin typeface="Barlow" panose="00000500000000000000" pitchFamily="2" charset="0"/>
-              </a:rPr>
-              <a:t>Shazeer</a:t>
-            </a:r>
-            <a:r>
-              <a:rPr lang="en-GB" sz="2000" dirty="0">
-                <a:latin typeface="Barlow" panose="00000500000000000000" pitchFamily="2" charset="0"/>
-              </a:rPr>
-              <a:t>, "Gated Linear Units with GELU activation," </a:t>
-            </a:r>
-            <a:r>
-              <a:rPr lang="en-GB" sz="2000" dirty="0" err="1">
-                <a:latin typeface="Barlow" panose="00000500000000000000" pitchFamily="2" charset="0"/>
-              </a:rPr>
-              <a:t>arXiv</a:t>
-            </a:r>
-            <a:r>
-              <a:rPr lang="en-GB" sz="2000" dirty="0">
-                <a:latin typeface="Barlow" panose="00000500000000000000" pitchFamily="2" charset="0"/>
-              </a:rPr>
-              <a:t> preprint arXiv:2002.05202, 2020.</a:t>
+              <a:t>A. Shazeer, "Gated Linear Units with GELU activation," arXiv preprint arXiv:2002.05202, 2020.</a:t>
             </a:r>
           </a:p>
           <a:p>
@@ -21890,7 +21719,7 @@
         </p:blipFill>
         <p:spPr>
           <a:xfrm>
-            <a:off x="190791" y="359552"/>
+            <a:off x="190791" y="0"/>
             <a:ext cx="8416314" cy="6413632"/>
           </a:xfrm>
         </p:spPr>
@@ -21967,6 +21796,46 @@
               <a:t>Superior Accuracy</a:t>
             </a:r>
             <a:endParaRPr lang="en-IN" sz="2400" dirty="0"/>
+          </a:p>
+        </p:txBody>
+      </p:sp>
+      <p:sp>
+        <p:nvSpPr>
+          <p:cNvPr id="3" name="TextBox 2">
+            <a:extLst>
+              <a:ext uri="{FF2B5EF4-FFF2-40B4-BE49-F238E27FC236}">
+                <a16:creationId xmlns:a16="http://schemas.microsoft.com/office/drawing/2014/main" id="{E24BAE9E-E4A3-0531-F9FE-CE2D7EB0AB6D}"/>
+              </a:ext>
+            </a:extLst>
+          </p:cNvPr>
+          <p:cNvSpPr txBox="1"/>
+          <p:nvPr/>
+        </p:nvSpPr>
+        <p:spPr>
+          <a:xfrm>
+            <a:off x="2370222" y="6476040"/>
+            <a:ext cx="5470358" cy="369332"/>
+          </a:xfrm>
+          <a:prstGeom prst="rect">
+            <a:avLst/>
+          </a:prstGeom>
+          <a:noFill/>
+        </p:spPr>
+        <p:txBody>
+          <a:bodyPr wrap="square" rtlCol="0">
+            <a:spAutoFit/>
+          </a:bodyPr>
+          <a:lstStyle/>
+          <a:p>
+            <a:r>
+              <a:rPr lang="en-GB" dirty="0">
+                <a:latin typeface="Barlow" panose="00000500000000000000" pitchFamily="2" charset="0"/>
+              </a:rPr>
+              <a:t>Image Source: Claude Sonnet 4 (Anthropic, 2025)</a:t>
+            </a:r>
+            <a:endParaRPr lang="en-IN" dirty="0">
+              <a:latin typeface="Barlow" panose="00000500000000000000" pitchFamily="2" charset="0"/>
+            </a:endParaRPr>
           </a:p>
         </p:txBody>
       </p:sp>
@@ -22047,412 +21916,126 @@
           </a:p>
         </p:txBody>
       </p:sp>
-      <mc:AlternateContent xmlns:mc="http://schemas.openxmlformats.org/markup-compatibility/2006">
-        <mc:Choice xmlns:a14="http://schemas.microsoft.com/office/drawing/2010/main" Requires="a14">
-          <p:sp>
-            <p:nvSpPr>
-              <p:cNvPr id="6" name="TextBox 5">
-                <a:extLst>
-                  <a:ext uri="{FF2B5EF4-FFF2-40B4-BE49-F238E27FC236}">
-                    <a16:creationId xmlns:a16="http://schemas.microsoft.com/office/drawing/2014/main" id="{3F328A19-6B2F-462C-D96B-F58C09479D3A}"/>
-                  </a:ext>
-                </a:extLst>
-              </p:cNvPr>
-              <p:cNvSpPr txBox="1"/>
-              <p:nvPr/>
-            </p:nvSpPr>
-            <p:spPr>
-              <a:xfrm>
-                <a:off x="445168" y="2610853"/>
-                <a:ext cx="6817892" cy="3823226"/>
-              </a:xfrm>
-              <a:prstGeom prst="rect">
-                <a:avLst/>
-              </a:prstGeom>
-              <a:noFill/>
-            </p:spPr>
-            <p:txBody>
-              <a:bodyPr wrap="none" rtlCol="0">
-                <a:spAutoFit/>
-              </a:bodyPr>
-              <a:lstStyle/>
-              <a:p>
-                <a:r>
-                  <a:rPr lang="en-IN" sz="2000" dirty="0">
-                    <a:latin typeface="Barlow" panose="00000500000000000000" pitchFamily="2" charset="0"/>
-                  </a:rPr>
-                  <a:t>Evolution: Adam → AdamW</a:t>
-                </a:r>
-              </a:p>
-              <a:p>
-                <a:endParaRPr lang="en-IN" sz="2000" dirty="0">
-                  <a:latin typeface="Barlow" panose="00000500000000000000" pitchFamily="2" charset="0"/>
-                </a:endParaRPr>
-              </a:p>
-              <a:p>
-                <a:r>
-                  <a:rPr lang="en-IN" sz="2000" dirty="0">
-                    <a:latin typeface="Barlow" panose="00000500000000000000" pitchFamily="2" charset="0"/>
-                  </a:rPr>
-                  <a:t>Key Improvement:</a:t>
-                </a:r>
-              </a:p>
-              <a:p>
-                <a:r>
-                  <a:rPr lang="en-IN" sz="2000" dirty="0">
-                    <a:latin typeface="Barlow" panose="00000500000000000000" pitchFamily="2" charset="0"/>
-                  </a:rPr>
-                  <a:t>• Decoupled weight decay from gradient updates</a:t>
-                </a:r>
-              </a:p>
-              <a:p>
-                <a:pPr/>
-                <a:r>
-                  <a:rPr lang="en-IN" sz="2000" dirty="0">
-                    <a:latin typeface="Barlow" panose="00000500000000000000" pitchFamily="2" charset="0"/>
-                  </a:rPr>
-                  <a:t>•</a:t>
-                </a:r>
-                <a14:m>
-                  <m:oMath xmlns:m="http://schemas.openxmlformats.org/officeDocument/2006/math">
-                    <m:sSub>
-                      <m:sSubPr>
-                        <m:ctrlPr>
-                          <a:rPr lang="el-GR" sz="2000" i="1" dirty="0" smtClean="0">
-                            <a:latin typeface="Cambria Math" panose="02040503050406030204" pitchFamily="18" charset="0"/>
-                          </a:rPr>
-                        </m:ctrlPr>
-                      </m:sSubPr>
-                      <m:e>
-                        <m:r>
-                          <a:rPr lang="el-GR" sz="2000" i="1" dirty="0" smtClean="0">
-                            <a:latin typeface="Cambria Math" panose="02040503050406030204" pitchFamily="18" charset="0"/>
-                          </a:rPr>
-                          <m:t>𝜃</m:t>
-                        </m:r>
-                      </m:e>
-                      <m:sub>
-                        <m:d>
-                          <m:dPr>
-                            <m:begChr m:val="{"/>
-                            <m:endChr m:val="}"/>
-                            <m:ctrlPr>
-                              <a:rPr lang="el-GR" sz="2000" i="1" dirty="0" smtClean="0">
-                                <a:latin typeface="Cambria Math" panose="02040503050406030204" pitchFamily="18" charset="0"/>
-                              </a:rPr>
-                            </m:ctrlPr>
-                          </m:dPr>
-                          <m:e>
-                            <m:r>
-                              <a:rPr lang="en-IN" sz="2000" i="1" dirty="0" smtClean="0">
-                                <a:latin typeface="Cambria Math" panose="02040503050406030204" pitchFamily="18" charset="0"/>
-                              </a:rPr>
-                              <m:t>𝑡</m:t>
-                            </m:r>
-                            <m:r>
-                              <a:rPr lang="en-IN" sz="2000" i="1" dirty="0" smtClean="0">
-                                <a:latin typeface="Cambria Math" panose="02040503050406030204" pitchFamily="18" charset="0"/>
-                              </a:rPr>
-                              <m:t>+1</m:t>
-                            </m:r>
-                          </m:e>
-                        </m:d>
-                      </m:sub>
-                    </m:sSub>
-                    <m:r>
-                      <a:rPr lang="en-IN" sz="2000" i="1" dirty="0" smtClean="0">
-                        <a:latin typeface="Cambria Math" panose="02040503050406030204" pitchFamily="18" charset="0"/>
-                      </a:rPr>
-                      <m:t> = </m:t>
-                    </m:r>
-                    <m:sSub>
-                      <m:sSubPr>
-                        <m:ctrlPr>
-                          <a:rPr lang="el-GR" sz="2000" i="1" dirty="0" smtClean="0">
-                            <a:latin typeface="Cambria Math" panose="02040503050406030204" pitchFamily="18" charset="0"/>
-                          </a:rPr>
-                        </m:ctrlPr>
-                      </m:sSubPr>
-                      <m:e>
-                        <m:r>
-                          <a:rPr lang="el-GR" sz="2000" i="1" dirty="0" smtClean="0">
-                            <a:latin typeface="Cambria Math" panose="02040503050406030204" pitchFamily="18" charset="0"/>
-                          </a:rPr>
-                          <m:t>𝜃</m:t>
-                        </m:r>
-                      </m:e>
-                      <m:sub>
-                        <m:r>
-                          <a:rPr lang="en-IN" sz="2000" i="1" dirty="0" smtClean="0">
-                            <a:latin typeface="Cambria Math" panose="02040503050406030204" pitchFamily="18" charset="0"/>
-                          </a:rPr>
-                          <m:t>𝑡</m:t>
-                        </m:r>
-                      </m:sub>
-                    </m:sSub>
-                    <m:r>
-                      <a:rPr lang="en-IN" sz="2000" i="1" dirty="0" smtClean="0">
-                        <a:latin typeface="Cambria Math" panose="02040503050406030204" pitchFamily="18" charset="0"/>
-                      </a:rPr>
-                      <m:t> − </m:t>
-                    </m:r>
-                    <m:r>
-                      <a:rPr lang="el-GR" sz="2000" i="1" dirty="0" smtClean="0">
-                        <a:latin typeface="Cambria Math" panose="02040503050406030204" pitchFamily="18" charset="0"/>
-                      </a:rPr>
-                      <m:t>𝛼</m:t>
-                    </m:r>
-                    <m:r>
-                      <a:rPr lang="el-GR" sz="2000" i="1" dirty="0" smtClean="0">
-                        <a:latin typeface="Cambria Math" panose="02040503050406030204" pitchFamily="18" charset="0"/>
-                      </a:rPr>
-                      <m:t>(</m:t>
-                    </m:r>
-                    <m:sSub>
-                      <m:sSubPr>
-                        <m:ctrlPr>
-                          <a:rPr lang="en-IN" sz="2000" i="1" dirty="0" smtClean="0">
-                            <a:latin typeface="Cambria Math" panose="02040503050406030204" pitchFamily="18" charset="0"/>
-                          </a:rPr>
-                        </m:ctrlPr>
-                      </m:sSubPr>
-                      <m:e>
-                        <m:acc>
-                          <m:accPr>
-                            <m:chr m:val="̂"/>
-                            <m:ctrlPr>
-                              <a:rPr lang="en-IN" sz="2000" i="1" dirty="0" smtClean="0">
-                                <a:latin typeface="Cambria Math" panose="02040503050406030204" pitchFamily="18" charset="0"/>
-                              </a:rPr>
-                            </m:ctrlPr>
-                          </m:accPr>
-                          <m:e>
-                            <m:r>
-                              <a:rPr lang="en-IN" sz="2000" i="1" dirty="0" smtClean="0">
-                                <a:latin typeface="Cambria Math" panose="02040503050406030204" pitchFamily="18" charset="0"/>
-                              </a:rPr>
-                              <m:t>𝑚</m:t>
-                            </m:r>
-                          </m:e>
-                        </m:acc>
-                      </m:e>
-                      <m:sub>
-                        <m:r>
-                          <a:rPr lang="en-IN" sz="2000" i="1" dirty="0" smtClean="0">
-                            <a:latin typeface="Cambria Math" panose="02040503050406030204" pitchFamily="18" charset="0"/>
-                          </a:rPr>
-                          <m:t>𝑡</m:t>
-                        </m:r>
-                      </m:sub>
-                    </m:sSub>
-                    <m:r>
-                      <a:rPr lang="en-GB" sz="2000" b="0" i="1" dirty="0" smtClean="0">
-                        <a:latin typeface="Cambria Math" panose="02040503050406030204" pitchFamily="18" charset="0"/>
-                      </a:rPr>
-                      <m:t>/</m:t>
-                    </m:r>
-                    <m:r>
-                      <a:rPr lang="en-IN" sz="2000" i="1" dirty="0" smtClean="0">
-                        <a:latin typeface="Cambria Math" panose="02040503050406030204" pitchFamily="18" charset="0"/>
-                      </a:rPr>
-                      <m:t>√</m:t>
-                    </m:r>
-                    <m:sSub>
-                      <m:sSubPr>
-                        <m:ctrlPr>
-                          <a:rPr lang="en-IN" sz="2000" i="1" dirty="0" smtClean="0">
-                            <a:latin typeface="Cambria Math" panose="02040503050406030204" pitchFamily="18" charset="0"/>
-                          </a:rPr>
-                        </m:ctrlPr>
-                      </m:sSubPr>
-                      <m:e>
-                        <m:acc>
-                          <m:accPr>
-                            <m:chr m:val="̂"/>
-                            <m:ctrlPr>
-                              <a:rPr lang="en-IN" sz="2000" i="1" dirty="0" smtClean="0">
-                                <a:latin typeface="Cambria Math" panose="02040503050406030204" pitchFamily="18" charset="0"/>
-                              </a:rPr>
-                            </m:ctrlPr>
-                          </m:accPr>
-                          <m:e>
-                            <m:r>
-                              <a:rPr lang="en-IN" sz="2000" i="1" dirty="0" smtClean="0">
-                                <a:latin typeface="Cambria Math" panose="02040503050406030204" pitchFamily="18" charset="0"/>
-                              </a:rPr>
-                              <m:t>𝑣</m:t>
-                            </m:r>
-                          </m:e>
-                        </m:acc>
-                      </m:e>
-                      <m:sub>
-                        <m:r>
-                          <a:rPr lang="en-IN" sz="2000" i="1" dirty="0" smtClean="0">
-                            <a:latin typeface="Cambria Math" panose="02040503050406030204" pitchFamily="18" charset="0"/>
-                          </a:rPr>
-                          <m:t>𝑡</m:t>
-                        </m:r>
-                      </m:sub>
-                    </m:sSub>
-                    <m:r>
-                      <a:rPr lang="en-IN" sz="2000" i="1" dirty="0" smtClean="0">
-                        <a:latin typeface="Cambria Math" panose="02040503050406030204" pitchFamily="18" charset="0"/>
-                      </a:rPr>
-                      <m:t> + </m:t>
-                    </m:r>
-                    <m:r>
-                      <a:rPr lang="el-GR" sz="2000" i="1" dirty="0" smtClean="0">
-                        <a:latin typeface="Cambria Math" panose="02040503050406030204" pitchFamily="18" charset="0"/>
-                      </a:rPr>
-                      <m:t>𝜆</m:t>
-                    </m:r>
-                    <m:sSub>
-                      <m:sSubPr>
-                        <m:ctrlPr>
-                          <a:rPr lang="el-GR" sz="2000" i="1" dirty="0" smtClean="0">
-                            <a:latin typeface="Cambria Math" panose="02040503050406030204" pitchFamily="18" charset="0"/>
-                          </a:rPr>
-                        </m:ctrlPr>
-                      </m:sSubPr>
-                      <m:e>
-                        <m:r>
-                          <a:rPr lang="el-GR" sz="2000" i="1" dirty="0" smtClean="0">
-                            <a:latin typeface="Cambria Math" panose="02040503050406030204" pitchFamily="18" charset="0"/>
-                          </a:rPr>
-                          <m:t>𝜃</m:t>
-                        </m:r>
-                      </m:e>
-                      <m:sub>
-                        <m:r>
-                          <a:rPr lang="en-IN" sz="2000" i="1" dirty="0" smtClean="0">
-                            <a:latin typeface="Cambria Math" panose="02040503050406030204" pitchFamily="18" charset="0"/>
-                          </a:rPr>
-                          <m:t>𝑡</m:t>
-                        </m:r>
-                      </m:sub>
-                    </m:sSub>
-                    <m:r>
-                      <a:rPr lang="en-IN" sz="2000" i="1" dirty="0" smtClean="0">
-                        <a:latin typeface="Cambria Math" panose="02040503050406030204" pitchFamily="18" charset="0"/>
-                      </a:rPr>
-                      <m:t>)</m:t>
-                    </m:r>
-                  </m:oMath>
-                </a14:m>
-                <a:endParaRPr lang="en-IN" sz="2000" dirty="0">
-                  <a:latin typeface="Barlow" panose="00000500000000000000" pitchFamily="2" charset="0"/>
-                </a:endParaRPr>
-              </a:p>
-              <a:p>
-                <a:endParaRPr lang="en-IN" sz="2000" dirty="0">
-                  <a:latin typeface="Barlow" panose="00000500000000000000" pitchFamily="2" charset="0"/>
-                </a:endParaRPr>
-              </a:p>
-              <a:p>
-                <a:r>
-                  <a:rPr lang="en-IN" sz="2000" dirty="0">
-                    <a:latin typeface="Barlow" panose="00000500000000000000" pitchFamily="2" charset="0"/>
-                  </a:rPr>
-                  <a:t>Why AdamW Dominates:</a:t>
-                </a:r>
-              </a:p>
-              <a:p>
-                <a:r>
-                  <a:rPr lang="en-IN" sz="2000" dirty="0">
-                    <a:latin typeface="Barlow" panose="00000500000000000000" pitchFamily="2" charset="0"/>
-                  </a:rPr>
-                  <a:t>✓ Better generalization than Adam</a:t>
-                </a:r>
-              </a:p>
-              <a:p>
-                <a:r>
-                  <a:rPr lang="en-IN" sz="2000" dirty="0">
-                    <a:latin typeface="Barlow" panose="00000500000000000000" pitchFamily="2" charset="0"/>
-                  </a:rPr>
-                  <a:t>✓ Stable training for transformers</a:t>
-                </a:r>
-              </a:p>
-              <a:p>
-                <a:r>
-                  <a:rPr lang="en-IN" sz="2000" dirty="0">
-                    <a:latin typeface="Barlow" panose="00000500000000000000" pitchFamily="2" charset="0"/>
-                  </a:rPr>
-                  <a:t>✓ De facto standard for BERT</a:t>
-                </a:r>
-                <a:r>
-                  <a:rPr lang="en-IN" sz="2000" b="1" baseline="30000" dirty="0">
-                    <a:latin typeface="Barlow" panose="00000500000000000000" pitchFamily="2" charset="0"/>
-                  </a:rPr>
-                  <a:t>[1]  </a:t>
-                </a:r>
-                <a:r>
-                  <a:rPr lang="en-IN" sz="2000" dirty="0">
-                    <a:latin typeface="Barlow" panose="00000500000000000000" pitchFamily="2" charset="0"/>
-                  </a:rPr>
-                  <a:t>family models</a:t>
-                </a:r>
-              </a:p>
-              <a:p>
-                <a:endParaRPr lang="en-IN" sz="2000" dirty="0">
-                  <a:latin typeface="Barlow" panose="00000500000000000000" pitchFamily="2" charset="0"/>
-                </a:endParaRPr>
-              </a:p>
-              <a:p>
-                <a:r>
-                  <a:rPr lang="en-IN" sz="2000" dirty="0">
-                    <a:latin typeface="Barlow" panose="00000500000000000000" pitchFamily="2" charset="0"/>
-                  </a:rPr>
-                  <a:t>Current Status: Default choice without alternatives explored</a:t>
-                </a:r>
-              </a:p>
-            </p:txBody>
-          </p:sp>
-        </mc:Choice>
-        <mc:Fallback>
-          <p:sp>
-            <p:nvSpPr>
-              <p:cNvPr id="6" name="TextBox 5">
-                <a:extLst>
-                  <a:ext uri="{FF2B5EF4-FFF2-40B4-BE49-F238E27FC236}">
-                    <a16:creationId xmlns:a16="http://schemas.microsoft.com/office/drawing/2014/main" id="{3F328A19-6B2F-462C-D96B-F58C09479D3A}"/>
-                  </a:ext>
-                </a:extLst>
-              </p:cNvPr>
-              <p:cNvSpPr txBox="1">
-                <a:spLocks noRot="1" noChangeAspect="1" noMove="1" noResize="1" noEditPoints="1" noAdjustHandles="1" noChangeArrowheads="1" noChangeShapeType="1" noTextEdit="1"/>
-              </p:cNvSpPr>
-              <p:nvPr/>
-            </p:nvSpPr>
-            <p:spPr>
-              <a:xfrm>
-                <a:off x="445168" y="2610853"/>
-                <a:ext cx="6817892" cy="3823226"/>
-              </a:xfrm>
-              <a:prstGeom prst="rect">
-                <a:avLst/>
-              </a:prstGeom>
-              <a:blipFill>
-                <a:blip r:embed="rId2"/>
-                <a:stretch>
-                  <a:fillRect l="-894" t="-957" r="-89" b="-2233"/>
-                </a:stretch>
-              </a:blipFill>
-            </p:spPr>
-            <p:txBody>
-              <a:bodyPr/>
-              <a:lstStyle/>
-              <a:p>
-                <a:r>
-                  <a:rPr lang="en-IN">
-                    <a:noFill/>
-                  </a:rPr>
-                  <a:t> </a:t>
-                </a:r>
-              </a:p>
-            </p:txBody>
-          </p:sp>
-        </mc:Fallback>
-      </mc:AlternateContent>
+      <p:sp>
+        <p:nvSpPr>
+          <p:cNvPr id="6" name="TextBox 5">
+            <a:extLst>
+              <a:ext uri="{FF2B5EF4-FFF2-40B4-BE49-F238E27FC236}">
+                <a16:creationId xmlns:a16="http://schemas.microsoft.com/office/drawing/2014/main" id="{3F328A19-6B2F-462C-D96B-F58C09479D3A}"/>
+              </a:ext>
+            </a:extLst>
+          </p:cNvPr>
+          <p:cNvSpPr txBox="1"/>
+          <p:nvPr/>
+        </p:nvSpPr>
+        <p:spPr>
+          <a:xfrm>
+            <a:off x="445168" y="2610853"/>
+            <a:ext cx="6846746" cy="3477875"/>
+          </a:xfrm>
+          <a:prstGeom prst="rect">
+            <a:avLst/>
+          </a:prstGeom>
+          <a:noFill/>
+        </p:spPr>
+        <p:txBody>
+          <a:bodyPr wrap="none" rtlCol="0">
+            <a:spAutoFit/>
+          </a:bodyPr>
+          <a:lstStyle/>
+          <a:p>
+            <a:r>
+              <a:rPr lang="en-IN" sz="2000" dirty="0">
+                <a:latin typeface="Barlow" panose="00000500000000000000" pitchFamily="2" charset="0"/>
+              </a:rPr>
+              <a:t>Evolution: Adam → AdamW</a:t>
+            </a:r>
+          </a:p>
+          <a:p>
+            <a:endParaRPr lang="en-IN" sz="2000" dirty="0">
+              <a:latin typeface="Barlow" panose="00000500000000000000" pitchFamily="2" charset="0"/>
+            </a:endParaRPr>
+          </a:p>
+          <a:p>
+            <a:r>
+              <a:rPr lang="en-IN" sz="2000" dirty="0">
+                <a:latin typeface="Barlow" panose="00000500000000000000" pitchFamily="2" charset="0"/>
+              </a:rPr>
+              <a:t>Key Improvement:</a:t>
+            </a:r>
+          </a:p>
+          <a:p>
+            <a:r>
+              <a:rPr lang="en-IN" sz="2000" dirty="0">
+                <a:latin typeface="Barlow" panose="00000500000000000000" pitchFamily="2" charset="0"/>
+              </a:rPr>
+              <a:t>• Decoupled weight decay from gradient updates</a:t>
+            </a:r>
+          </a:p>
+          <a:p>
+            <a:endParaRPr lang="en-IN" sz="2000" dirty="0">
+              <a:latin typeface="Barlow" panose="00000500000000000000" pitchFamily="2" charset="0"/>
+            </a:endParaRPr>
+          </a:p>
+          <a:p>
+            <a:r>
+              <a:rPr lang="en-IN" sz="2000" dirty="0">
+                <a:latin typeface="Barlow" panose="00000500000000000000" pitchFamily="2" charset="0"/>
+              </a:rPr>
+              <a:t>Why AdamW Dominates:</a:t>
+            </a:r>
+          </a:p>
+          <a:p>
+            <a:r>
+              <a:rPr lang="en-IN" sz="2000" dirty="0">
+                <a:latin typeface="Barlow" panose="00000500000000000000" pitchFamily="2" charset="0"/>
+              </a:rPr>
+              <a:t>✓ Better generalization than Adam</a:t>
+            </a:r>
+          </a:p>
+          <a:p>
+            <a:r>
+              <a:rPr lang="en-IN" sz="2000" dirty="0">
+                <a:latin typeface="Barlow" panose="00000500000000000000" pitchFamily="2" charset="0"/>
+              </a:rPr>
+              <a:t>✓ Stable training for transformers</a:t>
+            </a:r>
+          </a:p>
+          <a:p>
+            <a:r>
+              <a:rPr lang="en-IN" sz="2000" dirty="0">
+                <a:latin typeface="Barlow" panose="00000500000000000000" pitchFamily="2" charset="0"/>
+              </a:rPr>
+              <a:t>✓ De facto standard for BERT</a:t>
+            </a:r>
+            <a:r>
+              <a:rPr lang="en-IN" sz="2000" b="1" baseline="30000" dirty="0">
+                <a:latin typeface="Barlow" panose="00000500000000000000" pitchFamily="2" charset="0"/>
+              </a:rPr>
+              <a:t>[1]  </a:t>
+            </a:r>
+            <a:r>
+              <a:rPr lang="en-IN" sz="2000" dirty="0">
+                <a:latin typeface="Barlow" panose="00000500000000000000" pitchFamily="2" charset="0"/>
+              </a:rPr>
+              <a:t>family models</a:t>
+            </a:r>
+          </a:p>
+          <a:p>
+            <a:endParaRPr lang="en-IN" sz="2000" dirty="0">
+              <a:latin typeface="Barlow" panose="00000500000000000000" pitchFamily="2" charset="0"/>
+            </a:endParaRPr>
+          </a:p>
+          <a:p>
+            <a:r>
+              <a:rPr lang="en-IN" sz="2000" dirty="0">
+                <a:latin typeface="Barlow" panose="00000500000000000000" pitchFamily="2" charset="0"/>
+              </a:rPr>
+              <a:t>Current Status: Default choice without alternatives explored</a:t>
+            </a:r>
+          </a:p>
+        </p:txBody>
+      </p:sp>
     </p:spTree>
     <p:extLst>
       <p:ext uri="{BB962C8B-B14F-4D97-AF65-F5344CB8AC3E}">
@@ -23434,15 +23017,6 @@
 </file>
 
 <file path=customXml/item1.xml><?xml version="1.0" encoding="utf-8"?>
-<?mso-contentType ?>
-<FormTemplates xmlns="http://schemas.microsoft.com/sharepoint/v3/contenttype/forms">
-  <Display>DocumentLibraryForm</Display>
-  <Edit>DocumentLibraryForm</Edit>
-  <New>DocumentLibraryForm</New>
-</FormTemplates>
-</file>
-
-<file path=customXml/item2.xml><?xml version="1.0" encoding="utf-8"?>
 <p:properties xmlns:p="http://schemas.microsoft.com/office/2006/metadata/properties" xmlns:xsi="http://www.w3.org/2001/XMLSchema-instance" xmlns:pc="http://schemas.microsoft.com/office/infopath/2007/PartnerControls">
   <documentManagement>
     <_ip_UnifiedCompliancePolicyUIAction xmlns="http://schemas.microsoft.com/sharepoint/v3" xsi:nil="true"/>
@@ -23460,6 +23034,15 @@
     <MediaServiceKeyPoints xmlns="71af3243-3dd4-4a8d-8c0d-dd76da1f02a5" xsi:nil="true"/>
   </documentManagement>
 </p:properties>
+</file>
+
+<file path=customXml/item2.xml><?xml version="1.0" encoding="utf-8"?>
+<?mso-contentType ?>
+<FormTemplates xmlns="http://schemas.microsoft.com/sharepoint/v3/contenttype/forms">
+  <Display>DocumentLibraryForm</Display>
+  <Edit>DocumentLibraryForm</Edit>
+  <New>DocumentLibraryForm</New>
+</FormTemplates>
 </file>
 
 <file path=customXml/item3.xml><?xml version="1.0" encoding="utf-8"?>
@@ -23751,14 +23334,6 @@
 </file>
 
 <file path=customXml/itemProps1.xml><?xml version="1.0" encoding="utf-8"?>
-<ds:datastoreItem xmlns:ds="http://schemas.openxmlformats.org/officeDocument/2006/customXml" ds:itemID="{019B3EA6-E2E1-4B68-B700-9432F9FC79DA}">
-  <ds:schemaRefs>
-    <ds:schemaRef ds:uri="http://schemas.microsoft.com/sharepoint/v3/contenttype/forms"/>
-  </ds:schemaRefs>
-</ds:datastoreItem>
-</file>
-
-<file path=customXml/itemProps2.xml><?xml version="1.0" encoding="utf-8"?>
 <ds:datastoreItem xmlns:ds="http://schemas.openxmlformats.org/officeDocument/2006/customXml" ds:itemID="{BC8413E5-0484-489B-B293-D8720B6027F2}">
   <ds:schemaRefs>
     <ds:schemaRef ds:uri="16c05727-aa75-4e4a-9b5f-8a80a1165891"/>
@@ -23773,6 +23348,14 @@
     <ds:schemaRef ds:uri="http://schemas.microsoft.com/sharepoint/v3"/>
     <ds:schemaRef ds:uri="http://purl.org/dc/dcmitype/"/>
     <ds:schemaRef ds:uri="http://purl.org/dc/elements/1.1/"/>
+  </ds:schemaRefs>
+</ds:datastoreItem>
+</file>
+
+<file path=customXml/itemProps2.xml><?xml version="1.0" encoding="utf-8"?>
+<ds:datastoreItem xmlns:ds="http://schemas.openxmlformats.org/officeDocument/2006/customXml" ds:itemID="{019B3EA6-E2E1-4B68-B700-9432F9FC79DA}">
+  <ds:schemaRefs>
+    <ds:schemaRef ds:uri="http://schemas.microsoft.com/sharepoint/v3/contenttype/forms"/>
   </ds:schemaRefs>
 </ds:datastoreItem>
 </file>

</xml_diff>

<commit_message>
Refactor thesis presentation for improved clarity and structure
</commit_message>
<xml_diff>
--- a/cross_encoder/thesis/Thesis_presentation.pptx
+++ b/cross_encoder/thesis/Thesis_presentation.pptx
@@ -9936,9 +9936,13 @@
             <a:r>
               <a:rPr lang="en-IN" sz="2800" b="1" baseline="30000" dirty="0">
                 <a:latin typeface="Barlow SemiBold" panose="00000700000000000000" pitchFamily="2" charset="0"/>
+                <a:hlinkClick r:id="rId2" action="ppaction://hlinksldjump"/>
               </a:rPr>
               <a:t>[4]</a:t>
             </a:r>
+            <a:endParaRPr lang="en-IN" sz="2800" b="1" baseline="30000" dirty="0">
+              <a:latin typeface="Barlow SemiBold" panose="00000700000000000000" pitchFamily="2" charset="0"/>
+            </a:endParaRPr>
           </a:p>
         </p:txBody>
       </p:sp>
@@ -10172,10 +10176,10 @@
       </p:pic>
       <p:pic>
         <p:nvPicPr>
-          <p:cNvPr id="3" name="@holatex&#10;\begin{document}&#10;\center&#10;where:&#10;\begin{itemize}&#10;    \item $c_t$: interpolated momentum for update direction&#10;    \item $\text{sign}(\cdot)$: element-wise sign function&#10;    \item Other parameters follow similar definitions as AdamW&#10;\end{itemize}&#10;\end{document}">
+          <p:cNvPr id="6" name="@holatex&#10;\begin{document}&#10;\center&#10;where:&#10;\begin{itemize}&#10;    \item $c_t$: interpolated momentum for update direction&#10;    \item $\text{sign}(\cdot)$: element-wise sign function  &#10;    \item $\theta_t$: model parameters at time step $t$&#10;    \item $g_t$: gradient at time step $t$&#10;    \item $m_t$: exponential moving average of gradients (momentum)&#10;    \item $\eta$: learning rate&#10;    \item $\beta_1$: momentum coefficient for update direction (typically 0.9)&#10;    \item $\beta_2$: momentum coefficient for gradient tracking (typically 0.99)&#10;    \item $\lambda$: weight decay coefficient&#10;\end{itemize}&#10;\end{document}">
             <a:extLst>
               <a:ext uri="{FF2B5EF4-FFF2-40B4-BE49-F238E27FC236}">
-                <a16:creationId xmlns:a16="http://schemas.microsoft.com/office/drawing/2014/main" id="{996BC0B4-312F-574A-8729-9E94B96A1AB9}"/>
+                <a16:creationId xmlns:a16="http://schemas.microsoft.com/office/drawing/2014/main" id="{5860B546-5E53-616F-31DD-9768D14F3DAB}"/>
               </a:ext>
             </a:extLst>
           </p:cNvPr>
@@ -10192,8 +10196,8 @@
         </p:blipFill>
         <p:spPr>
           <a:xfrm>
-            <a:off x="6329956" y="3687882"/>
-            <a:ext cx="4599964" cy="1667013"/>
+            <a:off x="6505216" y="2461062"/>
+            <a:ext cx="4876782" cy="3949750"/>
           </a:xfrm>
           <a:prstGeom prst="rect">
             <a:avLst/>
@@ -10408,14 +10412,22 @@
             <a:r>
               <a:rPr lang="en-IN" sz="2400" b="1" baseline="30000" dirty="0">
                 <a:latin typeface="Barlow" panose="00000500000000000000" pitchFamily="2" charset="0"/>
+                <a:hlinkClick r:id="rId2" action="ppaction://hlinksldjump"/>
               </a:rPr>
               <a:t>[9]</a:t>
             </a:r>
             <a:r>
               <a:rPr lang="en-IN" sz="2400" dirty="0">
                 <a:latin typeface="Barlow" panose="00000500000000000000" pitchFamily="2" charset="0"/>
-              </a:rPr>
-              <a:t> Passage Ranking (~500K query-passage pairs)</a:t>
+                <a:hlinkClick r:id="rId2" action="ppaction://hlinksldjump"/>
+              </a:rPr>
+              <a:t> </a:t>
+            </a:r>
+            <a:r>
+              <a:rPr lang="en-IN" sz="2400" dirty="0">
+                <a:latin typeface="Barlow" panose="00000500000000000000" pitchFamily="2" charset="0"/>
+              </a:rPr>
+              <a:t>Passage Ranking (~500K query-passage pairs)</a:t>
             </a:r>
           </a:p>
           <a:p>
@@ -10435,14 +10447,22 @@
             <a:r>
               <a:rPr lang="en-IN" sz="2400" b="1" baseline="30000" dirty="0">
                 <a:latin typeface="Barlow" panose="00000500000000000000" pitchFamily="2" charset="0"/>
+                <a:hlinkClick r:id="rId3" action="ppaction://hlinksldjump"/>
               </a:rPr>
               <a:t>[8]</a:t>
             </a:r>
             <a:r>
               <a:rPr lang="en-IN" sz="2400" dirty="0">
                 <a:latin typeface="Barlow" panose="00000500000000000000" pitchFamily="2" charset="0"/>
-              </a:rPr>
-              <a:t> 2019 (43 queries with comprehensive relevance judgments)</a:t>
+                <a:hlinkClick r:id="rId3" action="ppaction://hlinksldjump"/>
+              </a:rPr>
+              <a:t> </a:t>
+            </a:r>
+            <a:r>
+              <a:rPr lang="en-IN" sz="2400" dirty="0">
+                <a:latin typeface="Barlow" panose="00000500000000000000" pitchFamily="2" charset="0"/>
+              </a:rPr>
+              <a:t>2019 (43 queries with comprehensive relevance judgments)</a:t>
             </a:r>
           </a:p>
           <a:p>
@@ -10488,9 +10508,13 @@
             <a:r>
               <a:rPr lang="en-IN" sz="2400" b="1" baseline="30000" dirty="0">
                 <a:latin typeface="Barlow" panose="00000500000000000000" pitchFamily="2" charset="0"/>
+                <a:hlinkClick r:id="rId2" action="ppaction://hlinksldjump"/>
               </a:rPr>
               <a:t>[10]</a:t>
             </a:r>
+            <a:endParaRPr lang="en-IN" sz="2400" b="1" baseline="30000" dirty="0">
+              <a:latin typeface="Barlow" panose="00000500000000000000" pitchFamily="2" charset="0"/>
+            </a:endParaRPr>
           </a:p>
           <a:p>
             <a:pPr lvl="1"/>
@@ -10524,9 +10548,13 @@
             <a:r>
               <a:rPr lang="en-IN" sz="2400" b="1" baseline="30000" dirty="0">
                 <a:latin typeface="Barlow" panose="00000500000000000000" pitchFamily="2" charset="0"/>
+                <a:hlinkClick r:id="rId2" action="ppaction://hlinksldjump"/>
               </a:rPr>
               <a:t>[11]</a:t>
             </a:r>
+            <a:endParaRPr lang="en-IN" sz="2400" b="1" baseline="30000" dirty="0">
+              <a:latin typeface="Barlow" panose="00000500000000000000" pitchFamily="2" charset="0"/>
+            </a:endParaRPr>
           </a:p>
           <a:p>
             <a:pPr lvl="1"/>
@@ -10681,14 +10709,14 @@
           <p:nvPr>
             <p:extLst>
               <p:ext uri="{D42A27DB-BD31-4B8C-83A1-F6EECF244321}">
-                <p14:modId xmlns:p14="http://schemas.microsoft.com/office/powerpoint/2010/main" val="2952616321"/>
+                <p14:modId xmlns:p14="http://schemas.microsoft.com/office/powerpoint/2010/main" val="4000075422"/>
               </p:ext>
             </p:extLst>
           </p:nvPr>
         </p:nvGraphicFramePr>
         <p:xfrm>
           <a:off x="782704" y="1812991"/>
-          <a:ext cx="10629934" cy="2621280"/>
+          <a:ext cx="10629934" cy="2926080"/>
         </p:xfrm>
         <a:graphic>
           <a:graphicData uri="http://schemas.openxmlformats.org/drawingml/2006/table">
@@ -10780,7 +10808,7 @@
                           </a:effectLst>
                           <a:latin typeface="Barlow Medium" panose="00000600000000000000" pitchFamily="2" charset="0"/>
                         </a:rPr>
-                        <a:t>Parameters</a:t>
+                        <a:t># Parameters</a:t>
                       </a:r>
                       <a:endParaRPr lang="en-IN" sz="2400" dirty="0">
                         <a:effectLst>
@@ -10895,7 +10923,15 @@
                         </a:rPr>
                         <a:t>MiniLM-L12-H384</a:t>
                       </a:r>
-                      <a:endParaRPr lang="en-IN" sz="2000" dirty="0">
+                      <a:r>
+                        <a:rPr lang="en-IN" sz="2000" b="1" baseline="30000" dirty="0">
+                          <a:effectLst/>
+                          <a:latin typeface="Barlow" panose="00000500000000000000" pitchFamily="2" charset="0"/>
+                          <a:hlinkClick r:id="rId3" action="ppaction://hlinksldjump"/>
+                        </a:rPr>
+                        <a:t>[5]</a:t>
+                      </a:r>
+                      <a:endParaRPr lang="en-IN" sz="2000" baseline="30000" dirty="0">
                         <a:effectLst/>
                         <a:latin typeface="Barlow" panose="00000500000000000000" pitchFamily="2" charset="0"/>
                       </a:endParaRPr>
@@ -11086,7 +11122,15 @@
                         </a:rPr>
                         <a:t>GTE-multilingual-base</a:t>
                       </a:r>
-                      <a:endParaRPr lang="en-IN" sz="2000" dirty="0">
+                      <a:r>
+                        <a:rPr lang="en-IN" sz="2000" b="1" baseline="30000" dirty="0">
+                          <a:effectLst/>
+                          <a:latin typeface="Barlow" panose="00000500000000000000" pitchFamily="2" charset="0"/>
+                          <a:hlinkClick r:id="rId3" action="ppaction://hlinksldjump"/>
+                        </a:rPr>
+                        <a:t>[7]</a:t>
+                      </a:r>
+                      <a:endParaRPr lang="en-IN" sz="2000" baseline="30000" dirty="0">
                         <a:effectLst/>
                         <a:latin typeface="Barlow" panose="00000500000000000000" pitchFamily="2" charset="0"/>
                       </a:endParaRPr>
@@ -11271,13 +11315,21 @@
                     <a:p>
                       <a:pPr algn="l"/>
                       <a:r>
-                        <a:rPr lang="en-IN" sz="2000" b="1">
+                        <a:rPr lang="en-IN" sz="2000" b="1" dirty="0">
                           <a:effectLst/>
                           <a:latin typeface="Barlow" panose="00000500000000000000" pitchFamily="2" charset="0"/>
                         </a:rPr>
                         <a:t>ModernBERT-base</a:t>
                       </a:r>
-                      <a:endParaRPr lang="en-IN" sz="2000">
+                      <a:r>
+                        <a:rPr lang="en-IN" sz="2000" b="1" baseline="30000" dirty="0">
+                          <a:effectLst/>
+                          <a:latin typeface="Barlow" panose="00000500000000000000" pitchFamily="2" charset="0"/>
+                          <a:hlinkClick r:id="rId3" action="ppaction://hlinksldjump"/>
+                        </a:rPr>
+                        <a:t>[6]</a:t>
+                      </a:r>
+                      <a:endParaRPr lang="en-IN" sz="2000" baseline="30000" dirty="0">
                         <a:effectLst/>
                         <a:latin typeface="Barlow" panose="00000500000000000000" pitchFamily="2" charset="0"/>
                       </a:endParaRPr>
@@ -11320,7 +11372,7 @@
                     <a:p>
                       <a:pPr algn="l"/>
                       <a:r>
-                        <a:rPr lang="en-IN" sz="2000">
+                        <a:rPr lang="en-IN" sz="2000" dirty="0">
                           <a:effectLst/>
                           <a:latin typeface="Barlow" panose="00000500000000000000" pitchFamily="2" charset="0"/>
                         </a:rPr>
@@ -11414,8 +11466,57 @@
                           <a:effectLst/>
                           <a:latin typeface="Barlow" panose="00000500000000000000" pitchFamily="2" charset="0"/>
                         </a:rPr>
-                        <a:t>RoPE, Flash Attention, GeGLU</a:t>
+                        <a:t>RoPE</a:t>
                       </a:r>
+                      <a:r>
+                        <a:rPr lang="en-IN" sz="2000" baseline="30000" dirty="0">
+                          <a:effectLst/>
+                          <a:latin typeface="Barlow" panose="00000500000000000000" pitchFamily="2" charset="0"/>
+                          <a:hlinkClick r:id="rId4" action="ppaction://hlinksldjump"/>
+                        </a:rPr>
+                        <a:t>[12]</a:t>
+                      </a:r>
+                      <a:r>
+                        <a:rPr lang="en-IN" sz="2000" baseline="30000" dirty="0">
+                          <a:effectLst/>
+                          <a:latin typeface="Barlow" panose="00000500000000000000" pitchFamily="2" charset="0"/>
+                        </a:rPr>
+                        <a:t>, </a:t>
+                      </a:r>
+                      <a:r>
+                        <a:rPr lang="en-IN" sz="2000" dirty="0">
+                          <a:effectLst/>
+                          <a:latin typeface="Barlow" panose="00000500000000000000" pitchFamily="2" charset="0"/>
+                        </a:rPr>
+                        <a:t>Flash Attention</a:t>
+                      </a:r>
+                      <a:r>
+                        <a:rPr lang="en-IN" sz="2000" baseline="30000" dirty="0">
+                          <a:effectLst/>
+                          <a:latin typeface="Barlow" panose="00000500000000000000" pitchFamily="2" charset="0"/>
+                          <a:hlinkClick r:id="rId4" action="ppaction://hlinksldjump"/>
+                        </a:rPr>
+                        <a:t>[13]</a:t>
+                      </a:r>
+                      <a:r>
+                        <a:rPr lang="en-IN" sz="2000" dirty="0">
+                          <a:effectLst/>
+                          <a:latin typeface="Barlow" panose="00000500000000000000" pitchFamily="2" charset="0"/>
+                        </a:rPr>
+                        <a:t>, GeGLU</a:t>
+                      </a:r>
+                      <a:r>
+                        <a:rPr lang="en-IN" sz="2000" baseline="30000" dirty="0">
+                          <a:effectLst/>
+                          <a:latin typeface="Barlow" panose="00000500000000000000" pitchFamily="2" charset="0"/>
+                          <a:hlinkClick r:id="rId4" action="ppaction://hlinksldjump"/>
+                        </a:rPr>
+                        <a:t>[14]</a:t>
+                      </a:r>
+                      <a:endParaRPr lang="en-IN" sz="2000" baseline="30000" dirty="0">
+                        <a:effectLst/>
+                        <a:latin typeface="Barlow" panose="00000500000000000000" pitchFamily="2" charset="0"/>
+                      </a:endParaRPr>
                     </a:p>
                   </a:txBody>
                   <a:tcPr anchor="ctr">
@@ -11737,7 +11838,7 @@
           <p:nvPr>
             <p:extLst>
               <p:ext uri="{D42A27DB-BD31-4B8C-83A1-F6EECF244321}">
-                <p14:modId xmlns:p14="http://schemas.microsoft.com/office/powerpoint/2010/main" val="2013879173"/>
+                <p14:modId xmlns:p14="http://schemas.microsoft.com/office/powerpoint/2010/main" val="4110281572"/>
               </p:ext>
             </p:extLst>
           </p:nvPr>
@@ -11939,7 +12040,28 @@
                           <a:effectLst/>
                           <a:latin typeface="Barlow" panose="00000500000000000000" pitchFamily="2" charset="0"/>
                         </a:rPr>
-                        <a:t>2e-5 (2e-6 for ModernBERT)</a:t>
+                        <a:t>2e-5 (2e-6 for ModernBERT</a:t>
+                      </a:r>
+                      <a:r>
+                        <a:rPr lang="en-IN" sz="2000" baseline="30000" dirty="0">
+                          <a:solidFill>
+                            <a:schemeClr val="tx1"/>
+                          </a:solidFill>
+                          <a:effectLst/>
+                          <a:latin typeface="Barlow" panose="00000500000000000000" pitchFamily="2" charset="0"/>
+                          <a:hlinkClick r:id="rId2" action="ppaction://hlinksldjump"/>
+                        </a:rPr>
+                        <a:t>[6]</a:t>
+                      </a:r>
+                      <a:r>
+                        <a:rPr lang="en-IN" sz="2000" dirty="0">
+                          <a:solidFill>
+                            <a:schemeClr val="tx1"/>
+                          </a:solidFill>
+                          <a:effectLst/>
+                          <a:latin typeface="Barlow" panose="00000500000000000000" pitchFamily="2" charset="0"/>
+                        </a:rPr>
+                        <a:t>)</a:t>
                       </a:r>
                     </a:p>
                   </a:txBody>
@@ -12432,7 +12554,7 @@
                     <a:p>
                       <a:pPr algn="ctr"/>
                       <a:r>
-                        <a:rPr lang="en-IN" sz="2000">
+                        <a:rPr lang="en-IN" sz="2000" dirty="0">
                           <a:solidFill>
                             <a:schemeClr val="tx1"/>
                           </a:solidFill>
@@ -12535,7 +12657,7 @@
 </file>
 
 <file path=ppt/slides/slide16.xml><?xml version="1.0" encoding="utf-8"?>
-<p:sld xmlns:a="http://schemas.openxmlformats.org/drawingml/2006/main" xmlns:r="http://schemas.openxmlformats.org/officeDocument/2006/relationships" xmlns:p="http://schemas.openxmlformats.org/presentationml/2006/main" show="0">
+<p:sld xmlns:a="http://schemas.openxmlformats.org/drawingml/2006/main" xmlns:r="http://schemas.openxmlformats.org/officeDocument/2006/relationships" xmlns:p="http://schemas.openxmlformats.org/presentationml/2006/main">
   <p:cSld>
     <p:spTree>
       <p:nvGrpSpPr>
@@ -12576,7 +12698,7 @@
               <a:rPr lang="en-GB" dirty="0">
                 <a:latin typeface="Barlow ExtraBold" panose="00000900000000000000" pitchFamily="2" charset="0"/>
               </a:rPr>
-              <a:t>Evaluation Metrices</a:t>
+              <a:t>Evaluation Metrics</a:t>
             </a:r>
             <a:endParaRPr lang="en-IN" dirty="0">
               <a:latin typeface="Barlow ExtraBold" panose="00000900000000000000" pitchFamily="2" charset="0"/>
@@ -12599,7 +12721,7 @@
         <p:spPr>
           <a:xfrm>
             <a:off x="527427" y="2346760"/>
-            <a:ext cx="8428911" cy="461665"/>
+            <a:ext cx="8938665" cy="461665"/>
           </a:xfrm>
           <a:prstGeom prst="rect">
             <a:avLst/>
@@ -12618,6 +12740,16 @@
               </a:rPr>
               <a:t>NDCG@10 - Normalized Discounted Cumulative Gain at rank 10</a:t>
             </a:r>
+            <a:r>
+              <a:rPr lang="en-GB" sz="2400" baseline="30000" dirty="0">
+                <a:latin typeface="Barlow Medium" panose="00000600000000000000" pitchFamily="2" charset="0"/>
+                <a:hlinkClick r:id="rId2" action="ppaction://hlinksldjump"/>
+              </a:rPr>
+              <a:t>[16]</a:t>
+            </a:r>
+            <a:endParaRPr lang="en-GB" sz="2400" baseline="30000" dirty="0">
+              <a:latin typeface="Barlow Medium" panose="00000600000000000000" pitchFamily="2" charset="0"/>
+            </a:endParaRPr>
           </a:p>
         </p:txBody>
       </p:sp>
@@ -12673,7 +12805,7 @@
           <p:nvPr/>
         </p:nvPicPr>
         <p:blipFill>
-          <a:blip r:embed="rId2"/>
+          <a:blip r:embed="rId3"/>
           <a:stretch>
             <a:fillRect/>
           </a:stretch>
@@ -12702,7 +12834,7 @@
 </file>
 
 <file path=ppt/slides/slide17.xml><?xml version="1.0" encoding="utf-8"?>
-<p:sld xmlns:a="http://schemas.openxmlformats.org/drawingml/2006/main" xmlns:r="http://schemas.openxmlformats.org/officeDocument/2006/relationships" xmlns:p="http://schemas.openxmlformats.org/presentationml/2006/main" show="0">
+<p:sld xmlns:a="http://schemas.openxmlformats.org/drawingml/2006/main" xmlns:r="http://schemas.openxmlformats.org/officeDocument/2006/relationships" xmlns:p="http://schemas.openxmlformats.org/presentationml/2006/main">
   <p:cSld>
     <p:spTree>
       <p:nvGrpSpPr>
@@ -12749,7 +12881,7 @@
               <a:rPr lang="en-GB" dirty="0">
                 <a:latin typeface="Barlow ExtraBold" panose="00000900000000000000" pitchFamily="2" charset="0"/>
               </a:rPr>
-              <a:t>Evaluation Metrices</a:t>
+              <a:t>Evaluation Metrics</a:t>
             </a:r>
             <a:endParaRPr lang="en-IN" dirty="0">
               <a:latin typeface="Barlow ExtraBold" panose="00000900000000000000" pitchFamily="2" charset="0"/>
@@ -18911,7 +19043,7 @@
           <p:nvPr>
             <p:extLst>
               <p:ext uri="{D42A27DB-BD31-4B8C-83A1-F6EECF244321}">
-                <p14:modId xmlns:p14="http://schemas.microsoft.com/office/powerpoint/2010/main" val="3728589400"/>
+                <p14:modId xmlns:p14="http://schemas.microsoft.com/office/powerpoint/2010/main" val="3211580055"/>
               </p:ext>
             </p:extLst>
           </p:nvPr>
@@ -19136,6 +19268,16 @@
                     <a:p>
                       <a:pPr algn="ctr"/>
                       <a:r>
+                        <a:rPr lang="en-GB" sz="2000" dirty="0">
+                          <a:solidFill>
+                            <a:srgbClr val="334155"/>
+                          </a:solidFill>
+                          <a:effectLst/>
+                          <a:latin typeface="Barlow" panose="00000500000000000000" pitchFamily="2" charset="0"/>
+                        </a:rPr>
+                        <a:t>A</a:t>
+                      </a:r>
+                      <a:r>
                         <a:rPr lang="en-IN" sz="2000" dirty="0">
                           <a:solidFill>
                             <a:srgbClr val="334155"/>
@@ -19143,7 +19285,7 @@
                           <a:effectLst/>
                           <a:latin typeface="Barlow" panose="00000500000000000000" pitchFamily="2" charset="0"/>
                         </a:rPr>
-                        <a:t>Lion</a:t>
+                        <a:t>damW</a:t>
                       </a:r>
                     </a:p>
                   </a:txBody>
@@ -19176,7 +19318,7 @@
                           <a:effectLst/>
                           <a:latin typeface="Barlow" panose="00000500000000000000" pitchFamily="2" charset="0"/>
                         </a:rPr>
-                        <a:t>Best metrics + efficiency</a:t>
+                        <a:t>Best metrics</a:t>
                       </a:r>
                     </a:p>
                   </a:txBody>
@@ -20301,7 +20443,7 @@
         </p:spPr>
         <p:txBody>
           <a:bodyPr>
-            <a:normAutofit lnSpcReduction="10000"/>
+            <a:normAutofit fontScale="92500" lnSpcReduction="20000"/>
           </a:bodyPr>
           <a:lstStyle/>
           <a:p>
@@ -20396,6 +20538,18 @@
                 <a:latin typeface="Barlow" panose="00000500000000000000" pitchFamily="2" charset="0"/>
               </a:rPr>
               <a:t>I. Loshchilov and F. Hutter, "SGDR: Stochastic Gradient Descent with Warm Restarts," in Proc. International Conference on Learning Representations (ICLR), 2017.</a:t>
+            </a:r>
+          </a:p>
+          <a:p>
+            <a:pPr marL="457200" indent="-457200">
+              <a:buFont typeface="+mj-lt"/>
+              <a:buAutoNum type="arabicPeriod" startAt="9"/>
+            </a:pPr>
+            <a:r>
+              <a:rPr lang="en-GB" sz="2000" dirty="0">
+                <a:latin typeface="Barlow" panose="00000500000000000000" pitchFamily="2" charset="0"/>
+              </a:rPr>
+              <a:t>Y. Wang et al., “A theoretical analysis of NDCG type ranking measures,” arXiv preprint arXiv:1304.6480, Apr. 2013.</a:t>
             </a:r>
             <a:endParaRPr lang="en-IN" sz="2000" dirty="0">
               <a:latin typeface="Barlow" panose="00000500000000000000" pitchFamily="2" charset="0"/>
@@ -20787,7 +20941,17 @@
             </a:r>
             <a:r>
               <a:rPr lang="en-IN" sz="2000" b="1" baseline="30000" dirty="0">
+                <a:solidFill>
+                  <a:srgbClr val="FF0000"/>
+                </a:solidFill>
                 <a:latin typeface="Barlow" panose="00000500000000000000" pitchFamily="2" charset="0"/>
+                <a:hlinkClick r:id="rId3" action="ppaction://hlinksldjump">
+                  <a:extLst>
+                    <a:ext uri="{A12FA001-AC4F-418D-AE19-62706E023703}">
+                      <ahyp:hlinkClr xmlns:ahyp="http://schemas.microsoft.com/office/drawing/2018/hyperlinkcolor" val="tx"/>
+                    </a:ext>
+                  </a:extLst>
+                </a:hlinkClick>
               </a:rPr>
               <a:t>[2] </a:t>
             </a:r>
@@ -20820,7 +20984,17 @@
             </a:r>
             <a:r>
               <a:rPr lang="en-IN" sz="2000" b="1" baseline="30000" dirty="0">
+                <a:solidFill>
+                  <a:srgbClr val="FF0000"/>
+                </a:solidFill>
                 <a:latin typeface="Barlow" panose="00000500000000000000" pitchFamily="2" charset="0"/>
+                <a:hlinkClick r:id="rId3" action="ppaction://hlinksldjump">
+                  <a:extLst>
+                    <a:ext uri="{A12FA001-AC4F-418D-AE19-62706E023703}">
+                      <ahyp:hlinkClr xmlns:ahyp="http://schemas.microsoft.com/office/drawing/2018/hyperlinkcolor" val="tx"/>
+                    </a:ext>
+                  </a:extLst>
+                </a:hlinkClick>
               </a:rPr>
               <a:t>[4] </a:t>
             </a:r>
@@ -21068,27 +21242,49 @@
             </a:r>
             <a:r>
               <a:rPr lang="en-IN" sz="2000" b="1" baseline="30000" dirty="0">
+                <a:solidFill>
+                  <a:srgbClr val="FF0000"/>
+                </a:solidFill>
                 <a:latin typeface="Barlow" panose="00000500000000000000" pitchFamily="2" charset="0"/>
+                <a:hlinkClick r:id="rId3" action="ppaction://hlinksldjump"/>
               </a:rPr>
               <a:t>[4]</a:t>
+            </a:r>
+            <a:r>
+              <a:rPr lang="en-IN" sz="2000" dirty="0">
+                <a:solidFill>
+                  <a:srgbClr val="FF0000"/>
+                </a:solidFill>
+                <a:latin typeface="Barlow" panose="00000500000000000000" pitchFamily="2" charset="0"/>
+                <a:hlinkClick r:id="rId3" action="ppaction://hlinksldjump"/>
+              </a:rPr>
+              <a:t> </a:t>
             </a:r>
             <a:r>
               <a:rPr lang="en-IN" sz="2000" dirty="0">
                 <a:latin typeface="Barlow" panose="00000500000000000000" pitchFamily="2" charset="0"/>
               </a:rPr>
-              <a:t> and AdamW</a:t>
+              <a:t>and AdamW</a:t>
             </a:r>
             <a:r>
               <a:rPr lang="en-IN" sz="2000" b="1" baseline="30000" dirty="0">
                 <a:latin typeface="Barlow" panose="00000500000000000000" pitchFamily="2" charset="0"/>
+                <a:hlinkClick r:id="rId3" action="ppaction://hlinksldjump"/>
               </a:rPr>
               <a:t>[3]</a:t>
             </a:r>
             <a:r>
               <a:rPr lang="en-IN" sz="2000" dirty="0">
                 <a:latin typeface="Barlow" panose="00000500000000000000" pitchFamily="2" charset="0"/>
-              </a:rPr>
-              <a:t> across three transformer architectures.</a:t>
+                <a:hlinkClick r:id="rId3" action="ppaction://hlinksldjump"/>
+              </a:rPr>
+              <a:t> </a:t>
+            </a:r>
+            <a:r>
+              <a:rPr lang="en-IN" sz="2000" dirty="0">
+                <a:latin typeface="Barlow" panose="00000500000000000000" pitchFamily="2" charset="0"/>
+              </a:rPr>
+              <a:t>across three transformer architectures.</a:t>
             </a:r>
           </a:p>
           <a:p>
@@ -21114,6 +21310,7 @@
             <a:r>
               <a:rPr lang="en-IN" sz="2000" b="1" baseline="30000" dirty="0">
                 <a:latin typeface="Barlow" panose="00000500000000000000" pitchFamily="2" charset="0"/>
+                <a:hlinkClick r:id="rId3" action="ppaction://hlinksldjump"/>
               </a:rPr>
               <a:t>[8] </a:t>
             </a:r>
@@ -21126,15 +21323,20 @@
             <a:r>
               <a:rPr lang="en-IN" sz="2000" b="1" baseline="30000" dirty="0">
                 <a:latin typeface="Barlow" panose="00000500000000000000" pitchFamily="2" charset="0"/>
+                <a:hlinkClick r:id="rId4" action="ppaction://hlinksldjump"/>
               </a:rPr>
               <a:t>[9]</a:t>
             </a:r>
             <a:r>
               <a:rPr lang="en-IN" sz="2000" dirty="0">
                 <a:latin typeface="Barlow" panose="00000500000000000000" pitchFamily="2" charset="0"/>
+                <a:hlinkClick r:id="rId4" action="ppaction://hlinksldjump"/>
               </a:rPr>
               <a:t>.</a:t>
             </a:r>
+            <a:endParaRPr lang="en-IN" sz="2000" dirty="0">
+              <a:latin typeface="Barlow" panose="00000500000000000000" pitchFamily="2" charset="0"/>
+            </a:endParaRPr>
           </a:p>
           <a:p>
             <a:pPr marL="342900" indent="-342900" algn="just">
@@ -21476,6 +21678,7 @@
             <a:r>
               <a:rPr lang="en-IN" sz="2000" b="1" baseline="30000" dirty="0">
                 <a:latin typeface="Barlow" panose="00000500000000000000" pitchFamily="2" charset="0"/>
+                <a:hlinkClick r:id="rId2" action="ppaction://hlinksldjump"/>
               </a:rPr>
               <a:t>[2] </a:t>
             </a:r>
@@ -21546,6 +21749,7 @@
             <a:r>
               <a:rPr lang="en-IN" sz="2000" b="1" baseline="30000" dirty="0">
                 <a:latin typeface="Barlow" panose="00000500000000000000" pitchFamily="2" charset="0"/>
+                <a:hlinkClick r:id="rId2" action="ppaction://hlinksldjump"/>
               </a:rPr>
               <a:t>[5]</a:t>
             </a:r>
@@ -21566,6 +21770,7 @@
             <a:r>
               <a:rPr lang="en-IN" sz="2000" b="1" baseline="30000" dirty="0">
                 <a:latin typeface="Barlow" panose="00000500000000000000" pitchFamily="2" charset="0"/>
+                <a:hlinkClick r:id="rId2" action="ppaction://hlinksldjump"/>
               </a:rPr>
               <a:t>[7]</a:t>
             </a:r>
@@ -21586,6 +21791,7 @@
             <a:r>
               <a:rPr lang="en-IN" sz="2000" b="1" baseline="30000" dirty="0">
                 <a:latin typeface="Barlow" panose="00000500000000000000" pitchFamily="2" charset="0"/>
+                <a:hlinkClick r:id="rId2" action="ppaction://hlinksldjump"/>
               </a:rPr>
               <a:t>[6]</a:t>
             </a:r>
@@ -21598,18 +21804,34 @@
             <a:r>
               <a:rPr lang="en-IN" sz="2000" b="1" baseline="30000" dirty="0">
                 <a:latin typeface="Barlow" panose="00000500000000000000" pitchFamily="2" charset="0"/>
+                <a:hlinkClick r:id="rId3" action="ppaction://hlinksldjump"/>
               </a:rPr>
               <a:t>[12]</a:t>
             </a:r>
             <a:r>
               <a:rPr lang="en-IN" sz="2000" dirty="0">
                 <a:latin typeface="Barlow" panose="00000500000000000000" pitchFamily="2" charset="0"/>
-              </a:rPr>
-              <a:t>, Flash Attention</a:t>
+                <a:hlinkClick r:id="rId3" action="ppaction://hlinksldjump"/>
+              </a:rPr>
+              <a:t>,</a:t>
+            </a:r>
+            <a:r>
+              <a:rPr lang="en-IN" sz="2000" dirty="0">
+                <a:latin typeface="Barlow" panose="00000500000000000000" pitchFamily="2" charset="0"/>
+                <a:hlinkClick r:id="rId3" action="ppaction://hlinksldjump"/>
+              </a:rPr>
+              <a:t> </a:t>
+            </a:r>
+            <a:r>
+              <a:rPr lang="en-IN" sz="2000" dirty="0">
+                <a:latin typeface="Barlow" panose="00000500000000000000" pitchFamily="2" charset="0"/>
+              </a:rPr>
+              <a:t>Flash Attention</a:t>
             </a:r>
             <a:r>
               <a:rPr lang="en-IN" sz="2000" b="1" baseline="30000" dirty="0">
                 <a:latin typeface="Barlow" panose="00000500000000000000" pitchFamily="2" charset="0"/>
+                <a:hlinkClick r:id="rId3" action="ppaction://hlinksldjump"/>
               </a:rPr>
               <a:t>[13]</a:t>
             </a:r>
@@ -21713,13 +21935,12 @@
         </p:nvPicPr>
         <p:blipFill>
           <a:blip r:embed="rId3"/>
-          <a:stretch>
-            <a:fillRect/>
-          </a:stretch>
+          <a:srcRect/>
+          <a:stretch/>
         </p:blipFill>
         <p:spPr>
           <a:xfrm>
-            <a:off x="190791" y="0"/>
+            <a:off x="190791" y="158262"/>
             <a:ext cx="8416314" cy="6413632"/>
           </a:xfrm>
         </p:spPr>
@@ -21796,46 +22017,6 @@
               <a:t>Superior Accuracy</a:t>
             </a:r>
             <a:endParaRPr lang="en-IN" sz="2400" dirty="0"/>
-          </a:p>
-        </p:txBody>
-      </p:sp>
-      <p:sp>
-        <p:nvSpPr>
-          <p:cNvPr id="3" name="TextBox 2">
-            <a:extLst>
-              <a:ext uri="{FF2B5EF4-FFF2-40B4-BE49-F238E27FC236}">
-                <a16:creationId xmlns:a16="http://schemas.microsoft.com/office/drawing/2014/main" id="{E24BAE9E-E4A3-0531-F9FE-CE2D7EB0AB6D}"/>
-              </a:ext>
-            </a:extLst>
-          </p:cNvPr>
-          <p:cNvSpPr txBox="1"/>
-          <p:nvPr/>
-        </p:nvSpPr>
-        <p:spPr>
-          <a:xfrm>
-            <a:off x="2370222" y="6476040"/>
-            <a:ext cx="5470358" cy="369332"/>
-          </a:xfrm>
-          <a:prstGeom prst="rect">
-            <a:avLst/>
-          </a:prstGeom>
-          <a:noFill/>
-        </p:spPr>
-        <p:txBody>
-          <a:bodyPr wrap="square" rtlCol="0">
-            <a:spAutoFit/>
-          </a:bodyPr>
-          <a:lstStyle/>
-          <a:p>
-            <a:r>
-              <a:rPr lang="en-GB" dirty="0">
-                <a:latin typeface="Barlow" panose="00000500000000000000" pitchFamily="2" charset="0"/>
-              </a:rPr>
-              <a:t>Image Source: Claude Sonnet 4 (Anthropic, 2025)</a:t>
-            </a:r>
-            <a:endParaRPr lang="en-IN" dirty="0">
-              <a:latin typeface="Barlow" panose="00000500000000000000" pitchFamily="2" charset="0"/>
-            </a:endParaRPr>
           </a:p>
         </p:txBody>
       </p:sp>
@@ -21910,9 +22091,13 @@
             <a:r>
               <a:rPr lang="en-IN" sz="2800" baseline="30000" dirty="0">
                 <a:latin typeface="Barlow SemiBold" panose="00000700000000000000" pitchFamily="2" charset="0"/>
+                <a:hlinkClick r:id="rId2" action="ppaction://hlinksldjump"/>
               </a:rPr>
               <a:t>[3]</a:t>
             </a:r>
+            <a:endParaRPr lang="en-IN" sz="2800" baseline="30000" dirty="0">
+              <a:latin typeface="Barlow SemiBold" panose="00000700000000000000" pitchFamily="2" charset="0"/>
+            </a:endParaRPr>
           </a:p>
         </p:txBody>
       </p:sp>
@@ -22099,6 +22284,7 @@
       <p:pic>
         <p:nvPicPr>
           <p:cNvPr id="7" name="@holatex&#10;\begin{document}&#10;\center&#10;\Large&#10;AdamW Optimizer&#10;\medskip&#10;&#10;\begin{align}&#10;m_t &amp;= \beta_1 m_{t-1} + (1 - \beta_1) g_t \\&#10;v_t &amp;= \beta_2 v_{t-1} + (1 - \beta_2) g_t^2 \\&#10;\hat{m}_t &amp;= \frac{m_t}{1 - \beta_1^t} \\&#10;\hat{v}_t &amp;= \frac{v_t}{1 - \beta_2^t} \\&#10;\theta_t &amp;= \theta_{t-1} - \eta \left( \frac{\hat{m}_t}{\sqrt{\hat{v}_t} + \epsilon} + \lambda \theta_{t-1} \right)&#10;\end{align}&#10;&#10;\end{document}">
+            <a:hlinkClick r:id="rId3" action="ppaction://hlinksldjump"/>
             <a:extLst>
               <a:ext uri="{FF2B5EF4-FFF2-40B4-BE49-F238E27FC236}">
                 <a16:creationId xmlns:a16="http://schemas.microsoft.com/office/drawing/2014/main" id="{9ADE2C19-748C-BEF1-E01F-6CA5DA982809}"/>
@@ -22111,7 +22297,7 @@
           <p:nvPr/>
         </p:nvPicPr>
         <p:blipFill>
-          <a:blip r:embed="rId3"/>
+          <a:blip r:embed="rId4"/>
           <a:stretch>
             <a:fillRect/>
           </a:stretch>
@@ -22141,7 +22327,7 @@
           <p:nvPr/>
         </p:nvPicPr>
         <p:blipFill>
-          <a:blip r:embed="rId4"/>
+          <a:blip r:embed="rId5"/>
           <a:stretch>
             <a:fillRect/>
           </a:stretch>
@@ -22998,7 +23184,7 @@
 
 <file path=ppt/webextensions/taskpanes.xml><?xml version="1.0" encoding="utf-8"?>
 <wetp:taskpanes xmlns:wetp="http://schemas.microsoft.com/office/webextensions/taskpanes/2010/11">
-  <wetp:taskpane dockstate="right" visibility="0" width="438" row="10">
+  <wetp:taskpane dockstate="right" visibility="0" width="578" row="1">
     <wetp:webextensionref xmlns:r="http://schemas.openxmlformats.org/officeDocument/2006/relationships" r:id="rId1"/>
   </wetp:taskpane>
 </wetp:taskpanes>
@@ -23336,18 +23522,18 @@
 <file path=customXml/itemProps1.xml><?xml version="1.0" encoding="utf-8"?>
 <ds:datastoreItem xmlns:ds="http://schemas.openxmlformats.org/officeDocument/2006/customXml" ds:itemID="{BC8413E5-0484-489B-B293-D8720B6027F2}">
   <ds:schemaRefs>
-    <ds:schemaRef ds:uri="16c05727-aa75-4e4a-9b5f-8a80a1165891"/>
-    <ds:schemaRef ds:uri="http://purl.org/dc/terms/"/>
+    <ds:schemaRef ds:uri="http://purl.org/dc/elements/1.1/"/>
     <ds:schemaRef ds:uri="http://schemas.microsoft.com/office/2006/metadata/properties"/>
+    <ds:schemaRef ds:uri="http://schemas.microsoft.com/sharepoint/v3"/>
+    <ds:schemaRef ds:uri="http://schemas.microsoft.com/office/2006/documentManagement/types"/>
+    <ds:schemaRef ds:uri="230e9df3-be65-4c73-a93b-d1236ebd677e"/>
     <ds:schemaRef ds:uri="http://schemas.microsoft.com/office/infopath/2007/PartnerControls"/>
     <ds:schemaRef ds:uri="http://www.w3.org/XML/1998/namespace"/>
-    <ds:schemaRef ds:uri="http://schemas.microsoft.com/office/2006/documentManagement/types"/>
     <ds:schemaRef ds:uri="http://schemas.openxmlformats.org/package/2006/metadata/core-properties"/>
+    <ds:schemaRef ds:uri="http://purl.org/dc/terms/"/>
+    <ds:schemaRef ds:uri="16c05727-aa75-4e4a-9b5f-8a80a1165891"/>
     <ds:schemaRef ds:uri="71af3243-3dd4-4a8d-8c0d-dd76da1f02a5"/>
-    <ds:schemaRef ds:uri="230e9df3-be65-4c73-a93b-d1236ebd677e"/>
-    <ds:schemaRef ds:uri="http://schemas.microsoft.com/sharepoint/v3"/>
     <ds:schemaRef ds:uri="http://purl.org/dc/dcmitype/"/>
-    <ds:schemaRef ds:uri="http://purl.org/dc/elements/1.1/"/>
   </ds:schemaRefs>
 </ds:datastoreItem>
 </file>

</xml_diff>

<commit_message>
Addition in gpu usage
</commit_message>
<xml_diff>
--- a/cross_encoder/thesis/Thesis_presentation.pptx
+++ b/cross_encoder/thesis/Thesis_presentation.pptx
@@ -18628,6 +18628,46 @@
             </a:r>
             <a:endParaRPr lang="en-IN" sz="2000" dirty="0">
               <a:latin typeface="Barlow SemiBold" panose="00000700000000000000" pitchFamily="2" charset="0"/>
+            </a:endParaRPr>
+          </a:p>
+        </p:txBody>
+      </p:sp>
+      <p:sp>
+        <p:nvSpPr>
+          <p:cNvPr id="2" name="TextBox 1">
+            <a:extLst>
+              <a:ext uri="{FF2B5EF4-FFF2-40B4-BE49-F238E27FC236}">
+                <a16:creationId xmlns:a16="http://schemas.microsoft.com/office/drawing/2014/main" id="{CEC592ED-C90F-911E-D6D9-9690BFA70C4C}"/>
+              </a:ext>
+            </a:extLst>
+          </p:cNvPr>
+          <p:cNvSpPr txBox="1"/>
+          <p:nvPr/>
+        </p:nvSpPr>
+        <p:spPr>
+          <a:xfrm>
+            <a:off x="7825153" y="1679336"/>
+            <a:ext cx="3659976" cy="369332"/>
+          </a:xfrm>
+          <a:prstGeom prst="rect">
+            <a:avLst/>
+          </a:prstGeom>
+          <a:noFill/>
+        </p:spPr>
+        <p:txBody>
+          <a:bodyPr wrap="none" rtlCol="0">
+            <a:spAutoFit/>
+          </a:bodyPr>
+          <a:lstStyle/>
+          <a:p>
+            <a:r>
+              <a:rPr lang="en-GB" b="1" dirty="0">
+                <a:latin typeface="Barlow" panose="00000500000000000000" pitchFamily="2" charset="0"/>
+              </a:rPr>
+              <a:t>*All calculations are w.r.t. AdamW</a:t>
+            </a:r>
+            <a:endParaRPr lang="en-IN" b="1" dirty="0">
+              <a:latin typeface="Barlow" panose="00000500000000000000" pitchFamily="2" charset="0"/>
             </a:endParaRPr>
           </a:p>
         </p:txBody>

</xml_diff>

<commit_message>
Update metrics notation in thesis presentation and refresh PowerPoint file
</commit_message>
<xml_diff>
--- a/cross_encoder/thesis/Thesis_presentation.pptx
+++ b/cross_encoder/thesis/Thesis_presentation.pptx
@@ -10411,23 +10411,94 @@
             </a:r>
             <a:r>
               <a:rPr lang="en-IN" sz="2400" b="1" baseline="30000" dirty="0">
+                <a:solidFill>
+                  <a:srgbClr val="FF0000"/>
+                </a:solidFill>
                 <a:latin typeface="Barlow" panose="00000500000000000000" pitchFamily="2" charset="0"/>
-                <a:hlinkClick r:id="rId2" action="ppaction://hlinksldjump"/>
+                <a:hlinkClick r:id="rId2" action="ppaction://hlinksldjump">
+                  <a:extLst>
+                    <a:ext uri="{A12FA001-AC4F-418D-AE19-62706E023703}">
+                      <ahyp:hlinkClr xmlns:ahyp="http://schemas.microsoft.com/office/drawing/2018/hyperlinkcolor" val="tx"/>
+                    </a:ext>
+                  </a:extLst>
+                </a:hlinkClick>
               </a:rPr>
               <a:t>[9]</a:t>
+            </a:r>
+            <a:r>
+              <a:rPr lang="en-IN" sz="2400" dirty="0">
+                <a:solidFill>
+                  <a:srgbClr val="FFC000"/>
+                </a:solidFill>
+                <a:latin typeface="Barlow" panose="00000500000000000000" pitchFamily="2" charset="0"/>
+                <a:hlinkClick r:id="rId2" action="ppaction://hlinksldjump">
+                  <a:extLst>
+                    <a:ext uri="{A12FA001-AC4F-418D-AE19-62706E023703}">
+                      <ahyp:hlinkClr xmlns:ahyp="http://schemas.microsoft.com/office/drawing/2018/hyperlinkcolor" val="tx"/>
+                    </a:ext>
+                  </a:extLst>
+                </a:hlinkClick>
+              </a:rPr>
+              <a:t> </a:t>
             </a:r>
             <a:r>
               <a:rPr lang="en-IN" sz="2400" dirty="0">
                 <a:latin typeface="Barlow" panose="00000500000000000000" pitchFamily="2" charset="0"/>
-                <a:hlinkClick r:id="rId2" action="ppaction://hlinksldjump"/>
-              </a:rPr>
-              <a:t> </a:t>
+              </a:rPr>
+              <a:t>Passage Ranking (~500K query-passage pairs)</a:t>
+            </a:r>
+          </a:p>
+          <a:p>
+            <a:pPr lvl="1"/>
+            <a:r>
+              <a:rPr lang="en-IN" sz="2400" b="1" dirty="0">
+                <a:latin typeface="Barlow" panose="00000500000000000000" pitchFamily="2" charset="0"/>
+              </a:rPr>
+              <a:t>Evaluation:</a:t>
             </a:r>
             <a:r>
               <a:rPr lang="en-IN" sz="2400" dirty="0">
                 <a:latin typeface="Barlow" panose="00000500000000000000" pitchFamily="2" charset="0"/>
               </a:rPr>
-              <a:t>Passage Ranking (~500K query-passage pairs)</a:t>
+              <a:t> TREC DL</a:t>
+            </a:r>
+            <a:r>
+              <a:rPr lang="en-IN" sz="2400" b="1" baseline="30000" dirty="0">
+                <a:solidFill>
+                  <a:srgbClr val="FF0000"/>
+                </a:solidFill>
+                <a:latin typeface="Barlow" panose="00000500000000000000" pitchFamily="2" charset="0"/>
+                <a:hlinkClick r:id="rId3" action="ppaction://hlinksldjump">
+                  <a:extLst>
+                    <a:ext uri="{A12FA001-AC4F-418D-AE19-62706E023703}">
+                      <ahyp:hlinkClr xmlns:ahyp="http://schemas.microsoft.com/office/drawing/2018/hyperlinkcolor" val="tx"/>
+                    </a:ext>
+                  </a:extLst>
+                </a:hlinkClick>
+              </a:rPr>
+              <a:t>[8]</a:t>
+            </a:r>
+            <a:r>
+              <a:rPr lang="en-IN" sz="2400" dirty="0">
+                <a:solidFill>
+                  <a:srgbClr val="FFC000"/>
+                </a:solidFill>
+                <a:latin typeface="Barlow" panose="00000500000000000000" pitchFamily="2" charset="0"/>
+                <a:hlinkClick r:id="rId3" action="ppaction://hlinksldjump">
+                  <a:extLst>
+                    <a:ext uri="{A12FA001-AC4F-418D-AE19-62706E023703}">
+                      <ahyp:hlinkClr xmlns:ahyp="http://schemas.microsoft.com/office/drawing/2018/hyperlinkcolor" val="tx"/>
+                    </a:ext>
+                  </a:extLst>
+                </a:hlinkClick>
+              </a:rPr>
+              <a:t> </a:t>
+            </a:r>
+            <a:r>
+              <a:rPr lang="en-IN" sz="2400" dirty="0">
+                <a:latin typeface="Barlow" panose="00000500000000000000" pitchFamily="2" charset="0"/>
+              </a:rPr>
+              <a:t>2019 (43 queries with comprehensive relevance judgments)</a:t>
             </a:r>
           </a:p>
           <a:p>
@@ -10436,48 +10507,35 @@
               <a:rPr lang="en-IN" sz="2400" b="1" dirty="0">
                 <a:latin typeface="Barlow" panose="00000500000000000000" pitchFamily="2" charset="0"/>
               </a:rPr>
-              <a:t>Evaluation:</a:t>
+              <a:t>Metrics:</a:t>
             </a:r>
             <a:r>
               <a:rPr lang="en-IN" sz="2400" dirty="0">
                 <a:latin typeface="Barlow" panose="00000500000000000000" pitchFamily="2" charset="0"/>
               </a:rPr>
-              <a:t> TREC DL</a:t>
-            </a:r>
-            <a:r>
-              <a:rPr lang="en-IN" sz="2400" b="1" baseline="30000" dirty="0">
+              <a:t> NDCG@10</a:t>
+            </a:r>
+            <a:r>
+              <a:rPr lang="en-IN" sz="2400" baseline="30000" dirty="0">
+                <a:solidFill>
+                  <a:srgbClr val="FF0000"/>
+                </a:solidFill>
                 <a:latin typeface="Barlow" panose="00000500000000000000" pitchFamily="2" charset="0"/>
-                <a:hlinkClick r:id="rId3" action="ppaction://hlinksldjump"/>
-              </a:rPr>
-              <a:t>[8]</a:t>
+                <a:hlinkClick r:id="rId2" action="ppaction://hlinksldjump">
+                  <a:extLst>
+                    <a:ext uri="{A12FA001-AC4F-418D-AE19-62706E023703}">
+                      <ahyp:hlinkClr xmlns:ahyp="http://schemas.microsoft.com/office/drawing/2018/hyperlinkcolor" val="tx"/>
+                    </a:ext>
+                  </a:extLst>
+                </a:hlinkClick>
+              </a:rPr>
+              <a:t>[16] </a:t>
             </a:r>
             <a:r>
               <a:rPr lang="en-IN" sz="2400" dirty="0">
                 <a:latin typeface="Barlow" panose="00000500000000000000" pitchFamily="2" charset="0"/>
-                <a:hlinkClick r:id="rId3" action="ppaction://hlinksldjump"/>
-              </a:rPr>
-              <a:t> </a:t>
-            </a:r>
-            <a:r>
-              <a:rPr lang="en-IN" sz="2400" dirty="0">
-                <a:latin typeface="Barlow" panose="00000500000000000000" pitchFamily="2" charset="0"/>
-              </a:rPr>
-              <a:t>2019 (43 queries with comprehensive relevance judgments)</a:t>
-            </a:r>
-          </a:p>
-          <a:p>
-            <a:pPr lvl="1"/>
-            <a:r>
-              <a:rPr lang="en-IN" sz="2400" b="1" dirty="0">
-                <a:latin typeface="Barlow" panose="00000500000000000000" pitchFamily="2" charset="0"/>
-              </a:rPr>
-              <a:t>Metrics:</a:t>
-            </a:r>
-            <a:r>
-              <a:rPr lang="en-IN" sz="2400" dirty="0">
-                <a:latin typeface="Barlow" panose="00000500000000000000" pitchFamily="2" charset="0"/>
-              </a:rPr>
-              <a:t> NDCG@10, MAP, MRR@10, Recall@10, R-Precision, P@10</a:t>
+              </a:rPr>
+              <a:t>, MAP, MRR@10, Recall@10, R-Precision, P@10</a:t>
             </a:r>
           </a:p>
           <a:p>
@@ -10507,12 +10565,24 @@
             </a:r>
             <a:r>
               <a:rPr lang="en-IN" sz="2400" b="1" baseline="30000" dirty="0">
+                <a:solidFill>
+                  <a:srgbClr val="FF0000"/>
+                </a:solidFill>
                 <a:latin typeface="Barlow" panose="00000500000000000000" pitchFamily="2" charset="0"/>
-                <a:hlinkClick r:id="rId2" action="ppaction://hlinksldjump"/>
+                <a:hlinkClick r:id="rId2" action="ppaction://hlinksldjump">
+                  <a:extLst>
+                    <a:ext uri="{A12FA001-AC4F-418D-AE19-62706E023703}">
+                      <ahyp:hlinkClr xmlns:ahyp="http://schemas.microsoft.com/office/drawing/2018/hyperlinkcolor" val="tx"/>
+                    </a:ext>
+                  </a:extLst>
+                </a:hlinkClick>
               </a:rPr>
               <a:t>[10]</a:t>
             </a:r>
             <a:endParaRPr lang="en-IN" sz="2400" b="1" baseline="30000" dirty="0">
+              <a:solidFill>
+                <a:srgbClr val="FF0000"/>
+              </a:solidFill>
               <a:latin typeface="Barlow" panose="00000500000000000000" pitchFamily="2" charset="0"/>
             </a:endParaRPr>
           </a:p>
@@ -10547,12 +10617,24 @@
             </a:r>
             <a:r>
               <a:rPr lang="en-IN" sz="2400" b="1" baseline="30000" dirty="0">
+                <a:solidFill>
+                  <a:srgbClr val="FF0000"/>
+                </a:solidFill>
                 <a:latin typeface="Barlow" panose="00000500000000000000" pitchFamily="2" charset="0"/>
-                <a:hlinkClick r:id="rId2" action="ppaction://hlinksldjump"/>
+                <a:hlinkClick r:id="rId2" action="ppaction://hlinksldjump">
+                  <a:extLst>
+                    <a:ext uri="{A12FA001-AC4F-418D-AE19-62706E023703}">
+                      <ahyp:hlinkClr xmlns:ahyp="http://schemas.microsoft.com/office/drawing/2018/hyperlinkcolor" val="tx"/>
+                    </a:ext>
+                  </a:extLst>
+                </a:hlinkClick>
               </a:rPr>
               <a:t>[11]</a:t>
             </a:r>
             <a:endParaRPr lang="en-IN" sz="2400" b="1" baseline="30000" dirty="0">
+              <a:solidFill>
+                <a:srgbClr val="FF0000"/>
+              </a:solidFill>
               <a:latin typeface="Barlow" panose="00000500000000000000" pitchFamily="2" charset="0"/>
             </a:endParaRPr>
           </a:p>
@@ -10709,7 +10791,7 @@
           <p:nvPr>
             <p:extLst>
               <p:ext uri="{D42A27DB-BD31-4B8C-83A1-F6EECF244321}">
-                <p14:modId xmlns:p14="http://schemas.microsoft.com/office/powerpoint/2010/main" val="4000075422"/>
+                <p14:modId xmlns:p14="http://schemas.microsoft.com/office/powerpoint/2010/main" val="589728642"/>
               </p:ext>
             </p:extLst>
           </p:nvPr>
@@ -10925,13 +11007,25 @@
                       </a:r>
                       <a:r>
                         <a:rPr lang="en-IN" sz="2000" b="1" baseline="30000" dirty="0">
+                          <a:solidFill>
+                            <a:srgbClr val="FF0000"/>
+                          </a:solidFill>
                           <a:effectLst/>
                           <a:latin typeface="Barlow" panose="00000500000000000000" pitchFamily="2" charset="0"/>
-                          <a:hlinkClick r:id="rId3" action="ppaction://hlinksldjump"/>
+                          <a:hlinkClick r:id="rId3" action="ppaction://hlinksldjump">
+                            <a:extLst>
+                              <a:ext uri="{A12FA001-AC4F-418D-AE19-62706E023703}">
+                                <ahyp:hlinkClr xmlns:ahyp="http://schemas.microsoft.com/office/drawing/2018/hyperlinkcolor" val="tx"/>
+                              </a:ext>
+                            </a:extLst>
+                          </a:hlinkClick>
                         </a:rPr>
                         <a:t>[5]</a:t>
                       </a:r>
                       <a:endParaRPr lang="en-IN" sz="2000" baseline="30000" dirty="0">
+                        <a:solidFill>
+                          <a:srgbClr val="FF0000"/>
+                        </a:solidFill>
                         <a:effectLst/>
                         <a:latin typeface="Barlow" panose="00000500000000000000" pitchFamily="2" charset="0"/>
                       </a:endParaRPr>
@@ -11124,13 +11218,25 @@
                       </a:r>
                       <a:r>
                         <a:rPr lang="en-IN" sz="2000" b="1" baseline="30000" dirty="0">
+                          <a:solidFill>
+                            <a:srgbClr val="FF0000"/>
+                          </a:solidFill>
                           <a:effectLst/>
                           <a:latin typeface="Barlow" panose="00000500000000000000" pitchFamily="2" charset="0"/>
-                          <a:hlinkClick r:id="rId3" action="ppaction://hlinksldjump"/>
+                          <a:hlinkClick r:id="rId3" action="ppaction://hlinksldjump">
+                            <a:extLst>
+                              <a:ext uri="{A12FA001-AC4F-418D-AE19-62706E023703}">
+                                <ahyp:hlinkClr xmlns:ahyp="http://schemas.microsoft.com/office/drawing/2018/hyperlinkcolor" val="tx"/>
+                              </a:ext>
+                            </a:extLst>
+                          </a:hlinkClick>
                         </a:rPr>
                         <a:t>[7]</a:t>
                       </a:r>
                       <a:endParaRPr lang="en-IN" sz="2000" baseline="30000" dirty="0">
+                        <a:solidFill>
+                          <a:srgbClr val="FF0000"/>
+                        </a:solidFill>
                         <a:effectLst/>
                         <a:latin typeface="Barlow" panose="00000500000000000000" pitchFamily="2" charset="0"/>
                       </a:endParaRPr>
@@ -11323,13 +11429,25 @@
                       </a:r>
                       <a:r>
                         <a:rPr lang="en-IN" sz="2000" b="1" baseline="30000" dirty="0">
+                          <a:solidFill>
+                            <a:srgbClr val="FF0000"/>
+                          </a:solidFill>
                           <a:effectLst/>
                           <a:latin typeface="Barlow" panose="00000500000000000000" pitchFamily="2" charset="0"/>
-                          <a:hlinkClick r:id="rId3" action="ppaction://hlinksldjump"/>
+                          <a:hlinkClick r:id="rId3" action="ppaction://hlinksldjump">
+                            <a:extLst>
+                              <a:ext uri="{A12FA001-AC4F-418D-AE19-62706E023703}">
+                                <ahyp:hlinkClr xmlns:ahyp="http://schemas.microsoft.com/office/drawing/2018/hyperlinkcolor" val="tx"/>
+                              </a:ext>
+                            </a:extLst>
+                          </a:hlinkClick>
                         </a:rPr>
                         <a:t>[6]</a:t>
                       </a:r>
                       <a:endParaRPr lang="en-IN" sz="2000" baseline="30000" dirty="0">
+                        <a:solidFill>
+                          <a:srgbClr val="FF0000"/>
+                        </a:solidFill>
                         <a:effectLst/>
                         <a:latin typeface="Barlow" panose="00000500000000000000" pitchFamily="2" charset="0"/>
                       </a:endParaRPr>
@@ -11470,9 +11588,18 @@
                       </a:r>
                       <a:r>
                         <a:rPr lang="en-IN" sz="2000" baseline="30000" dirty="0">
+                          <a:solidFill>
+                            <a:srgbClr val="FF0000"/>
+                          </a:solidFill>
                           <a:effectLst/>
                           <a:latin typeface="Barlow" panose="00000500000000000000" pitchFamily="2" charset="0"/>
-                          <a:hlinkClick r:id="rId4" action="ppaction://hlinksldjump"/>
+                          <a:hlinkClick r:id="rId4" action="ppaction://hlinksldjump">
+                            <a:extLst>
+                              <a:ext uri="{A12FA001-AC4F-418D-AE19-62706E023703}">
+                                <ahyp:hlinkClr xmlns:ahyp="http://schemas.microsoft.com/office/drawing/2018/hyperlinkcolor" val="tx"/>
+                              </a:ext>
+                            </a:extLst>
+                          </a:hlinkClick>
                         </a:rPr>
                         <a:t>[12]</a:t>
                       </a:r>
@@ -11492,9 +11619,18 @@
                       </a:r>
                       <a:r>
                         <a:rPr lang="en-IN" sz="2000" baseline="30000" dirty="0">
+                          <a:solidFill>
+                            <a:srgbClr val="FF0000"/>
+                          </a:solidFill>
                           <a:effectLst/>
                           <a:latin typeface="Barlow" panose="00000500000000000000" pitchFamily="2" charset="0"/>
-                          <a:hlinkClick r:id="rId4" action="ppaction://hlinksldjump"/>
+                          <a:hlinkClick r:id="rId4" action="ppaction://hlinksldjump">
+                            <a:extLst>
+                              <a:ext uri="{A12FA001-AC4F-418D-AE19-62706E023703}">
+                                <ahyp:hlinkClr xmlns:ahyp="http://schemas.microsoft.com/office/drawing/2018/hyperlinkcolor" val="tx"/>
+                              </a:ext>
+                            </a:extLst>
+                          </a:hlinkClick>
                         </a:rPr>
                         <a:t>[13]</a:t>
                       </a:r>
@@ -11507,13 +11643,25 @@
                       </a:r>
                       <a:r>
                         <a:rPr lang="en-IN" sz="2000" baseline="30000" dirty="0">
+                          <a:solidFill>
+                            <a:srgbClr val="FF0000"/>
+                          </a:solidFill>
                           <a:effectLst/>
                           <a:latin typeface="Barlow" panose="00000500000000000000" pitchFamily="2" charset="0"/>
-                          <a:hlinkClick r:id="rId4" action="ppaction://hlinksldjump"/>
+                          <a:hlinkClick r:id="rId4" action="ppaction://hlinksldjump">
+                            <a:extLst>
+                              <a:ext uri="{A12FA001-AC4F-418D-AE19-62706E023703}">
+                                <ahyp:hlinkClr xmlns:ahyp="http://schemas.microsoft.com/office/drawing/2018/hyperlinkcolor" val="tx"/>
+                              </a:ext>
+                            </a:extLst>
+                          </a:hlinkClick>
                         </a:rPr>
                         <a:t>[14]</a:t>
                       </a:r>
                       <a:endParaRPr lang="en-IN" sz="2000" baseline="30000" dirty="0">
+                        <a:solidFill>
+                          <a:srgbClr val="FF0000"/>
+                        </a:solidFill>
                         <a:effectLst/>
                         <a:latin typeface="Barlow" panose="00000500000000000000" pitchFamily="2" charset="0"/>
                       </a:endParaRPr>
@@ -11838,7 +11986,7 @@
           <p:nvPr>
             <p:extLst>
               <p:ext uri="{D42A27DB-BD31-4B8C-83A1-F6EECF244321}">
-                <p14:modId xmlns:p14="http://schemas.microsoft.com/office/powerpoint/2010/main" val="4110281572"/>
+                <p14:modId xmlns:p14="http://schemas.microsoft.com/office/powerpoint/2010/main" val="1270312117"/>
               </p:ext>
             </p:extLst>
           </p:nvPr>
@@ -12045,11 +12193,17 @@
                       <a:r>
                         <a:rPr lang="en-IN" sz="2000" baseline="30000" dirty="0">
                           <a:solidFill>
-                            <a:schemeClr val="tx1"/>
+                            <a:srgbClr val="FF0000"/>
                           </a:solidFill>
                           <a:effectLst/>
                           <a:latin typeface="Barlow" panose="00000500000000000000" pitchFamily="2" charset="0"/>
-                          <a:hlinkClick r:id="rId2" action="ppaction://hlinksldjump"/>
+                          <a:hlinkClick r:id="rId2" action="ppaction://hlinksldjump">
+                            <a:extLst>
+                              <a:ext uri="{A12FA001-AC4F-418D-AE19-62706E023703}">
+                                <ahyp:hlinkClr xmlns:ahyp="http://schemas.microsoft.com/office/drawing/2018/hyperlinkcolor" val="tx"/>
+                              </a:ext>
+                            </a:extLst>
+                          </a:hlinkClick>
                         </a:rPr>
                         <a:t>[6]</a:t>
                       </a:r>
@@ -12597,14 +12751,38 @@
                         <a:t>Cosine Annealing</a:t>
                       </a:r>
                       <a:r>
-                        <a:rPr lang="en-IN" sz="2000" b="1" baseline="30000" dirty="0">
+                        <a:rPr lang="en-IN" sz="2000" b="0" baseline="30000" dirty="0">
                           <a:solidFill>
-                            <a:schemeClr val="tx1"/>
+                            <a:srgbClr val="FF0000"/>
                           </a:solidFill>
                           <a:effectLst/>
                           <a:latin typeface="Barlow" panose="00000500000000000000" pitchFamily="2" charset="0"/>
+                          <a:hlinkClick r:id="rId3" action="ppaction://hlinksldjump">
+                            <a:extLst>
+                              <a:ext uri="{A12FA001-AC4F-418D-AE19-62706E023703}">
+                                <ahyp:hlinkClr xmlns:ahyp="http://schemas.microsoft.com/office/drawing/2018/hyperlinkcolor" val="tx"/>
+                              </a:ext>
+                            </a:extLst>
+                          </a:hlinkClick>
                         </a:rPr>
                         <a:t>[15]</a:t>
+                      </a:r>
+                      <a:r>
+                        <a:rPr lang="en-IN" sz="2000" b="0" dirty="0">
+                          <a:solidFill>
+                            <a:srgbClr val="FF0000"/>
+                          </a:solidFill>
+                          <a:effectLst/>
+                          <a:latin typeface="Barlow" panose="00000500000000000000" pitchFamily="2" charset="0"/>
+                          <a:hlinkClick r:id="rId3" action="ppaction://hlinksldjump">
+                            <a:extLst>
+                              <a:ext uri="{A12FA001-AC4F-418D-AE19-62706E023703}">
+                                <ahyp:hlinkClr xmlns:ahyp="http://schemas.microsoft.com/office/drawing/2018/hyperlinkcolor" val="tx"/>
+                              </a:ext>
+                            </a:extLst>
+                          </a:hlinkClick>
+                        </a:rPr>
+                        <a:t> </a:t>
                       </a:r>
                       <a:r>
                         <a:rPr lang="en-IN" sz="2000" dirty="0">
@@ -12614,7 +12792,7 @@
                           <a:effectLst/>
                           <a:latin typeface="Barlow" panose="00000500000000000000" pitchFamily="2" charset="0"/>
                         </a:rPr>
-                        <a:t> (ModernBERT)</a:t>
+                        <a:t>(ModernBERT)</a:t>
                       </a:r>
                     </a:p>
                   </a:txBody>
@@ -12742,12 +12920,24 @@
             </a:r>
             <a:r>
               <a:rPr lang="en-GB" sz="2400" baseline="30000" dirty="0">
+                <a:solidFill>
+                  <a:srgbClr val="FF0000"/>
+                </a:solidFill>
                 <a:latin typeface="Barlow Medium" panose="00000600000000000000" pitchFamily="2" charset="0"/>
-                <a:hlinkClick r:id="rId2" action="ppaction://hlinksldjump"/>
+                <a:hlinkClick r:id="rId2" action="ppaction://hlinksldjump">
+                  <a:extLst>
+                    <a:ext uri="{A12FA001-AC4F-418D-AE19-62706E023703}">
+                      <ahyp:hlinkClr xmlns:ahyp="http://schemas.microsoft.com/office/drawing/2018/hyperlinkcolor" val="tx"/>
+                    </a:ext>
+                  </a:extLst>
+                </a:hlinkClick>
               </a:rPr>
               <a:t>[16]</a:t>
             </a:r>
             <a:endParaRPr lang="en-GB" sz="2400" baseline="30000" dirty="0">
+              <a:solidFill>
+                <a:srgbClr val="FF0000"/>
+              </a:solidFill>
               <a:latin typeface="Barlow Medium" panose="00000600000000000000" pitchFamily="2" charset="0"/>
             </a:endParaRPr>
           </a:p>
@@ -21286,7 +21476,13 @@
                   <a:srgbClr val="FF0000"/>
                 </a:solidFill>
                 <a:latin typeface="Barlow" panose="00000500000000000000" pitchFamily="2" charset="0"/>
-                <a:hlinkClick r:id="rId3" action="ppaction://hlinksldjump"/>
+                <a:hlinkClick r:id="rId3" action="ppaction://hlinksldjump">
+                  <a:extLst>
+                    <a:ext uri="{A12FA001-AC4F-418D-AE19-62706E023703}">
+                      <ahyp:hlinkClr xmlns:ahyp="http://schemas.microsoft.com/office/drawing/2018/hyperlinkcolor" val="tx"/>
+                    </a:ext>
+                  </a:extLst>
+                </a:hlinkClick>
               </a:rPr>
               <a:t>[4]</a:t>
             </a:r>
@@ -21308,15 +21504,33 @@
             </a:r>
             <a:r>
               <a:rPr lang="en-IN" sz="2000" b="1" baseline="30000" dirty="0">
+                <a:solidFill>
+                  <a:srgbClr val="FF0000"/>
+                </a:solidFill>
                 <a:latin typeface="Barlow" panose="00000500000000000000" pitchFamily="2" charset="0"/>
-                <a:hlinkClick r:id="rId3" action="ppaction://hlinksldjump"/>
+                <a:hlinkClick r:id="rId3" action="ppaction://hlinksldjump">
+                  <a:extLst>
+                    <a:ext uri="{A12FA001-AC4F-418D-AE19-62706E023703}">
+                      <ahyp:hlinkClr xmlns:ahyp="http://schemas.microsoft.com/office/drawing/2018/hyperlinkcolor" val="tx"/>
+                    </a:ext>
+                  </a:extLst>
+                </a:hlinkClick>
               </a:rPr>
               <a:t>[3]</a:t>
             </a:r>
             <a:r>
               <a:rPr lang="en-IN" sz="2000" dirty="0">
+                <a:solidFill>
+                  <a:srgbClr val="FFC000"/>
+                </a:solidFill>
                 <a:latin typeface="Barlow" panose="00000500000000000000" pitchFamily="2" charset="0"/>
-                <a:hlinkClick r:id="rId3" action="ppaction://hlinksldjump"/>
+                <a:hlinkClick r:id="rId3" action="ppaction://hlinksldjump">
+                  <a:extLst>
+                    <a:ext uri="{A12FA001-AC4F-418D-AE19-62706E023703}">
+                      <ahyp:hlinkClr xmlns:ahyp="http://schemas.microsoft.com/office/drawing/2018/hyperlinkcolor" val="tx"/>
+                    </a:ext>
+                  </a:extLst>
+                </a:hlinkClick>
               </a:rPr>
               <a:t> </a:t>
             </a:r>
@@ -21349,8 +21563,17 @@
             </a:r>
             <a:r>
               <a:rPr lang="en-IN" sz="2000" b="1" baseline="30000" dirty="0">
+                <a:solidFill>
+                  <a:srgbClr val="FF0000"/>
+                </a:solidFill>
                 <a:latin typeface="Barlow" panose="00000500000000000000" pitchFamily="2" charset="0"/>
-                <a:hlinkClick r:id="rId3" action="ppaction://hlinksldjump"/>
+                <a:hlinkClick r:id="rId3" action="ppaction://hlinksldjump">
+                  <a:extLst>
+                    <a:ext uri="{A12FA001-AC4F-418D-AE19-62706E023703}">
+                      <ahyp:hlinkClr xmlns:ahyp="http://schemas.microsoft.com/office/drawing/2018/hyperlinkcolor" val="tx"/>
+                    </a:ext>
+                  </a:extLst>
+                </a:hlinkClick>
               </a:rPr>
               <a:t>[8] </a:t>
             </a:r>
@@ -21362,15 +21585,33 @@
             </a:r>
             <a:r>
               <a:rPr lang="en-IN" sz="2000" b="1" baseline="30000" dirty="0">
+                <a:solidFill>
+                  <a:srgbClr val="FF0000"/>
+                </a:solidFill>
                 <a:latin typeface="Barlow" panose="00000500000000000000" pitchFamily="2" charset="0"/>
-                <a:hlinkClick r:id="rId4" action="ppaction://hlinksldjump"/>
+                <a:hlinkClick r:id="rId4" action="ppaction://hlinksldjump">
+                  <a:extLst>
+                    <a:ext uri="{A12FA001-AC4F-418D-AE19-62706E023703}">
+                      <ahyp:hlinkClr xmlns:ahyp="http://schemas.microsoft.com/office/drawing/2018/hyperlinkcolor" val="tx"/>
+                    </a:ext>
+                  </a:extLst>
+                </a:hlinkClick>
               </a:rPr>
               <a:t>[9]</a:t>
             </a:r>
             <a:r>
               <a:rPr lang="en-IN" sz="2000" dirty="0">
+                <a:solidFill>
+                  <a:srgbClr val="FFC000"/>
+                </a:solidFill>
                 <a:latin typeface="Barlow" panose="00000500000000000000" pitchFamily="2" charset="0"/>
-                <a:hlinkClick r:id="rId4" action="ppaction://hlinksldjump"/>
+                <a:hlinkClick r:id="rId4" action="ppaction://hlinksldjump">
+                  <a:extLst>
+                    <a:ext uri="{A12FA001-AC4F-418D-AE19-62706E023703}">
+                      <ahyp:hlinkClr xmlns:ahyp="http://schemas.microsoft.com/office/drawing/2018/hyperlinkcolor" val="tx"/>
+                    </a:ext>
+                  </a:extLst>
+                </a:hlinkClick>
               </a:rPr>
               <a:t>.</a:t>
             </a:r>
@@ -21717,8 +21958,17 @@
             </a:r>
             <a:r>
               <a:rPr lang="en-IN" sz="2000" b="1" baseline="30000" dirty="0">
+                <a:solidFill>
+                  <a:srgbClr val="FF0000"/>
+                </a:solidFill>
                 <a:latin typeface="Barlow" panose="00000500000000000000" pitchFamily="2" charset="0"/>
-                <a:hlinkClick r:id="rId2" action="ppaction://hlinksldjump"/>
+                <a:hlinkClick r:id="rId2" action="ppaction://hlinksldjump">
+                  <a:extLst>
+                    <a:ext uri="{A12FA001-AC4F-418D-AE19-62706E023703}">
+                      <ahyp:hlinkClr xmlns:ahyp="http://schemas.microsoft.com/office/drawing/2018/hyperlinkcolor" val="tx"/>
+                    </a:ext>
+                  </a:extLst>
+                </a:hlinkClick>
               </a:rPr>
               <a:t>[2] </a:t>
             </a:r>
@@ -21788,8 +22038,17 @@
             </a:r>
             <a:r>
               <a:rPr lang="en-IN" sz="2000" b="1" baseline="30000" dirty="0">
+                <a:solidFill>
+                  <a:srgbClr val="FF0000"/>
+                </a:solidFill>
                 <a:latin typeface="Barlow" panose="00000500000000000000" pitchFamily="2" charset="0"/>
-                <a:hlinkClick r:id="rId2" action="ppaction://hlinksldjump"/>
+                <a:hlinkClick r:id="rId2" action="ppaction://hlinksldjump">
+                  <a:extLst>
+                    <a:ext uri="{A12FA001-AC4F-418D-AE19-62706E023703}">
+                      <ahyp:hlinkClr xmlns:ahyp="http://schemas.microsoft.com/office/drawing/2018/hyperlinkcolor" val="tx"/>
+                    </a:ext>
+                  </a:extLst>
+                </a:hlinkClick>
               </a:rPr>
               <a:t>[5]</a:t>
             </a:r>
@@ -21809,8 +22068,17 @@
             </a:r>
             <a:r>
               <a:rPr lang="en-IN" sz="2000" b="1" baseline="30000" dirty="0">
+                <a:solidFill>
+                  <a:srgbClr val="FF0000"/>
+                </a:solidFill>
                 <a:latin typeface="Barlow" panose="00000500000000000000" pitchFamily="2" charset="0"/>
-                <a:hlinkClick r:id="rId2" action="ppaction://hlinksldjump"/>
+                <a:hlinkClick r:id="rId2" action="ppaction://hlinksldjump">
+                  <a:extLst>
+                    <a:ext uri="{A12FA001-AC4F-418D-AE19-62706E023703}">
+                      <ahyp:hlinkClr xmlns:ahyp="http://schemas.microsoft.com/office/drawing/2018/hyperlinkcolor" val="tx"/>
+                    </a:ext>
+                  </a:extLst>
+                </a:hlinkClick>
               </a:rPr>
               <a:t>[7]</a:t>
             </a:r>
@@ -21830,8 +22098,17 @@
             </a:r>
             <a:r>
               <a:rPr lang="en-IN" sz="2000" b="1" baseline="30000" dirty="0">
+                <a:solidFill>
+                  <a:srgbClr val="FF0000"/>
+                </a:solidFill>
                 <a:latin typeface="Barlow" panose="00000500000000000000" pitchFamily="2" charset="0"/>
-                <a:hlinkClick r:id="rId2" action="ppaction://hlinksldjump"/>
+                <a:hlinkClick r:id="rId2" action="ppaction://hlinksldjump">
+                  <a:extLst>
+                    <a:ext uri="{A12FA001-AC4F-418D-AE19-62706E023703}">
+                      <ahyp:hlinkClr xmlns:ahyp="http://schemas.microsoft.com/office/drawing/2018/hyperlinkcolor" val="tx"/>
+                    </a:ext>
+                  </a:extLst>
+                </a:hlinkClick>
               </a:rPr>
               <a:t>[6]</a:t>
             </a:r>
@@ -21843,35 +22120,71 @@
             </a:r>
             <a:r>
               <a:rPr lang="en-IN" sz="2000" b="1" baseline="30000" dirty="0">
+                <a:solidFill>
+                  <a:srgbClr val="FF0000"/>
+                </a:solidFill>
                 <a:latin typeface="Barlow" panose="00000500000000000000" pitchFamily="2" charset="0"/>
-                <a:hlinkClick r:id="rId3" action="ppaction://hlinksldjump"/>
+                <a:hlinkClick r:id="rId3" action="ppaction://hlinksldjump">
+                  <a:extLst>
+                    <a:ext uri="{A12FA001-AC4F-418D-AE19-62706E023703}">
+                      <ahyp:hlinkClr xmlns:ahyp="http://schemas.microsoft.com/office/drawing/2018/hyperlinkcolor" val="tx"/>
+                    </a:ext>
+                  </a:extLst>
+                </a:hlinkClick>
               </a:rPr>
               <a:t>[12]</a:t>
+            </a:r>
+            <a:r>
+              <a:rPr lang="en-IN" sz="2000" dirty="0">
+                <a:solidFill>
+                  <a:srgbClr val="FF0000"/>
+                </a:solidFill>
+                <a:latin typeface="Barlow" panose="00000500000000000000" pitchFamily="2" charset="0"/>
+                <a:hlinkClick r:id="rId3" action="ppaction://hlinksldjump">
+                  <a:extLst>
+                    <a:ext uri="{A12FA001-AC4F-418D-AE19-62706E023703}">
+                      <ahyp:hlinkClr xmlns:ahyp="http://schemas.microsoft.com/office/drawing/2018/hyperlinkcolor" val="tx"/>
+                    </a:ext>
+                  </a:extLst>
+                </a:hlinkClick>
+              </a:rPr>
+              <a:t>,</a:t>
+            </a:r>
+            <a:r>
+              <a:rPr lang="en-IN" sz="2000" dirty="0">
+                <a:solidFill>
+                  <a:srgbClr val="FF0000"/>
+                </a:solidFill>
+                <a:latin typeface="Barlow" panose="00000500000000000000" pitchFamily="2" charset="0"/>
+                <a:hlinkClick r:id="rId3" action="ppaction://hlinksldjump">
+                  <a:extLst>
+                    <a:ext uri="{A12FA001-AC4F-418D-AE19-62706E023703}">
+                      <ahyp:hlinkClr xmlns:ahyp="http://schemas.microsoft.com/office/drawing/2018/hyperlinkcolor" val="tx"/>
+                    </a:ext>
+                  </a:extLst>
+                </a:hlinkClick>
+              </a:rPr>
+              <a:t> </a:t>
             </a:r>
             <a:r>
               <a:rPr lang="en-IN" sz="2000" dirty="0">
                 <a:latin typeface="Barlow" panose="00000500000000000000" pitchFamily="2" charset="0"/>
-                <a:hlinkClick r:id="rId3" action="ppaction://hlinksldjump"/>
-              </a:rPr>
-              <a:t>,</a:t>
-            </a:r>
-            <a:r>
-              <a:rPr lang="en-IN" sz="2000" dirty="0">
+              </a:rPr>
+              <a:t>Flash Attention</a:t>
+            </a:r>
+            <a:r>
+              <a:rPr lang="en-IN" sz="2000" b="1" baseline="30000" dirty="0">
+                <a:solidFill>
+                  <a:srgbClr val="FF0000"/>
+                </a:solidFill>
                 <a:latin typeface="Barlow" panose="00000500000000000000" pitchFamily="2" charset="0"/>
-                <a:hlinkClick r:id="rId3" action="ppaction://hlinksldjump"/>
-              </a:rPr>
-              <a:t> </a:t>
-            </a:r>
-            <a:r>
-              <a:rPr lang="en-IN" sz="2000" dirty="0">
-                <a:latin typeface="Barlow" panose="00000500000000000000" pitchFamily="2" charset="0"/>
-              </a:rPr>
-              <a:t>Flash Attention</a:t>
-            </a:r>
-            <a:r>
-              <a:rPr lang="en-IN" sz="2000" b="1" baseline="30000" dirty="0">
-                <a:latin typeface="Barlow" panose="00000500000000000000" pitchFamily="2" charset="0"/>
-                <a:hlinkClick r:id="rId3" action="ppaction://hlinksldjump"/>
+                <a:hlinkClick r:id="rId3" action="ppaction://hlinksldjump">
+                  <a:extLst>
+                    <a:ext uri="{A12FA001-AC4F-418D-AE19-62706E023703}">
+                      <ahyp:hlinkClr xmlns:ahyp="http://schemas.microsoft.com/office/drawing/2018/hyperlinkcolor" val="tx"/>
+                    </a:ext>
+                  </a:extLst>
+                </a:hlinkClick>
               </a:rPr>
               <a:t>[13]</a:t>
             </a:r>

</xml_diff>

<commit_message>
Update training dataset size and add code/model availability links in thesis presentation
</commit_message>
<xml_diff>
--- a/cross_encoder/thesis/Thesis_presentation.pptx
+++ b/cross_encoder/thesis/Thesis_presentation.pptx
@@ -5,10 +5,10 @@
     <p:sldMasterId id="2147483672" r:id="rId4"/>
   </p:sldMasterIdLst>
   <p:notesMasterIdLst>
-    <p:notesMasterId r:id="rId33"/>
+    <p:notesMasterId r:id="rId35"/>
   </p:notesMasterIdLst>
   <p:handoutMasterIdLst>
-    <p:handoutMasterId r:id="rId34"/>
+    <p:handoutMasterId r:id="rId36"/>
   </p:handoutMasterIdLst>
   <p:sldIdLst>
     <p:sldId id="256" r:id="rId5"/>
@@ -35,10 +35,12 @@
     <p:sldId id="278" r:id="rId26"/>
     <p:sldId id="289" r:id="rId27"/>
     <p:sldId id="269" r:id="rId28"/>
-    <p:sldId id="290" r:id="rId29"/>
-    <p:sldId id="291" r:id="rId30"/>
-    <p:sldId id="292" r:id="rId31"/>
-    <p:sldId id="284" r:id="rId32"/>
+    <p:sldId id="293" r:id="rId29"/>
+    <p:sldId id="294" r:id="rId30"/>
+    <p:sldId id="290" r:id="rId31"/>
+    <p:sldId id="291" r:id="rId32"/>
+    <p:sldId id="292" r:id="rId33"/>
+    <p:sldId id="284" r:id="rId34"/>
   </p:sldIdLst>
   <p:sldSz cx="12192000" cy="6858000"/>
   <p:notesSz cx="6858000" cy="9144000"/>
@@ -1464,7 +1466,7 @@
           <a:p>
             <a:fld id="{E6AEB063-7F11-4E3B-BA52-07405B1C2D95}" type="slidenum">
               <a:rPr lang="en-US" smtClean="0"/>
-              <a:t>28</a:t>
+              <a:t>30</a:t>
             </a:fld>
             <a:endParaRPr lang="en-US" dirty="0"/>
           </a:p>
@@ -10445,7 +10447,7 @@
               <a:rPr lang="en-IN" sz="2400" dirty="0">
                 <a:latin typeface="Barlow" panose="00000500000000000000" pitchFamily="2" charset="0"/>
               </a:rPr>
-              <a:t>Passage Ranking (~500K query-passage pairs)</a:t>
+              <a:t>Passage Ranking (~2M triplets)</a:t>
             </a:r>
           </a:p>
           <a:p>
@@ -10535,7 +10537,7 @@
               <a:rPr lang="en-IN" sz="2400" dirty="0">
                 <a:latin typeface="Barlow" panose="00000500000000000000" pitchFamily="2" charset="0"/>
               </a:rPr>
-              <a:t>, MAP, MRR@10, Recall@10, R-Precision, P@10</a:t>
+              <a:t>, MAP, MRR@10, Recall@10, P@10</a:t>
             </a:r>
           </a:p>
           <a:p>
@@ -10706,7 +10708,51 @@
               <a:rPr lang="en-IN" sz="2400" dirty="0">
                 <a:latin typeface="Barlow" panose="00000500000000000000" pitchFamily="2" charset="0"/>
               </a:rPr>
-              <a:t> Learning rates (2e-5 standard, 2e-6 for ModernBERT+Lion)</a:t>
+              <a:t> Learning rates (2e-5 standard, 2e-6 for ModernBERT</a:t>
+            </a:r>
+            <a:r>
+              <a:rPr lang="en-IN" sz="2400" baseline="30000" dirty="0">
+                <a:solidFill>
+                  <a:srgbClr val="FF0000"/>
+                </a:solidFill>
+                <a:latin typeface="Barlow" panose="00000500000000000000" pitchFamily="2" charset="0"/>
+                <a:hlinkClick r:id="rId3" action="ppaction://hlinksldjump">
+                  <a:extLst>
+                    <a:ext uri="{A12FA001-AC4F-418D-AE19-62706E023703}">
+                      <ahyp:hlinkClr xmlns:ahyp="http://schemas.microsoft.com/office/drawing/2018/hyperlinkcolor" val="tx"/>
+                    </a:ext>
+                  </a:extLst>
+                </a:hlinkClick>
+              </a:rPr>
+              <a:t>[6]</a:t>
+            </a:r>
+            <a:r>
+              <a:rPr lang="en-IN" sz="2400" dirty="0">
+                <a:latin typeface="Barlow" panose="00000500000000000000" pitchFamily="2" charset="0"/>
+              </a:rPr>
+              <a:t>+Lion</a:t>
+            </a:r>
+            <a:r>
+              <a:rPr lang="en-IN" sz="2400" baseline="30000" dirty="0">
+                <a:solidFill>
+                  <a:srgbClr val="FF0000"/>
+                </a:solidFill>
+                <a:latin typeface="Barlow" panose="00000500000000000000" pitchFamily="2" charset="0"/>
+                <a:hlinkClick r:id="rId3" action="ppaction://hlinksldjump">
+                  <a:extLst>
+                    <a:ext uri="{A12FA001-AC4F-418D-AE19-62706E023703}">
+                      <ahyp:hlinkClr xmlns:ahyp="http://schemas.microsoft.com/office/drawing/2018/hyperlinkcolor" val="tx"/>
+                    </a:ext>
+                  </a:extLst>
+                </a:hlinkClick>
+              </a:rPr>
+              <a:t>[4]</a:t>
+            </a:r>
+            <a:r>
+              <a:rPr lang="en-IN" sz="2400" dirty="0">
+                <a:latin typeface="Barlow" panose="00000500000000000000" pitchFamily="2" charset="0"/>
+              </a:rPr>
+              <a:t>)</a:t>
             </a:r>
           </a:p>
         </p:txBody>
@@ -20378,6 +20424,242 @@
       </p:grpSpPr>
       <p:sp>
         <p:nvSpPr>
+          <p:cNvPr id="2" name="Title 1">
+            <a:extLst>
+              <a:ext uri="{FF2B5EF4-FFF2-40B4-BE49-F238E27FC236}">
+                <a16:creationId xmlns:a16="http://schemas.microsoft.com/office/drawing/2014/main" id="{23AB296B-71D9-5C1C-7F8F-165046B741D8}"/>
+              </a:ext>
+            </a:extLst>
+          </p:cNvPr>
+          <p:cNvSpPr>
+            <a:spLocks noGrp="1"/>
+          </p:cNvSpPr>
+          <p:nvPr>
+            <p:ph type="title"/>
+          </p:nvPr>
+        </p:nvSpPr>
+        <p:spPr/>
+        <p:txBody>
+          <a:bodyPr/>
+          <a:lstStyle/>
+          <a:p>
+            <a:r>
+              <a:rPr lang="en-GB" dirty="0">
+                <a:latin typeface="Barlow ExtraBold" panose="00000900000000000000" pitchFamily="2" charset="0"/>
+              </a:rPr>
+              <a:t>Code and Model availability</a:t>
+            </a:r>
+            <a:endParaRPr lang="en-IN" dirty="0">
+              <a:latin typeface="Barlow ExtraBold" panose="00000900000000000000" pitchFamily="2" charset="0"/>
+            </a:endParaRPr>
+          </a:p>
+        </p:txBody>
+      </p:sp>
+    </p:spTree>
+    <p:extLst>
+      <p:ext uri="{BB962C8B-B14F-4D97-AF65-F5344CB8AC3E}">
+        <p14:creationId xmlns:p14="http://schemas.microsoft.com/office/powerpoint/2010/main" val="3032910472"/>
+      </p:ext>
+    </p:extLst>
+  </p:cSld>
+  <p:clrMapOvr>
+    <a:masterClrMapping/>
+  </p:clrMapOvr>
+</p:sld>
+</file>
+
+<file path=ppt/slides/slide26.xml><?xml version="1.0" encoding="utf-8"?>
+<p:sld xmlns:a="http://schemas.openxmlformats.org/drawingml/2006/main" xmlns:r="http://schemas.openxmlformats.org/officeDocument/2006/relationships" xmlns:p="http://schemas.openxmlformats.org/presentationml/2006/main">
+  <p:cSld>
+    <p:spTree>
+      <p:nvGrpSpPr>
+        <p:cNvPr id="1" name="">
+          <a:extLst>
+            <a:ext uri="{FF2B5EF4-FFF2-40B4-BE49-F238E27FC236}">
+              <a16:creationId xmlns:a16="http://schemas.microsoft.com/office/drawing/2014/main" id="{5FB818C9-2186-F63A-6998-385E02599FEB}"/>
+            </a:ext>
+          </a:extLst>
+        </p:cNvPr>
+        <p:cNvGrpSpPr/>
+        <p:nvPr/>
+      </p:nvGrpSpPr>
+      <p:grpSpPr>
+        <a:xfrm>
+          <a:off x="0" y="0"/>
+          <a:ext cx="0" cy="0"/>
+          <a:chOff x="0" y="0"/>
+          <a:chExt cx="0" cy="0"/>
+        </a:xfrm>
+      </p:grpSpPr>
+      <p:sp>
+        <p:nvSpPr>
+          <p:cNvPr id="5" name="Text Placeholder 4">
+            <a:extLst>
+              <a:ext uri="{FF2B5EF4-FFF2-40B4-BE49-F238E27FC236}">
+                <a16:creationId xmlns:a16="http://schemas.microsoft.com/office/drawing/2014/main" id="{2898D326-FA1B-355D-92D0-C089225B5146}"/>
+              </a:ext>
+            </a:extLst>
+          </p:cNvPr>
+          <p:cNvSpPr>
+            <a:spLocks noGrp="1"/>
+          </p:cNvSpPr>
+          <p:nvPr>
+            <p:ph type="body" sz="half" idx="2"/>
+          </p:nvPr>
+        </p:nvSpPr>
+        <p:spPr>
+          <a:xfrm>
+            <a:off x="706277" y="1197142"/>
+            <a:ext cx="10779446" cy="5209674"/>
+          </a:xfrm>
+        </p:spPr>
+        <p:txBody>
+          <a:bodyPr>
+            <a:noAutofit/>
+          </a:bodyPr>
+          <a:lstStyle/>
+          <a:p>
+            <a:pPr marL="342900" indent="-342900">
+              <a:buFont typeface="Wingdings" panose="05000000000000000000" pitchFamily="2" charset="2"/>
+              <a:buChar char="q"/>
+            </a:pPr>
+            <a:r>
+              <a:rPr lang="en-GB" sz="3200" dirty="0">
+                <a:latin typeface="Barlow Medium" panose="00000600000000000000" pitchFamily="2" charset="0"/>
+              </a:rPr>
+              <a:t>Code for reproducibility can be found on: </a:t>
+            </a:r>
+            <a:r>
+              <a:rPr lang="en-GB" sz="3200" dirty="0">
+                <a:solidFill>
+                  <a:srgbClr val="FF0000"/>
+                </a:solidFill>
+                <a:latin typeface="Barlow Medium" panose="00000600000000000000" pitchFamily="2" charset="0"/>
+                <a:hlinkClick r:id="rId2">
+                  <a:extLst>
+                    <a:ext uri="{A12FA001-AC4F-418D-AE19-62706E023703}">
+                      <ahyp:hlinkClr xmlns:ahyp="http://schemas.microsoft.com/office/drawing/2018/hyperlinkcolor" val="tx"/>
+                    </a:ext>
+                  </a:extLst>
+                </a:hlinkClick>
+              </a:rPr>
+              <a:t>https://github.com/skfrost19/Cross-Encoder-Lion-vs-AdamW.git</a:t>
+            </a:r>
+            <a:endParaRPr lang="en-GB" sz="3200" dirty="0">
+              <a:solidFill>
+                <a:srgbClr val="FF0000"/>
+              </a:solidFill>
+              <a:latin typeface="Barlow Medium" panose="00000600000000000000" pitchFamily="2" charset="0"/>
+            </a:endParaRPr>
+          </a:p>
+          <a:p>
+            <a:pPr marL="342900" indent="-342900">
+              <a:buFont typeface="Wingdings" panose="05000000000000000000" pitchFamily="2" charset="2"/>
+              <a:buChar char="q"/>
+            </a:pPr>
+            <a:r>
+              <a:rPr lang="en-GB" sz="3200" dirty="0">
+                <a:latin typeface="Barlow Medium" panose="00000600000000000000" pitchFamily="2" charset="0"/>
+              </a:rPr>
+              <a:t>Trained Cross encoders can be found on:</a:t>
+            </a:r>
+            <a:r>
+              <a:rPr lang="en-IN" sz="3200" dirty="0">
+                <a:latin typeface="Barlow Medium" panose="00000600000000000000" pitchFamily="2" charset="0"/>
+              </a:rPr>
+              <a:t> </a:t>
+            </a:r>
+            <a:r>
+              <a:rPr lang="en-IN" sz="3200" dirty="0">
+                <a:solidFill>
+                  <a:srgbClr val="FF0000"/>
+                </a:solidFill>
+                <a:latin typeface="Barlow Medium" panose="00000600000000000000" pitchFamily="2" charset="0"/>
+                <a:hlinkClick r:id="rId3">
+                  <a:extLst>
+                    <a:ext uri="{A12FA001-AC4F-418D-AE19-62706E023703}">
+                      <ahyp:hlinkClr xmlns:ahyp="http://schemas.microsoft.com/office/drawing/2018/hyperlinkcolor" val="tx"/>
+                    </a:ext>
+                  </a:extLst>
+                </a:hlinkClick>
+              </a:rPr>
+              <a:t>https://huggingface.co/collections/skfrost19/rerenkers-681320776cfb45e44b18f5f1</a:t>
+            </a:r>
+            <a:endParaRPr lang="en-IN" sz="3200" dirty="0">
+              <a:solidFill>
+                <a:srgbClr val="FF0000"/>
+              </a:solidFill>
+              <a:latin typeface="Barlow Medium" panose="00000600000000000000" pitchFamily="2" charset="0"/>
+            </a:endParaRPr>
+          </a:p>
+          <a:p>
+            <a:pPr marL="342900" indent="-342900">
+              <a:buFont typeface="Wingdings" panose="05000000000000000000" pitchFamily="2" charset="2"/>
+              <a:buChar char="q"/>
+            </a:pPr>
+            <a:r>
+              <a:rPr lang="en-IN" sz="3200" dirty="0">
+                <a:latin typeface="Barlow Medium" panose="00000600000000000000" pitchFamily="2" charset="0"/>
+              </a:rPr>
+              <a:t>Pre-print can be found on: </a:t>
+            </a:r>
+            <a:r>
+              <a:rPr lang="en-IN" sz="3200" dirty="0">
+                <a:solidFill>
+                  <a:srgbClr val="FF0000"/>
+                </a:solidFill>
+                <a:latin typeface="Barlow Medium" panose="00000600000000000000" pitchFamily="2" charset="0"/>
+                <a:hlinkClick r:id="rId4">
+                  <a:extLst>
+                    <a:ext uri="{A12FA001-AC4F-418D-AE19-62706E023703}">
+                      <ahyp:hlinkClr xmlns:ahyp="http://schemas.microsoft.com/office/drawing/2018/hyperlinkcolor" val="tx"/>
+                    </a:ext>
+                  </a:extLst>
+                </a:hlinkClick>
+              </a:rPr>
+              <a:t>https://arxiv.org/abs/2506.18297</a:t>
+            </a:r>
+            <a:endParaRPr lang="en-GB" sz="3200" dirty="0">
+              <a:solidFill>
+                <a:srgbClr val="FF0000"/>
+              </a:solidFill>
+              <a:latin typeface="Barlow Medium" panose="00000600000000000000" pitchFamily="2" charset="0"/>
+            </a:endParaRPr>
+          </a:p>
+        </p:txBody>
+      </p:sp>
+    </p:spTree>
+    <p:extLst>
+      <p:ext uri="{BB962C8B-B14F-4D97-AF65-F5344CB8AC3E}">
+        <p14:creationId xmlns:p14="http://schemas.microsoft.com/office/powerpoint/2010/main" val="1171816428"/>
+      </p:ext>
+    </p:extLst>
+  </p:cSld>
+  <p:clrMapOvr>
+    <a:masterClrMapping/>
+  </p:clrMapOvr>
+</p:sld>
+</file>
+
+<file path=ppt/slides/slide27.xml><?xml version="1.0" encoding="utf-8"?>
+<p:sld xmlns:a="http://schemas.openxmlformats.org/drawingml/2006/main" xmlns:r="http://schemas.openxmlformats.org/officeDocument/2006/relationships" xmlns:p="http://schemas.openxmlformats.org/presentationml/2006/main">
+  <p:cSld>
+    <p:spTree>
+      <p:nvGrpSpPr>
+        <p:cNvPr id="1" name=""/>
+        <p:cNvGrpSpPr/>
+        <p:nvPr/>
+      </p:nvGrpSpPr>
+      <p:grpSpPr>
+        <a:xfrm>
+          <a:off x="0" y="0"/>
+          <a:ext cx="0" cy="0"/>
+          <a:chOff x="0" y="0"/>
+          <a:chExt cx="0" cy="0"/>
+        </a:xfrm>
+      </p:grpSpPr>
+      <p:sp>
+        <p:nvSpPr>
           <p:cNvPr id="3" name="Title 2">
             <a:extLst>
               <a:ext uri="{FF2B5EF4-FFF2-40B4-BE49-F238E27FC236}">
@@ -20588,7 +20870,7 @@
 </p:sld>
 </file>
 
-<file path=ppt/slides/slide26.xml><?xml version="1.0" encoding="utf-8"?>
+<file path=ppt/slides/slide28.xml><?xml version="1.0" encoding="utf-8"?>
 <p:sld xmlns:a="http://schemas.openxmlformats.org/drawingml/2006/main" xmlns:r="http://schemas.openxmlformats.org/officeDocument/2006/relationships" xmlns:p="http://schemas.openxmlformats.org/presentationml/2006/main">
   <p:cSld>
     <p:spTree>
@@ -20800,7 +21082,7 @@
 </p:sld>
 </file>
 
-<file path=ppt/slides/slide27.xml><?xml version="1.0" encoding="utf-8"?>
+<file path=ppt/slides/slide29.xml><?xml version="1.0" encoding="utf-8"?>
 <p:sld xmlns:a="http://schemas.openxmlformats.org/drawingml/2006/main" xmlns:r="http://schemas.openxmlformats.org/officeDocument/2006/relationships" xmlns:p="http://schemas.openxmlformats.org/presentationml/2006/main">
   <p:cSld>
     <p:spTree>
@@ -20997,72 +21279,6 @@
     <p:extLst>
       <p:ext uri="{BB962C8B-B14F-4D97-AF65-F5344CB8AC3E}">
         <p14:creationId xmlns:p14="http://schemas.microsoft.com/office/powerpoint/2010/main" val="105729659"/>
-      </p:ext>
-    </p:extLst>
-  </p:cSld>
-  <p:clrMapOvr>
-    <a:masterClrMapping/>
-  </p:clrMapOvr>
-</p:sld>
-</file>
-
-<file path=ppt/slides/slide28.xml><?xml version="1.0" encoding="utf-8"?>
-<p:sld xmlns:a="http://schemas.openxmlformats.org/drawingml/2006/main" xmlns:r="http://schemas.openxmlformats.org/officeDocument/2006/relationships" xmlns:p="http://schemas.openxmlformats.org/presentationml/2006/main">
-  <p:cSld>
-    <p:spTree>
-      <p:nvGrpSpPr>
-        <p:cNvPr id="1" name="">
-          <a:extLst>
-            <a:ext uri="{FF2B5EF4-FFF2-40B4-BE49-F238E27FC236}">
-              <a16:creationId xmlns:a16="http://schemas.microsoft.com/office/drawing/2014/main" id="{A029116E-BD98-EFAB-1E2F-29B3F9288541}"/>
-            </a:ext>
-          </a:extLst>
-        </p:cNvPr>
-        <p:cNvGrpSpPr/>
-        <p:nvPr/>
-      </p:nvGrpSpPr>
-      <p:grpSpPr>
-        <a:xfrm>
-          <a:off x="0" y="0"/>
-          <a:ext cx="0" cy="0"/>
-          <a:chOff x="0" y="0"/>
-          <a:chExt cx="0" cy="0"/>
-        </a:xfrm>
-      </p:grpSpPr>
-      <p:sp>
-        <p:nvSpPr>
-          <p:cNvPr id="2" name="Title 1">
-            <a:extLst>
-              <a:ext uri="{FF2B5EF4-FFF2-40B4-BE49-F238E27FC236}">
-                <a16:creationId xmlns:a16="http://schemas.microsoft.com/office/drawing/2014/main" id="{D53321B8-DF6D-4A69-F020-DC2108ACAE4B}"/>
-              </a:ext>
-            </a:extLst>
-          </p:cNvPr>
-          <p:cNvSpPr>
-            <a:spLocks noGrp="1"/>
-          </p:cNvSpPr>
-          <p:nvPr>
-            <p:ph type="title"/>
-          </p:nvPr>
-        </p:nvSpPr>
-        <p:spPr bwMode="white"/>
-        <p:txBody>
-          <a:bodyPr/>
-          <a:lstStyle/>
-          <a:p>
-            <a:r>
-              <a:rPr lang="en-US" sz="4000" dirty="0">
-                <a:latin typeface="Barlow ExtraBold" panose="00000900000000000000" pitchFamily="2" charset="0"/>
-              </a:rPr>
-              <a:t>THANK YOU</a:t>
-            </a:r>
-          </a:p>
-        </p:txBody>
-      </p:sp>
-    </p:spTree>
-    <p:extLst>
-      <p:ext uri="{BB962C8B-B14F-4D97-AF65-F5344CB8AC3E}">
-        <p14:creationId xmlns:p14="http://schemas.microsoft.com/office/powerpoint/2010/main" val="4069644453"/>
       </p:ext>
     </p:extLst>
   </p:cSld>
@@ -21362,6 +21578,72 @@
     <p:extLst>
       <p:ext uri="{BB962C8B-B14F-4D97-AF65-F5344CB8AC3E}">
         <p14:creationId xmlns:p14="http://schemas.microsoft.com/office/powerpoint/2010/main" val="2131043727"/>
+      </p:ext>
+    </p:extLst>
+  </p:cSld>
+  <p:clrMapOvr>
+    <a:masterClrMapping/>
+  </p:clrMapOvr>
+</p:sld>
+</file>
+
+<file path=ppt/slides/slide30.xml><?xml version="1.0" encoding="utf-8"?>
+<p:sld xmlns:a="http://schemas.openxmlformats.org/drawingml/2006/main" xmlns:r="http://schemas.openxmlformats.org/officeDocument/2006/relationships" xmlns:p="http://schemas.openxmlformats.org/presentationml/2006/main">
+  <p:cSld>
+    <p:spTree>
+      <p:nvGrpSpPr>
+        <p:cNvPr id="1" name="">
+          <a:extLst>
+            <a:ext uri="{FF2B5EF4-FFF2-40B4-BE49-F238E27FC236}">
+              <a16:creationId xmlns:a16="http://schemas.microsoft.com/office/drawing/2014/main" id="{A029116E-BD98-EFAB-1E2F-29B3F9288541}"/>
+            </a:ext>
+          </a:extLst>
+        </p:cNvPr>
+        <p:cNvGrpSpPr/>
+        <p:nvPr/>
+      </p:nvGrpSpPr>
+      <p:grpSpPr>
+        <a:xfrm>
+          <a:off x="0" y="0"/>
+          <a:ext cx="0" cy="0"/>
+          <a:chOff x="0" y="0"/>
+          <a:chExt cx="0" cy="0"/>
+        </a:xfrm>
+      </p:grpSpPr>
+      <p:sp>
+        <p:nvSpPr>
+          <p:cNvPr id="2" name="Title 1">
+            <a:extLst>
+              <a:ext uri="{FF2B5EF4-FFF2-40B4-BE49-F238E27FC236}">
+                <a16:creationId xmlns:a16="http://schemas.microsoft.com/office/drawing/2014/main" id="{D53321B8-DF6D-4A69-F020-DC2108ACAE4B}"/>
+              </a:ext>
+            </a:extLst>
+          </p:cNvPr>
+          <p:cNvSpPr>
+            <a:spLocks noGrp="1"/>
+          </p:cNvSpPr>
+          <p:nvPr>
+            <p:ph type="title"/>
+          </p:nvPr>
+        </p:nvSpPr>
+        <p:spPr bwMode="white"/>
+        <p:txBody>
+          <a:bodyPr/>
+          <a:lstStyle/>
+          <a:p>
+            <a:r>
+              <a:rPr lang="en-US" sz="4000" dirty="0">
+                <a:latin typeface="Barlow ExtraBold" panose="00000900000000000000" pitchFamily="2" charset="0"/>
+              </a:rPr>
+              <a:t>THANK YOU</a:t>
+            </a:r>
+          </a:p>
+        </p:txBody>
+      </p:sp>
+    </p:spTree>
+    <p:extLst>
+      <p:ext uri="{BB962C8B-B14F-4D97-AF65-F5344CB8AC3E}">
+        <p14:creationId xmlns:p14="http://schemas.microsoft.com/office/powerpoint/2010/main" val="4069644453"/>
       </p:ext>
     </p:extLst>
   </p:cSld>

</xml_diff>

<commit_message>
Update evaluation metrics and results in thesis presentation
</commit_message>
<xml_diff>
--- a/cross_encoder/thesis/Thesis_presentation.pptx
+++ b/cross_encoder/thesis/Thesis_presentation.pptx
@@ -26,8 +26,8 @@
     <p:sldId id="272" r:id="rId17"/>
     <p:sldId id="264" r:id="rId18"/>
     <p:sldId id="279" r:id="rId19"/>
-    <p:sldId id="271" r:id="rId20"/>
-    <p:sldId id="273" r:id="rId21"/>
+    <p:sldId id="273" r:id="rId20"/>
+    <p:sldId id="271" r:id="rId21"/>
     <p:sldId id="288" r:id="rId22"/>
     <p:sldId id="275" r:id="rId23"/>
     <p:sldId id="276" r:id="rId24"/>
@@ -10537,7 +10537,7 @@
               <a:rPr lang="en-IN" sz="2400" dirty="0">
                 <a:latin typeface="Barlow" panose="00000500000000000000" pitchFamily="2" charset="0"/>
               </a:rPr>
-              <a:t>, MAP, MRR@10, Recall@10, P@10</a:t>
+              <a:t>, MRR@10, Recall@10, P@10</a:t>
             </a:r>
           </a:p>
           <a:p>
@@ -12885,195 +12885,6 @@
   <p:cSld>
     <p:spTree>
       <p:nvGrpSpPr>
-        <p:cNvPr id="1" name=""/>
-        <p:cNvGrpSpPr/>
-        <p:nvPr/>
-      </p:nvGrpSpPr>
-      <p:grpSpPr>
-        <a:xfrm>
-          <a:off x="0" y="0"/>
-          <a:ext cx="0" cy="0"/>
-          <a:chOff x="0" y="0"/>
-          <a:chExt cx="0" cy="0"/>
-        </a:xfrm>
-      </p:grpSpPr>
-      <p:sp>
-        <p:nvSpPr>
-          <p:cNvPr id="2" name="Title 1">
-            <a:extLst>
-              <a:ext uri="{FF2B5EF4-FFF2-40B4-BE49-F238E27FC236}">
-                <a16:creationId xmlns:a16="http://schemas.microsoft.com/office/drawing/2014/main" id="{E06B4AAE-A61A-4FE9-7D4D-04001D6A33A7}"/>
-              </a:ext>
-            </a:extLst>
-          </p:cNvPr>
-          <p:cNvSpPr>
-            <a:spLocks noGrp="1"/>
-          </p:cNvSpPr>
-          <p:nvPr>
-            <p:ph type="title"/>
-          </p:nvPr>
-        </p:nvSpPr>
-        <p:spPr/>
-        <p:txBody>
-          <a:bodyPr/>
-          <a:lstStyle/>
-          <a:p>
-            <a:r>
-              <a:rPr lang="en-GB" dirty="0">
-                <a:latin typeface="Barlow ExtraBold" panose="00000900000000000000" pitchFamily="2" charset="0"/>
-              </a:rPr>
-              <a:t>Evaluation Metrics</a:t>
-            </a:r>
-            <a:endParaRPr lang="en-IN" dirty="0">
-              <a:latin typeface="Barlow ExtraBold" panose="00000900000000000000" pitchFamily="2" charset="0"/>
-            </a:endParaRPr>
-          </a:p>
-        </p:txBody>
-      </p:sp>
-      <p:sp>
-        <p:nvSpPr>
-          <p:cNvPr id="6" name="TextBox 5">
-            <a:extLst>
-              <a:ext uri="{FF2B5EF4-FFF2-40B4-BE49-F238E27FC236}">
-                <a16:creationId xmlns:a16="http://schemas.microsoft.com/office/drawing/2014/main" id="{F72B3316-1ADE-DDFF-23B4-6BC8F225AD2A}"/>
-              </a:ext>
-            </a:extLst>
-          </p:cNvPr>
-          <p:cNvSpPr txBox="1"/>
-          <p:nvPr/>
-        </p:nvSpPr>
-        <p:spPr>
-          <a:xfrm>
-            <a:off x="527427" y="2346760"/>
-            <a:ext cx="8938665" cy="461665"/>
-          </a:xfrm>
-          <a:prstGeom prst="rect">
-            <a:avLst/>
-          </a:prstGeom>
-          <a:noFill/>
-        </p:spPr>
-        <p:txBody>
-          <a:bodyPr wrap="none" rtlCol="0">
-            <a:spAutoFit/>
-          </a:bodyPr>
-          <a:lstStyle/>
-          <a:p>
-            <a:r>
-              <a:rPr lang="en-GB" sz="2400" dirty="0">
-                <a:latin typeface="Barlow Medium" panose="00000600000000000000" pitchFamily="2" charset="0"/>
-              </a:rPr>
-              <a:t>NDCG@10 - Normalized Discounted Cumulative Gain at rank 10</a:t>
-            </a:r>
-            <a:r>
-              <a:rPr lang="en-GB" sz="2400" baseline="30000" dirty="0">
-                <a:solidFill>
-                  <a:srgbClr val="FF0000"/>
-                </a:solidFill>
-                <a:latin typeface="Barlow Medium" panose="00000600000000000000" pitchFamily="2" charset="0"/>
-                <a:hlinkClick r:id="rId2" action="ppaction://hlinksldjump">
-                  <a:extLst>
-                    <a:ext uri="{A12FA001-AC4F-418D-AE19-62706E023703}">
-                      <ahyp:hlinkClr xmlns:ahyp="http://schemas.microsoft.com/office/drawing/2018/hyperlinkcolor" val="tx"/>
-                    </a:ext>
-                  </a:extLst>
-                </a:hlinkClick>
-              </a:rPr>
-              <a:t>[16]</a:t>
-            </a:r>
-            <a:endParaRPr lang="en-GB" sz="2400" baseline="30000" dirty="0">
-              <a:solidFill>
-                <a:srgbClr val="FF0000"/>
-              </a:solidFill>
-              <a:latin typeface="Barlow Medium" panose="00000600000000000000" pitchFamily="2" charset="0"/>
-            </a:endParaRPr>
-          </a:p>
-        </p:txBody>
-      </p:sp>
-      <p:sp>
-        <p:nvSpPr>
-          <p:cNvPr id="7" name="TextBox 6">
-            <a:extLst>
-              <a:ext uri="{FF2B5EF4-FFF2-40B4-BE49-F238E27FC236}">
-                <a16:creationId xmlns:a16="http://schemas.microsoft.com/office/drawing/2014/main" id="{061EE149-ABB6-78F4-BB33-DDCA828B8076}"/>
-              </a:ext>
-            </a:extLst>
-          </p:cNvPr>
-          <p:cNvSpPr txBox="1"/>
-          <p:nvPr/>
-        </p:nvSpPr>
-        <p:spPr>
-          <a:xfrm>
-            <a:off x="527427" y="2906550"/>
-            <a:ext cx="8908852" cy="923330"/>
-          </a:xfrm>
-          <a:prstGeom prst="rect">
-            <a:avLst/>
-          </a:prstGeom>
-          <a:noFill/>
-        </p:spPr>
-        <p:txBody>
-          <a:bodyPr wrap="square" rtlCol="0">
-            <a:spAutoFit/>
-          </a:bodyPr>
-          <a:lstStyle/>
-          <a:p>
-            <a:r>
-              <a:rPr lang="en-GB" dirty="0">
-                <a:latin typeface="Barlow" panose="00000500000000000000" pitchFamily="2" charset="0"/>
-              </a:rPr>
-              <a:t>NDCG@10 measures the quality of ranking systems by considering both the relevance of retrieved documents and their positions in the ranking. It is normalized by the ideal DCG to ensure values between 0 and 1, where higher values indicate better performance.</a:t>
-            </a:r>
-          </a:p>
-        </p:txBody>
-      </p:sp>
-      <p:pic>
-        <p:nvPicPr>
-          <p:cNvPr id="8" name="@holatex&#10;\begin{document}&#10;\begin{equation}&#10;\text{NDCG@10} = \frac{\text{DCG@10}}{\text{IDCG@10}}&#10;\end{equation}&#10;&#10;where:&#10;\begin{equation}&#10;\text{DCG@10} = \sum_{i=1}^{10} \frac{2^{rel_i} - 1}{\log_2(i + 1)}&#10;\end{equation}&#10;&#10;and $rel_i$ is the relevance score of the document at position $i$, and IDCG@10 is the ideal DCG computed using the best possible ranking.&#10;&#10;\end{document}">
-            <a:extLst>
-              <a:ext uri="{FF2B5EF4-FFF2-40B4-BE49-F238E27FC236}">
-                <a16:creationId xmlns:a16="http://schemas.microsoft.com/office/drawing/2014/main" id="{E2452F6C-0672-68CF-1E6D-B7CB3B53A0CE}"/>
-              </a:ext>
-            </a:extLst>
-          </p:cNvPr>
-          <p:cNvPicPr>
-            <a:picLocks/>
-          </p:cNvPicPr>
-          <p:nvPr/>
-        </p:nvPicPr>
-        <p:blipFill>
-          <a:blip r:embed="rId3"/>
-          <a:stretch>
-            <a:fillRect/>
-          </a:stretch>
-        </p:blipFill>
-        <p:spPr>
-          <a:xfrm>
-            <a:off x="1117600" y="4383878"/>
-            <a:ext cx="6959600" cy="2026933"/>
-          </a:xfrm>
-          <a:prstGeom prst="rect">
-            <a:avLst/>
-          </a:prstGeom>
-        </p:spPr>
-      </p:pic>
-    </p:spTree>
-    <p:extLst>
-      <p:ext uri="{BB962C8B-B14F-4D97-AF65-F5344CB8AC3E}">
-        <p14:creationId xmlns:p14="http://schemas.microsoft.com/office/powerpoint/2010/main" val="1961845443"/>
-      </p:ext>
-    </p:extLst>
-  </p:cSld>
-  <p:clrMapOvr>
-    <a:masterClrMapping/>
-  </p:clrMapOvr>
-</p:sld>
-</file>
-
-<file path=ppt/slides/slide17.xml><?xml version="1.0" encoding="utf-8"?>
-<p:sld xmlns:a="http://schemas.openxmlformats.org/drawingml/2006/main" xmlns:r="http://schemas.openxmlformats.org/officeDocument/2006/relationships" xmlns:p="http://schemas.openxmlformats.org/presentationml/2006/main">
-  <p:cSld>
-    <p:spTree>
-      <p:nvGrpSpPr>
         <p:cNvPr id="1" name="">
           <a:extLst>
             <a:ext uri="{FF2B5EF4-FFF2-40B4-BE49-F238E27FC236}">
@@ -13233,6 +13044,195 @@
     <p:extLst>
       <p:ext uri="{BB962C8B-B14F-4D97-AF65-F5344CB8AC3E}">
         <p14:creationId xmlns:p14="http://schemas.microsoft.com/office/powerpoint/2010/main" val="2752368493"/>
+      </p:ext>
+    </p:extLst>
+  </p:cSld>
+  <p:clrMapOvr>
+    <a:masterClrMapping/>
+  </p:clrMapOvr>
+</p:sld>
+</file>
+
+<file path=ppt/slides/slide17.xml><?xml version="1.0" encoding="utf-8"?>
+<p:sld xmlns:a="http://schemas.openxmlformats.org/drawingml/2006/main" xmlns:r="http://schemas.openxmlformats.org/officeDocument/2006/relationships" xmlns:p="http://schemas.openxmlformats.org/presentationml/2006/main">
+  <p:cSld>
+    <p:spTree>
+      <p:nvGrpSpPr>
+        <p:cNvPr id="1" name=""/>
+        <p:cNvGrpSpPr/>
+        <p:nvPr/>
+      </p:nvGrpSpPr>
+      <p:grpSpPr>
+        <a:xfrm>
+          <a:off x="0" y="0"/>
+          <a:ext cx="0" cy="0"/>
+          <a:chOff x="0" y="0"/>
+          <a:chExt cx="0" cy="0"/>
+        </a:xfrm>
+      </p:grpSpPr>
+      <p:sp>
+        <p:nvSpPr>
+          <p:cNvPr id="2" name="Title 1">
+            <a:extLst>
+              <a:ext uri="{FF2B5EF4-FFF2-40B4-BE49-F238E27FC236}">
+                <a16:creationId xmlns:a16="http://schemas.microsoft.com/office/drawing/2014/main" id="{E06B4AAE-A61A-4FE9-7D4D-04001D6A33A7}"/>
+              </a:ext>
+            </a:extLst>
+          </p:cNvPr>
+          <p:cNvSpPr>
+            <a:spLocks noGrp="1"/>
+          </p:cNvSpPr>
+          <p:nvPr>
+            <p:ph type="title"/>
+          </p:nvPr>
+        </p:nvSpPr>
+        <p:spPr/>
+        <p:txBody>
+          <a:bodyPr/>
+          <a:lstStyle/>
+          <a:p>
+            <a:r>
+              <a:rPr lang="en-GB" dirty="0">
+                <a:latin typeface="Barlow ExtraBold" panose="00000900000000000000" pitchFamily="2" charset="0"/>
+              </a:rPr>
+              <a:t>Evaluation Metrics</a:t>
+            </a:r>
+            <a:endParaRPr lang="en-IN" dirty="0">
+              <a:latin typeface="Barlow ExtraBold" panose="00000900000000000000" pitchFamily="2" charset="0"/>
+            </a:endParaRPr>
+          </a:p>
+        </p:txBody>
+      </p:sp>
+      <p:sp>
+        <p:nvSpPr>
+          <p:cNvPr id="6" name="TextBox 5">
+            <a:extLst>
+              <a:ext uri="{FF2B5EF4-FFF2-40B4-BE49-F238E27FC236}">
+                <a16:creationId xmlns:a16="http://schemas.microsoft.com/office/drawing/2014/main" id="{F72B3316-1ADE-DDFF-23B4-6BC8F225AD2A}"/>
+              </a:ext>
+            </a:extLst>
+          </p:cNvPr>
+          <p:cNvSpPr txBox="1"/>
+          <p:nvPr/>
+        </p:nvSpPr>
+        <p:spPr>
+          <a:xfrm>
+            <a:off x="527427" y="2346760"/>
+            <a:ext cx="8938665" cy="461665"/>
+          </a:xfrm>
+          <a:prstGeom prst="rect">
+            <a:avLst/>
+          </a:prstGeom>
+          <a:noFill/>
+        </p:spPr>
+        <p:txBody>
+          <a:bodyPr wrap="none" rtlCol="0">
+            <a:spAutoFit/>
+          </a:bodyPr>
+          <a:lstStyle/>
+          <a:p>
+            <a:r>
+              <a:rPr lang="en-GB" sz="2400" dirty="0">
+                <a:latin typeface="Barlow Medium" panose="00000600000000000000" pitchFamily="2" charset="0"/>
+              </a:rPr>
+              <a:t>NDCG@10 - Normalized Discounted Cumulative Gain at rank 10</a:t>
+            </a:r>
+            <a:r>
+              <a:rPr lang="en-GB" sz="2400" baseline="30000" dirty="0">
+                <a:solidFill>
+                  <a:srgbClr val="FF0000"/>
+                </a:solidFill>
+                <a:latin typeface="Barlow Medium" panose="00000600000000000000" pitchFamily="2" charset="0"/>
+                <a:hlinkClick r:id="rId2" action="ppaction://hlinksldjump">
+                  <a:extLst>
+                    <a:ext uri="{A12FA001-AC4F-418D-AE19-62706E023703}">
+                      <ahyp:hlinkClr xmlns:ahyp="http://schemas.microsoft.com/office/drawing/2018/hyperlinkcolor" val="tx"/>
+                    </a:ext>
+                  </a:extLst>
+                </a:hlinkClick>
+              </a:rPr>
+              <a:t>[16]</a:t>
+            </a:r>
+            <a:endParaRPr lang="en-GB" sz="2400" baseline="30000" dirty="0">
+              <a:solidFill>
+                <a:srgbClr val="FF0000"/>
+              </a:solidFill>
+              <a:latin typeface="Barlow Medium" panose="00000600000000000000" pitchFamily="2" charset="0"/>
+            </a:endParaRPr>
+          </a:p>
+        </p:txBody>
+      </p:sp>
+      <p:sp>
+        <p:nvSpPr>
+          <p:cNvPr id="7" name="TextBox 6">
+            <a:extLst>
+              <a:ext uri="{FF2B5EF4-FFF2-40B4-BE49-F238E27FC236}">
+                <a16:creationId xmlns:a16="http://schemas.microsoft.com/office/drawing/2014/main" id="{061EE149-ABB6-78F4-BB33-DDCA828B8076}"/>
+              </a:ext>
+            </a:extLst>
+          </p:cNvPr>
+          <p:cNvSpPr txBox="1"/>
+          <p:nvPr/>
+        </p:nvSpPr>
+        <p:spPr>
+          <a:xfrm>
+            <a:off x="527427" y="2906550"/>
+            <a:ext cx="8908852" cy="923330"/>
+          </a:xfrm>
+          <a:prstGeom prst="rect">
+            <a:avLst/>
+          </a:prstGeom>
+          <a:noFill/>
+        </p:spPr>
+        <p:txBody>
+          <a:bodyPr wrap="square" rtlCol="0">
+            <a:spAutoFit/>
+          </a:bodyPr>
+          <a:lstStyle/>
+          <a:p>
+            <a:r>
+              <a:rPr lang="en-GB" dirty="0">
+                <a:latin typeface="Barlow" panose="00000500000000000000" pitchFamily="2" charset="0"/>
+              </a:rPr>
+              <a:t>NDCG@10 measures the quality of ranking systems by considering both the relevance of retrieved documents and their positions in the ranking. It is normalized by the ideal DCG to ensure values between 0 and 1, where higher values indicate better performance.</a:t>
+            </a:r>
+          </a:p>
+        </p:txBody>
+      </p:sp>
+      <p:pic>
+        <p:nvPicPr>
+          <p:cNvPr id="8" name="@holatex&#10;\begin{document}&#10;\begin{equation}&#10;\text{NDCG@10} = \frac{\text{DCG@10}}{\text{IDCG@10}}&#10;\end{equation}&#10;&#10;where:&#10;\begin{equation}&#10;\text{DCG@10} = \sum_{i=1}^{10} \frac{2^{rel_i} - 1}{\log_2(i + 1)}&#10;\end{equation}&#10;&#10;and $rel_i$ is the relevance score of the document at position $i$, and IDCG@10 is the ideal DCG computed using the best possible ranking.&#10;&#10;\end{document}">
+            <a:extLst>
+              <a:ext uri="{FF2B5EF4-FFF2-40B4-BE49-F238E27FC236}">
+                <a16:creationId xmlns:a16="http://schemas.microsoft.com/office/drawing/2014/main" id="{E2452F6C-0672-68CF-1E6D-B7CB3B53A0CE}"/>
+              </a:ext>
+            </a:extLst>
+          </p:cNvPr>
+          <p:cNvPicPr>
+            <a:picLocks/>
+          </p:cNvPicPr>
+          <p:nvPr/>
+        </p:nvPicPr>
+        <p:blipFill>
+          <a:blip r:embed="rId3"/>
+          <a:stretch>
+            <a:fillRect/>
+          </a:stretch>
+        </p:blipFill>
+        <p:spPr>
+          <a:xfrm>
+            <a:off x="1117600" y="4383878"/>
+            <a:ext cx="6959600" cy="2026933"/>
+          </a:xfrm>
+          <a:prstGeom prst="rect">
+            <a:avLst/>
+          </a:prstGeom>
+        </p:spPr>
+      </p:pic>
+    </p:spTree>
+    <p:extLst>
+      <p:ext uri="{BB962C8B-B14F-4D97-AF65-F5344CB8AC3E}">
+        <p14:creationId xmlns:p14="http://schemas.microsoft.com/office/powerpoint/2010/main" val="1961845443"/>
       </p:ext>
     </p:extLst>
   </p:cSld>
@@ -13386,14 +13386,14 @@
           <p:nvPr>
             <p:extLst>
               <p:ext uri="{D42A27DB-BD31-4B8C-83A1-F6EECF244321}">
-                <p14:modId xmlns:p14="http://schemas.microsoft.com/office/powerpoint/2010/main" val="2709341113"/>
+                <p14:modId xmlns:p14="http://schemas.microsoft.com/office/powerpoint/2010/main" val="1126788479"/>
               </p:ext>
             </p:extLst>
           </p:nvPr>
         </p:nvGraphicFramePr>
         <p:xfrm>
-          <a:off x="930000" y="2405853"/>
-          <a:ext cx="10332000" cy="3059998"/>
+          <a:off x="1668000" y="2286584"/>
+          <a:ext cx="8856000" cy="3059998"/>
         </p:xfrm>
         <a:graphic>
           <a:graphicData uri="http://schemas.openxmlformats.org/drawingml/2006/table">
@@ -13420,13 +13420,6 @@
                   <a:extLst>
                     <a:ext uri="{9D8B030D-6E8A-4147-A177-3AD203B41FA5}">
                       <a16:colId xmlns:a16="http://schemas.microsoft.com/office/drawing/2014/main" val="1757895171"/>
-                    </a:ext>
-                  </a:extLst>
-                </a:gridCol>
-                <a:gridCol w="1476000">
-                  <a:extLst>
-                    <a:ext uri="{9D8B030D-6E8A-4147-A177-3AD203B41FA5}">
-                      <a16:colId xmlns:a16="http://schemas.microsoft.com/office/drawing/2014/main" val="1926697050"/>
                     </a:ext>
                   </a:extLst>
                 </a:gridCol>
@@ -13575,39 +13568,6 @@
                           <a:effectLst/>
                           <a:latin typeface="Barlow SemiBold" panose="00000700000000000000" pitchFamily="2" charset="0"/>
                         </a:rPr>
-                        <a:t>MAP</a:t>
-                      </a:r>
-                    </a:p>
-                  </a:txBody>
-                  <a:tcPr anchor="ctr">
-                    <a:lnB w="12700" cap="flat" cmpd="sng" algn="ctr">
-                      <a:solidFill>
-                        <a:schemeClr val="tx1"/>
-                      </a:solidFill>
-                      <a:prstDash val="solid"/>
-                      <a:round/>
-                      <a:headEnd type="none" w="med" len="med"/>
-                      <a:tailEnd type="none" w="med" len="med"/>
-                    </a:lnB>
-                    <a:solidFill>
-                      <a:srgbClr val="0070C0"/>
-                    </a:solidFill>
-                  </a:tcPr>
-                </a:tc>
-                <a:tc>
-                  <a:txBody>
-                    <a:bodyPr/>
-                    <a:lstStyle/>
-                    <a:p>
-                      <a:pPr algn="ctr"/>
-                      <a:r>
-                        <a:rPr lang="en-IN" sz="2200" b="1" dirty="0">
-                          <a:solidFill>
-                            <a:srgbClr val="FFFFFF"/>
-                          </a:solidFill>
-                          <a:effectLst/>
-                          <a:latin typeface="Barlow SemiBold" panose="00000700000000000000" pitchFamily="2" charset="0"/>
-                        </a:rPr>
                         <a:t>MRR@10</a:t>
                       </a:r>
                     </a:p>
@@ -13901,70 +13861,6 @@
                     <a:p>
                       <a:pPr algn="ctr"/>
                       <a:r>
-                        <a:rPr lang="en-IN" b="1" dirty="0">
-                          <a:solidFill>
-                            <a:srgbClr val="334155"/>
-                          </a:solidFill>
-                          <a:effectLst/>
-                          <a:latin typeface="Barlow Medium" panose="00000600000000000000" pitchFamily="2" charset="0"/>
-                        </a:rPr>
-                        <a:t>0.4908</a:t>
-                      </a:r>
-                    </a:p>
-                  </a:txBody>
-                  <a:tcPr anchor="ctr">
-                    <a:lnL w="3175" cap="flat" cmpd="sng" algn="ctr">
-                      <a:noFill/>
-                      <a:prstDash val="solid"/>
-                      <a:round/>
-                      <a:headEnd type="none" w="med" len="med"/>
-                      <a:tailEnd type="none" w="med" len="med"/>
-                    </a:lnL>
-                    <a:lnR w="3175" cap="flat" cmpd="sng" algn="ctr">
-                      <a:noFill/>
-                      <a:prstDash val="solid"/>
-                      <a:round/>
-                      <a:headEnd type="none" w="med" len="med"/>
-                      <a:tailEnd type="none" w="med" len="med"/>
-                    </a:lnR>
-                    <a:lnT w="12700" cap="flat" cmpd="sng" algn="ctr">
-                      <a:solidFill>
-                        <a:schemeClr val="tx1"/>
-                      </a:solidFill>
-                      <a:prstDash val="solid"/>
-                      <a:round/>
-                      <a:headEnd type="none" w="med" len="med"/>
-                      <a:tailEnd type="none" w="med" len="med"/>
-                    </a:lnT>
-                    <a:lnB w="3175" cap="flat" cmpd="sng" algn="ctr">
-                      <a:solidFill>
-                        <a:schemeClr val="tx1"/>
-                      </a:solidFill>
-                      <a:prstDash val="solid"/>
-                      <a:round/>
-                      <a:headEnd type="none" w="med" len="med"/>
-                      <a:tailEnd type="none" w="med" len="med"/>
-                    </a:lnB>
-                    <a:lnTlToBr w="12700" cmpd="sng">
-                      <a:noFill/>
-                      <a:prstDash val="solid"/>
-                    </a:lnTlToBr>
-                    <a:lnBlToTr w="12700" cmpd="sng">
-                      <a:noFill/>
-                      <a:prstDash val="solid"/>
-                    </a:lnBlToTr>
-                    <a:solidFill>
-                      <a:srgbClr val="92D050"/>
-                    </a:solidFill>
-                  </a:tcPr>
-                </a:tc>
-                <a:tc>
-                  <a:txBody>
-                    <a:bodyPr/>
-                    <a:lstStyle/>
-                    <a:p>
-                      <a:pPr algn="ctr"/>
-                      <a:r>
                         <a:rPr lang="en-IN" dirty="0">
                           <a:solidFill>
                             <a:srgbClr val="334155"/>
@@ -14289,70 +14185,6 @@
                           <a:latin typeface="Barlow Medium" panose="00000600000000000000" pitchFamily="2" charset="0"/>
                         </a:rPr>
                         <a:t>0.7031</a:t>
-                      </a:r>
-                    </a:p>
-                  </a:txBody>
-                  <a:tcPr anchor="ctr">
-                    <a:lnL w="3175" cap="flat" cmpd="sng" algn="ctr">
-                      <a:noFill/>
-                      <a:prstDash val="solid"/>
-                      <a:round/>
-                      <a:headEnd type="none" w="med" len="med"/>
-                      <a:tailEnd type="none" w="med" len="med"/>
-                    </a:lnL>
-                    <a:lnR w="3175" cap="flat" cmpd="sng" algn="ctr">
-                      <a:noFill/>
-                      <a:prstDash val="solid"/>
-                      <a:round/>
-                      <a:headEnd type="none" w="med" len="med"/>
-                      <a:tailEnd type="none" w="med" len="med"/>
-                    </a:lnR>
-                    <a:lnT w="3175" cap="flat" cmpd="sng" algn="ctr">
-                      <a:solidFill>
-                        <a:schemeClr val="tx1"/>
-                      </a:solidFill>
-                      <a:prstDash val="solid"/>
-                      <a:round/>
-                      <a:headEnd type="none" w="med" len="med"/>
-                      <a:tailEnd type="none" w="med" len="med"/>
-                    </a:lnT>
-                    <a:lnB w="3175" cap="flat" cmpd="sng" algn="ctr">
-                      <a:solidFill>
-                        <a:schemeClr val="tx1"/>
-                      </a:solidFill>
-                      <a:prstDash val="solid"/>
-                      <a:round/>
-                      <a:headEnd type="none" w="med" len="med"/>
-                      <a:tailEnd type="none" w="med" len="med"/>
-                    </a:lnB>
-                    <a:lnTlToBr w="12700" cmpd="sng">
-                      <a:noFill/>
-                      <a:prstDash val="solid"/>
-                    </a:lnTlToBr>
-                    <a:lnBlToTr w="12700" cmpd="sng">
-                      <a:noFill/>
-                      <a:prstDash val="solid"/>
-                    </a:lnBlToTr>
-                    <a:solidFill>
-                      <a:schemeClr val="bg1"/>
-                    </a:solidFill>
-                  </a:tcPr>
-                </a:tc>
-                <a:tc>
-                  <a:txBody>
-                    <a:bodyPr/>
-                    <a:lstStyle/>
-                    <a:p>
-                      <a:pPr algn="ctr"/>
-                      <a:r>
-                        <a:rPr lang="en-IN" dirty="0">
-                          <a:solidFill>
-                            <a:srgbClr val="334155"/>
-                          </a:solidFill>
-                          <a:effectLst/>
-                          <a:latin typeface="Barlow Medium" panose="00000600000000000000" pitchFamily="2" charset="0"/>
-                        </a:rPr>
-                        <a:t>0.4858</a:t>
                       </a:r>
                     </a:p>
                   </a:txBody>
@@ -14799,70 +14631,6 @@
                     <a:p>
                       <a:pPr algn="ctr"/>
                       <a:r>
-                        <a:rPr lang="en-IN" b="1" dirty="0">
-                          <a:solidFill>
-                            <a:srgbClr val="334155"/>
-                          </a:solidFill>
-                          <a:effectLst/>
-                          <a:latin typeface="Barlow Medium" panose="00000600000000000000" pitchFamily="2" charset="0"/>
-                        </a:rPr>
-                        <a:t>0.5005</a:t>
-                      </a:r>
-                    </a:p>
-                  </a:txBody>
-                  <a:tcPr anchor="ctr">
-                    <a:lnL w="3175" cap="flat" cmpd="sng" algn="ctr">
-                      <a:noFill/>
-                      <a:prstDash val="solid"/>
-                      <a:round/>
-                      <a:headEnd type="none" w="med" len="med"/>
-                      <a:tailEnd type="none" w="med" len="med"/>
-                    </a:lnL>
-                    <a:lnR w="3175" cap="flat" cmpd="sng" algn="ctr">
-                      <a:noFill/>
-                      <a:prstDash val="solid"/>
-                      <a:round/>
-                      <a:headEnd type="none" w="med" len="med"/>
-                      <a:tailEnd type="none" w="med" len="med"/>
-                    </a:lnR>
-                    <a:lnT w="3175" cap="flat" cmpd="sng" algn="ctr">
-                      <a:solidFill>
-                        <a:schemeClr val="tx1"/>
-                      </a:solidFill>
-                      <a:prstDash val="solid"/>
-                      <a:round/>
-                      <a:headEnd type="none" w="med" len="med"/>
-                      <a:tailEnd type="none" w="med" len="med"/>
-                    </a:lnT>
-                    <a:lnB w="3175" cap="flat" cmpd="sng" algn="ctr">
-                      <a:solidFill>
-                        <a:schemeClr val="tx1"/>
-                      </a:solidFill>
-                      <a:prstDash val="solid"/>
-                      <a:round/>
-                      <a:headEnd type="none" w="med" len="med"/>
-                      <a:tailEnd type="none" w="med" len="med"/>
-                    </a:lnB>
-                    <a:lnTlToBr w="12700" cmpd="sng">
-                      <a:noFill/>
-                      <a:prstDash val="solid"/>
-                    </a:lnTlToBr>
-                    <a:lnBlToTr w="12700" cmpd="sng">
-                      <a:noFill/>
-                      <a:prstDash val="solid"/>
-                    </a:lnBlToTr>
-                    <a:solidFill>
-                      <a:srgbClr val="92D050"/>
-                    </a:solidFill>
-                  </a:tcPr>
-                </a:tc>
-                <a:tc>
-                  <a:txBody>
-                    <a:bodyPr/>
-                    <a:lstStyle/>
-                    <a:p>
-                      <a:pPr algn="ctr"/>
-                      <a:r>
                         <a:rPr lang="en-IN" dirty="0">
                           <a:solidFill>
                             <a:srgbClr val="334155"/>
@@ -15187,70 +14955,6 @@
                           <a:latin typeface="Barlow Medium" panose="00000600000000000000" pitchFamily="2" charset="0"/>
                         </a:rPr>
                         <a:t>0.6909</a:t>
-                      </a:r>
-                    </a:p>
-                  </a:txBody>
-                  <a:tcPr anchor="ctr">
-                    <a:lnL w="3175" cap="flat" cmpd="sng" algn="ctr">
-                      <a:noFill/>
-                      <a:prstDash val="solid"/>
-                      <a:round/>
-                      <a:headEnd type="none" w="med" len="med"/>
-                      <a:tailEnd type="none" w="med" len="med"/>
-                    </a:lnL>
-                    <a:lnR w="3175" cap="flat" cmpd="sng" algn="ctr">
-                      <a:noFill/>
-                      <a:prstDash val="solid"/>
-                      <a:round/>
-                      <a:headEnd type="none" w="med" len="med"/>
-                      <a:tailEnd type="none" w="med" len="med"/>
-                    </a:lnR>
-                    <a:lnT w="3175" cap="flat" cmpd="sng" algn="ctr">
-                      <a:solidFill>
-                        <a:schemeClr val="tx1"/>
-                      </a:solidFill>
-                      <a:prstDash val="solid"/>
-                      <a:round/>
-                      <a:headEnd type="none" w="med" len="med"/>
-                      <a:tailEnd type="none" w="med" len="med"/>
-                    </a:lnT>
-                    <a:lnB w="3175" cap="flat" cmpd="sng" algn="ctr">
-                      <a:solidFill>
-                        <a:schemeClr val="tx1"/>
-                      </a:solidFill>
-                      <a:prstDash val="solid"/>
-                      <a:round/>
-                      <a:headEnd type="none" w="med" len="med"/>
-                      <a:tailEnd type="none" w="med" len="med"/>
-                    </a:lnB>
-                    <a:lnTlToBr w="12700" cmpd="sng">
-                      <a:noFill/>
-                      <a:prstDash val="solid"/>
-                    </a:lnTlToBr>
-                    <a:lnBlToTr w="12700" cmpd="sng">
-                      <a:noFill/>
-                      <a:prstDash val="solid"/>
-                    </a:lnBlToTr>
-                    <a:solidFill>
-                      <a:schemeClr val="bg1"/>
-                    </a:solidFill>
-                  </a:tcPr>
-                </a:tc>
-                <a:tc>
-                  <a:txBody>
-                    <a:bodyPr/>
-                    <a:lstStyle/>
-                    <a:p>
-                      <a:pPr algn="ctr"/>
-                      <a:r>
-                        <a:rPr lang="en-IN" dirty="0">
-                          <a:solidFill>
-                            <a:srgbClr val="334155"/>
-                          </a:solidFill>
-                          <a:effectLst/>
-                          <a:latin typeface="Barlow Medium" panose="00000600000000000000" pitchFamily="2" charset="0"/>
-                        </a:rPr>
-                        <a:t>0.4921</a:t>
                       </a:r>
                     </a:p>
                   </a:txBody>
@@ -15636,70 +15340,6 @@
                           <a:latin typeface="Barlow Medium" panose="00000600000000000000" pitchFamily="2" charset="0"/>
                         </a:rPr>
                         <a:t>0.7105</a:t>
-                      </a:r>
-                    </a:p>
-                  </a:txBody>
-                  <a:tcPr anchor="ctr">
-                    <a:lnL w="3175" cap="flat" cmpd="sng" algn="ctr">
-                      <a:noFill/>
-                      <a:prstDash val="solid"/>
-                      <a:round/>
-                      <a:headEnd type="none" w="med" len="med"/>
-                      <a:tailEnd type="none" w="med" len="med"/>
-                    </a:lnL>
-                    <a:lnR w="3175" cap="flat" cmpd="sng" algn="ctr">
-                      <a:noFill/>
-                      <a:prstDash val="solid"/>
-                      <a:round/>
-                      <a:headEnd type="none" w="med" len="med"/>
-                      <a:tailEnd type="none" w="med" len="med"/>
-                    </a:lnR>
-                    <a:lnT w="3175" cap="flat" cmpd="sng" algn="ctr">
-                      <a:solidFill>
-                        <a:schemeClr val="tx1"/>
-                      </a:solidFill>
-                      <a:prstDash val="solid"/>
-                      <a:round/>
-                      <a:headEnd type="none" w="med" len="med"/>
-                      <a:tailEnd type="none" w="med" len="med"/>
-                    </a:lnT>
-                    <a:lnB w="3175" cap="flat" cmpd="sng" algn="ctr">
-                      <a:solidFill>
-                        <a:schemeClr val="tx1"/>
-                      </a:solidFill>
-                      <a:prstDash val="solid"/>
-                      <a:round/>
-                      <a:headEnd type="none" w="med" len="med"/>
-                      <a:tailEnd type="none" w="med" len="med"/>
-                    </a:lnB>
-                    <a:lnTlToBr w="12700" cmpd="sng">
-                      <a:noFill/>
-                      <a:prstDash val="solid"/>
-                    </a:lnTlToBr>
-                    <a:lnBlToTr w="12700" cmpd="sng">
-                      <a:noFill/>
-                      <a:prstDash val="solid"/>
-                    </a:lnBlToTr>
-                    <a:solidFill>
-                      <a:schemeClr val="bg1"/>
-                    </a:solidFill>
-                  </a:tcPr>
-                </a:tc>
-                <a:tc>
-                  <a:txBody>
-                    <a:bodyPr/>
-                    <a:lstStyle/>
-                    <a:p>
-                      <a:pPr algn="ctr"/>
-                      <a:r>
-                        <a:rPr lang="en-IN">
-                          <a:solidFill>
-                            <a:srgbClr val="334155"/>
-                          </a:solidFill>
-                          <a:effectLst/>
-                          <a:latin typeface="Barlow Medium" panose="00000600000000000000" pitchFamily="2" charset="0"/>
-                        </a:rPr>
-                        <a:t>0.5066</a:t>
                       </a:r>
                     </a:p>
                   </a:txBody>
@@ -16162,82 +15802,6 @@
                           <a:effectLst/>
                           <a:latin typeface="Barlow Medium" panose="00000600000000000000" pitchFamily="2" charset="0"/>
                         </a:rPr>
-                        <a:t>0.5121</a:t>
-                      </a:r>
-                      <a:endParaRPr lang="en-IN" dirty="0">
-                        <a:solidFill>
-                          <a:srgbClr val="334155"/>
-                        </a:solidFill>
-                        <a:effectLst/>
-                        <a:latin typeface="Barlow Medium" panose="00000600000000000000" pitchFamily="2" charset="0"/>
-                      </a:endParaRPr>
-                    </a:p>
-                  </a:txBody>
-                  <a:tcPr anchor="ctr">
-                    <a:lnL w="3175" cap="flat" cmpd="sng" algn="ctr">
-                      <a:noFill/>
-                      <a:prstDash val="solid"/>
-                      <a:round/>
-                      <a:headEnd type="none" w="med" len="med"/>
-                      <a:tailEnd type="none" w="med" len="med"/>
-                    </a:lnL>
-                    <a:lnR w="3175" cap="flat" cmpd="sng" algn="ctr">
-                      <a:noFill/>
-                      <a:prstDash val="solid"/>
-                      <a:round/>
-                      <a:headEnd type="none" w="med" len="med"/>
-                      <a:tailEnd type="none" w="med" len="med"/>
-                    </a:lnR>
-                    <a:lnT w="3175" cap="flat" cmpd="sng" algn="ctr">
-                      <a:solidFill>
-                        <a:schemeClr val="tx1"/>
-                      </a:solidFill>
-                      <a:prstDash val="solid"/>
-                      <a:round/>
-                      <a:headEnd type="none" w="med" len="med"/>
-                      <a:tailEnd type="none" w="med" len="med"/>
-                    </a:lnT>
-                    <a:lnB w="9525" cap="rnd" cmpd="sng" algn="ctr">
-                      <a:noFill/>
-                      <a:prstDash val="solid"/>
-                    </a:lnB>
-                    <a:lnTlToBr w="12700" cmpd="sng">
-                      <a:noFill/>
-                      <a:prstDash val="solid"/>
-                    </a:lnTlToBr>
-                    <a:lnBlToTr w="12700" cmpd="sng">
-                      <a:noFill/>
-                      <a:prstDash val="solid"/>
-                    </a:lnBlToTr>
-                    <a:solidFill>
-                      <a:srgbClr val="92D050"/>
-                    </a:solidFill>
-                  </a:tcPr>
-                </a:tc>
-                <a:tc>
-                  <a:txBody>
-                    <a:bodyPr/>
-                    <a:lstStyle/>
-                    <a:p>
-                      <a:pPr algn="ctr"/>
-                      <a:r>
-                        <a:rPr lang="en-IN" dirty="0">
-                          <a:solidFill>
-                            <a:srgbClr val="334155"/>
-                          </a:solidFill>
-                          <a:effectLst/>
-                          <a:latin typeface="Barlow Medium" panose="00000600000000000000" pitchFamily="2" charset="0"/>
-                        </a:rPr>
-                        <a:t>🏆</a:t>
-                      </a:r>
-                      <a:r>
-                        <a:rPr lang="en-IN" b="1" dirty="0">
-                          <a:solidFill>
-                            <a:srgbClr val="334155"/>
-                          </a:solidFill>
-                          <a:effectLst/>
-                          <a:latin typeface="Barlow Medium" panose="00000600000000000000" pitchFamily="2" charset="0"/>
-                        </a:rPr>
                         <a:t>0.5988</a:t>
                       </a:r>
                       <a:endParaRPr lang="en-IN" dirty="0">
@@ -16446,7 +16010,7 @@
         </p:nvSpPr>
         <p:spPr>
           <a:xfrm>
-            <a:off x="2558643" y="5839722"/>
+            <a:off x="3161617" y="5707201"/>
             <a:ext cx="6274964" cy="707886"/>
           </a:xfrm>
           <a:prstGeom prst="rect">
@@ -16480,7 +16044,7 @@
               <a:rPr lang="en-GB" sz="2000" b="1" dirty="0">
                 <a:latin typeface="Barlow SemiBold" panose="00000700000000000000" pitchFamily="2" charset="0"/>
               </a:rPr>
-              <a:t>🏆 Overall Winner: ModernBERT + Lion achieved highest performance in 4/5 metrics</a:t>
+              <a:t>🏆 Overall Winner: (ModernBERT + Lion) achieved highest performance in 3/4 metrics</a:t>
             </a:r>
             <a:endParaRPr lang="en-IN" sz="2000" dirty="0">
               <a:latin typeface="Barlow SemiBold" panose="00000700000000000000" pitchFamily="2" charset="0"/>
@@ -20406,7 +19970,7 @@
 </file>
 
 <file path=ppt/slides/slide25.xml><?xml version="1.0" encoding="utf-8"?>
-<p:sld xmlns:a="http://schemas.openxmlformats.org/drawingml/2006/main" xmlns:r="http://schemas.openxmlformats.org/officeDocument/2006/relationships" xmlns:p="http://schemas.openxmlformats.org/presentationml/2006/main">
+<p:sld xmlns:a="http://schemas.openxmlformats.org/drawingml/2006/main" xmlns:r="http://schemas.openxmlformats.org/officeDocument/2006/relationships" xmlns:p="http://schemas.openxmlformats.org/presentationml/2006/main" show="0">
   <p:cSld>
     <p:spTree>
       <p:nvGrpSpPr>
@@ -20469,7 +20033,7 @@
 </file>
 
 <file path=ppt/slides/slide26.xml><?xml version="1.0" encoding="utf-8"?>
-<p:sld xmlns:a="http://schemas.openxmlformats.org/drawingml/2006/main" xmlns:r="http://schemas.openxmlformats.org/officeDocument/2006/relationships" xmlns:p="http://schemas.openxmlformats.org/presentationml/2006/main">
+<p:sld xmlns:a="http://schemas.openxmlformats.org/drawingml/2006/main" xmlns:r="http://schemas.openxmlformats.org/officeDocument/2006/relationships" xmlns:p="http://schemas.openxmlformats.org/presentationml/2006/main" show="0">
   <p:cSld>
     <p:spTree>
       <p:nvGrpSpPr>
@@ -21523,13 +21087,33 @@
             </a:r>
             <a:r>
               <a:rPr lang="en-GB" b="1" i="1" baseline="30000" dirty="0">
+                <a:solidFill>
+                  <a:srgbClr val="FF0000"/>
+                </a:solidFill>
                 <a:latin typeface="Barlow Medium" panose="00000600000000000000" pitchFamily="2" charset="0"/>
+                <a:hlinkClick r:id="rId3" action="ppaction://hlinksldjump">
+                  <a:extLst>
+                    <a:ext uri="{A12FA001-AC4F-418D-AE19-62706E023703}">
+                      <ahyp:hlinkClr xmlns:ahyp="http://schemas.microsoft.com/office/drawing/2018/hyperlinkcolor" val="tx"/>
+                    </a:ext>
+                  </a:extLst>
+                </a:hlinkClick>
               </a:rPr>
               <a:t>[4]</a:t>
             </a:r>
             <a:r>
               <a:rPr lang="en-GB" b="1" i="1" dirty="0">
+                <a:solidFill>
+                  <a:srgbClr val="FF0000"/>
+                </a:solidFill>
                 <a:latin typeface="Barlow Medium" panose="00000600000000000000" pitchFamily="2" charset="0"/>
+                <a:hlinkClick r:id="rId3" action="ppaction://hlinksldjump">
+                  <a:extLst>
+                    <a:ext uri="{A12FA001-AC4F-418D-AE19-62706E023703}">
+                      <ahyp:hlinkClr xmlns:ahyp="http://schemas.microsoft.com/office/drawing/2018/hyperlinkcolor" val="tx"/>
+                    </a:ext>
+                  </a:extLst>
+                </a:hlinkClick>
               </a:rPr>
               <a:t> </a:t>
             </a:r>
@@ -21544,13 +21128,33 @@
             </a:r>
             <a:r>
               <a:rPr lang="en-GB" b="1" i="1" baseline="30000" dirty="0">
+                <a:solidFill>
+                  <a:srgbClr val="FF0000"/>
+                </a:solidFill>
                 <a:latin typeface="Barlow Medium" panose="00000600000000000000" pitchFamily="2" charset="0"/>
+                <a:hlinkClick r:id="rId3" action="ppaction://hlinksldjump">
+                  <a:extLst>
+                    <a:ext uri="{A12FA001-AC4F-418D-AE19-62706E023703}">
+                      <ahyp:hlinkClr xmlns:ahyp="http://schemas.microsoft.com/office/drawing/2018/hyperlinkcolor" val="tx"/>
+                    </a:ext>
+                  </a:extLst>
+                </a:hlinkClick>
               </a:rPr>
               <a:t>[3]</a:t>
             </a:r>
             <a:r>
               <a:rPr lang="en-GB" b="1" i="1" dirty="0">
+                <a:solidFill>
+                  <a:srgbClr val="FF0000"/>
+                </a:solidFill>
                 <a:latin typeface="Barlow Medium" panose="00000600000000000000" pitchFamily="2" charset="0"/>
+                <a:hlinkClick r:id="rId3" action="ppaction://hlinksldjump">
+                  <a:extLst>
+                    <a:ext uri="{A12FA001-AC4F-418D-AE19-62706E023703}">
+                      <ahyp:hlinkClr xmlns:ahyp="http://schemas.microsoft.com/office/drawing/2018/hyperlinkcolor" val="tx"/>
+                    </a:ext>
+                  </a:extLst>
+                </a:hlinkClick>
               </a:rPr>
               <a:t> </a:t>
             </a:r>

</xml_diff>

<commit_message>
Update performance metrics and optimize model choices in thesis presentation
</commit_message>
<xml_diff>
--- a/cross_encoder/thesis/Thesis_presentation.pptx
+++ b/cross_encoder/thesis/Thesis_presentation.pptx
@@ -244,7 +244,7 @@
           <a:p>
             <a:fld id="{8E836F02-AF67-416B-AB85-08CFF698F86D}" type="datetimeFigureOut">
               <a:rPr lang="en-US" smtClean="0"/>
-              <a:t>6/22/2025</a:t>
+              <a:t>6/25/2025</a:t>
             </a:fld>
             <a:endParaRPr lang="en-US" dirty="0"/>
           </a:p>
@@ -421,7 +421,7 @@
           <a:p>
             <a:fld id="{45B7E8F0-931C-4E43-98D1-A3CD0E0034DC}" type="datetimeFigureOut">
               <a:rPr lang="en-US" smtClean="0"/>
-              <a:t>6/22/2025</a:t>
+              <a:t>6/25/2025</a:t>
             </a:fld>
             <a:endParaRPr lang="en-US" dirty="0"/>
           </a:p>
@@ -2771,7 +2771,7 @@
           </a:effectLst>
           <a:extLst>
             <a:ext uri="{91240B29-F687-4f45-9708-019B960494DF}">
-              <a14:hiddenLine xmlns:a14="http://schemas.microsoft.com/office/drawing/2010/main" xmlns="" w="9525">
+              <a14:hiddenLine xmlns="" xmlns:a14="http://schemas.microsoft.com/office/drawing/2010/main" w="9525">
                 <a:solidFill>
                   <a:srgbClr val="000000"/>
                 </a:solidFill>
@@ -2963,7 +2963,7 @@
           <a:p>
             <a:fld id="{FB7F6C47-B260-4BB6-8230-7D14D5CDE026}" type="datetimeFigureOut">
               <a:rPr lang="en-US" noProof="0" smtClean="0"/>
-              <a:t>6/22/2025</a:t>
+              <a:t>6/25/2025</a:t>
             </a:fld>
             <a:endParaRPr lang="en-US" noProof="0" dirty="0"/>
           </a:p>
@@ -3322,7 +3322,7 @@
           <a:p>
             <a:fld id="{FB7F6C47-B260-4BB6-8230-7D14D5CDE026}" type="datetimeFigureOut">
               <a:rPr lang="en-US" noProof="0" smtClean="0"/>
-              <a:t>6/22/2025</a:t>
+              <a:t>6/25/2025</a:t>
             </a:fld>
             <a:endParaRPr lang="en-US" noProof="0" dirty="0"/>
           </a:p>
@@ -3499,7 +3499,7 @@
           </a:effectLst>
           <a:extLst>
             <a:ext uri="{91240B29-F687-4f45-9708-019B960494DF}">
-              <a14:hiddenLine xmlns:a14="http://schemas.microsoft.com/office/drawing/2010/main" xmlns="" w="9525">
+              <a14:hiddenLine xmlns="" xmlns:a14="http://schemas.microsoft.com/office/drawing/2010/main" w="9525">
                 <a:solidFill>
                   <a:srgbClr val="000000"/>
                 </a:solidFill>
@@ -3827,7 +3827,7 @@
           <a:p>
             <a:fld id="{FB7F6C47-B260-4BB6-8230-7D14D5CDE026}" type="datetimeFigureOut">
               <a:rPr lang="en-US" noProof="0" smtClean="0"/>
-              <a:t>6/22/2025</a:t>
+              <a:t>6/25/2025</a:t>
             </a:fld>
             <a:endParaRPr lang="en-US" noProof="0" dirty="0"/>
           </a:p>
@@ -4004,7 +4004,7 @@
           </a:effectLst>
           <a:extLst>
             <a:ext uri="{91240B29-F687-4f45-9708-019B960494DF}">
-              <a14:hiddenLine xmlns:a14="http://schemas.microsoft.com/office/drawing/2010/main" xmlns="" w="9525">
+              <a14:hiddenLine xmlns="" xmlns:a14="http://schemas.microsoft.com/office/drawing/2010/main" w="9525">
                 <a:solidFill>
                   <a:srgbClr val="000000"/>
                 </a:solidFill>
@@ -4079,7 +4079,7 @@
           <a:p>
             <a:fld id="{FB7F6C47-B260-4BB6-8230-7D14D5CDE026}" type="datetimeFigureOut">
               <a:rPr lang="en-US" noProof="0" smtClean="0"/>
-              <a:t>6/22/2025</a:t>
+              <a:t>6/25/2025</a:t>
             </a:fld>
             <a:endParaRPr lang="en-US" noProof="0" dirty="0"/>
           </a:p>
@@ -4195,7 +4195,7 @@
           <a:p>
             <a:fld id="{FB7F6C47-B260-4BB6-8230-7D14D5CDE026}" type="datetimeFigureOut">
               <a:rPr lang="en-US" noProof="0" smtClean="0"/>
-              <a:t>6/22/2025</a:t>
+              <a:t>6/25/2025</a:t>
             </a:fld>
             <a:endParaRPr lang="en-US" noProof="0" dirty="0"/>
           </a:p>
@@ -4483,7 +4483,7 @@
           </a:effectLst>
           <a:extLst>
             <a:ext uri="{91240B29-F687-4f45-9708-019B960494DF}">
-              <a14:hiddenLine xmlns:a14="http://schemas.microsoft.com/office/drawing/2010/main" xmlns="" w="9525">
+              <a14:hiddenLine xmlns="" xmlns:a14="http://schemas.microsoft.com/office/drawing/2010/main" w="9525">
                 <a:solidFill>
                   <a:srgbClr val="000000"/>
                 </a:solidFill>
@@ -4688,7 +4688,7 @@
           <a:p>
             <a:fld id="{FB7F6C47-B260-4BB6-8230-7D14D5CDE026}" type="datetimeFigureOut">
               <a:rPr lang="en-US" noProof="0" smtClean="0"/>
-              <a:t>6/22/2025</a:t>
+              <a:t>6/25/2025</a:t>
             </a:fld>
             <a:endParaRPr lang="en-US" noProof="0" dirty="0"/>
           </a:p>
@@ -5203,7 +5203,7 @@
           <a:p>
             <a:fld id="{FB7F6C47-B260-4BB6-8230-7D14D5CDE026}" type="datetimeFigureOut">
               <a:rPr lang="en-US" noProof="0" smtClean="0"/>
-              <a:t>6/22/2025</a:t>
+              <a:t>6/25/2025</a:t>
             </a:fld>
             <a:endParaRPr lang="en-US" noProof="0" dirty="0"/>
           </a:p>
@@ -5599,7 +5599,7 @@
           <a:p>
             <a:fld id="{FB7F6C47-B260-4BB6-8230-7D14D5CDE026}" type="datetimeFigureOut">
               <a:rPr lang="en-US" noProof="0" smtClean="0"/>
-              <a:t>6/22/2025</a:t>
+              <a:t>6/25/2025</a:t>
             </a:fld>
             <a:endParaRPr lang="en-US" noProof="0" dirty="0"/>
           </a:p>
@@ -5778,7 +5778,7 @@
           </a:effectLst>
           <a:extLst>
             <a:ext uri="{91240B29-F687-4f45-9708-019B960494DF}">
-              <a14:hiddenLine xmlns:a14="http://schemas.microsoft.com/office/drawing/2010/main" xmlns="" w="9525">
+              <a14:hiddenLine xmlns="" xmlns:a14="http://schemas.microsoft.com/office/drawing/2010/main" w="9525">
                 <a:solidFill>
                   <a:srgbClr val="000000"/>
                 </a:solidFill>
@@ -5930,7 +5930,7 @@
           <a:p>
             <a:fld id="{FB7F6C47-B260-4BB6-8230-7D14D5CDE026}" type="datetimeFigureOut">
               <a:rPr lang="en-US" noProof="0" smtClean="0"/>
-              <a:t>6/22/2025</a:t>
+              <a:t>6/25/2025</a:t>
             </a:fld>
             <a:endParaRPr lang="en-US" noProof="0" dirty="0"/>
           </a:p>
@@ -6107,7 +6107,7 @@
           </a:effectLst>
           <a:extLst>
             <a:ext uri="{91240B29-F687-4f45-9708-019B960494DF}">
-              <a14:hiddenLine xmlns:a14="http://schemas.microsoft.com/office/drawing/2010/main" xmlns="" w="9525">
+              <a14:hiddenLine xmlns="" xmlns:a14="http://schemas.microsoft.com/office/drawing/2010/main" w="9525">
                 <a:solidFill>
                   <a:srgbClr val="000000"/>
                 </a:solidFill>
@@ -6328,7 +6328,7 @@
           <a:p>
             <a:fld id="{FB7F6C47-B260-4BB6-8230-7D14D5CDE026}" type="datetimeFigureOut">
               <a:rPr lang="en-US" noProof="0" smtClean="0"/>
-              <a:t>6/22/2025</a:t>
+              <a:t>6/25/2025</a:t>
             </a:fld>
             <a:endParaRPr lang="en-US" noProof="0" dirty="0"/>
           </a:p>
@@ -6580,7 +6580,7 @@
           <a:p>
             <a:fld id="{FB7F6C47-B260-4BB6-8230-7D14D5CDE026}" type="datetimeFigureOut">
               <a:rPr lang="en-US" noProof="0" smtClean="0"/>
-              <a:t>6/22/2025</a:t>
+              <a:t>6/25/2025</a:t>
             </a:fld>
             <a:endParaRPr lang="en-US" noProof="0" dirty="0"/>
           </a:p>
@@ -6757,7 +6757,7 @@
           </a:effectLst>
           <a:extLst>
             <a:ext uri="{91240B29-F687-4f45-9708-019B960494DF}">
-              <a14:hiddenLine xmlns:a14="http://schemas.microsoft.com/office/drawing/2010/main" xmlns="" w="9525">
+              <a14:hiddenLine xmlns="" xmlns:a14="http://schemas.microsoft.com/office/drawing/2010/main" w="9525">
                 <a:solidFill>
                   <a:srgbClr val="000000"/>
                 </a:solidFill>
@@ -7000,7 +7000,7 @@
           <a:p>
             <a:fld id="{FB7F6C47-B260-4BB6-8230-7D14D5CDE026}" type="datetimeFigureOut">
               <a:rPr lang="en-US" noProof="0" smtClean="0"/>
-              <a:t>6/22/2025</a:t>
+              <a:t>6/25/2025</a:t>
             </a:fld>
             <a:endParaRPr lang="en-US" noProof="0" dirty="0"/>
           </a:p>
@@ -7177,7 +7177,7 @@
           </a:effectLst>
           <a:extLst>
             <a:ext uri="{91240B29-F687-4f45-9708-019B960494DF}">
-              <a14:hiddenLine xmlns:a14="http://schemas.microsoft.com/office/drawing/2010/main" xmlns="" w="9525">
+              <a14:hiddenLine xmlns="" xmlns:a14="http://schemas.microsoft.com/office/drawing/2010/main" w="9525">
                 <a:solidFill>
                   <a:srgbClr val="000000"/>
                 </a:solidFill>
@@ -7414,7 +7414,7 @@
           <a:p>
             <a:fld id="{FB7F6C47-B260-4BB6-8230-7D14D5CDE026}" type="datetimeFigureOut">
               <a:rPr lang="en-US" noProof="0" smtClean="0"/>
-              <a:t>6/22/2025</a:t>
+              <a:t>6/25/2025</a:t>
             </a:fld>
             <a:endParaRPr lang="en-US" noProof="0" dirty="0"/>
           </a:p>
@@ -7837,7 +7837,7 @@
           <a:p>
             <a:fld id="{FB7F6C47-B260-4BB6-8230-7D14D5CDE026}" type="datetimeFigureOut">
               <a:rPr lang="en-US" noProof="0" smtClean="0"/>
-              <a:t>6/22/2025</a:t>
+              <a:t>6/25/2025</a:t>
             </a:fld>
             <a:endParaRPr lang="en-US" noProof="0" dirty="0"/>
           </a:p>
@@ -8014,7 +8014,7 @@
           </a:effectLst>
           <a:extLst>
             <a:ext uri="{91240B29-F687-4f45-9708-019B960494DF}">
-              <a14:hiddenLine xmlns:a14="http://schemas.microsoft.com/office/drawing/2010/main" xmlns="" w="9525">
+              <a14:hiddenLine xmlns="" xmlns:a14="http://schemas.microsoft.com/office/drawing/2010/main" w="9525">
                 <a:solidFill>
                   <a:srgbClr val="000000"/>
                 </a:solidFill>
@@ -8164,7 +8164,7 @@
           <a:p>
             <a:fld id="{FB7F6C47-B260-4BB6-8230-7D14D5CDE026}" type="datetimeFigureOut">
               <a:rPr lang="en-US" noProof="0" smtClean="0"/>
-              <a:t>6/22/2025</a:t>
+              <a:t>6/25/2025</a:t>
             </a:fld>
             <a:endParaRPr lang="en-US" noProof="0" dirty="0"/>
           </a:p>
@@ -8728,7 +8728,7 @@
           <a:p>
             <a:fld id="{FB7F6C47-B260-4BB6-8230-7D14D5CDE026}" type="datetimeFigureOut">
               <a:rPr lang="en-US" noProof="0" smtClean="0"/>
-              <a:t>6/22/2025</a:t>
+              <a:t>6/25/2025</a:t>
             </a:fld>
             <a:endParaRPr lang="en-US" noProof="0" dirty="0"/>
           </a:p>
@@ -8905,7 +8905,7 @@
           </a:effectLst>
           <a:extLst>
             <a:ext uri="{91240B29-F687-4f45-9708-019B960494DF}">
-              <a14:hiddenLine xmlns:a14="http://schemas.microsoft.com/office/drawing/2010/main" xmlns="" w="9525">
+              <a14:hiddenLine xmlns="" xmlns:a14="http://schemas.microsoft.com/office/drawing/2010/main" w="9525">
                 <a:solidFill>
                   <a:srgbClr val="000000"/>
                 </a:solidFill>
@@ -9043,7 +9043,7 @@
           <a:p>
             <a:fld id="{FB7F6C47-B260-4BB6-8230-7D14D5CDE026}" type="datetimeFigureOut">
               <a:rPr lang="en-US" noProof="0" smtClean="0"/>
-              <a:t>6/22/2025</a:t>
+              <a:t>6/25/2025</a:t>
             </a:fld>
             <a:endParaRPr lang="en-US" noProof="0" dirty="0"/>
           </a:p>
@@ -9307,7 +9307,7 @@
           <a:p>
             <a:fld id="{FB7F6C47-B260-4BB6-8230-7D14D5CDE026}" type="datetimeFigureOut">
               <a:rPr lang="en-US" noProof="0" smtClean="0"/>
-              <a:t>6/22/2025</a:t>
+              <a:t>6/25/2025</a:t>
             </a:fld>
             <a:endParaRPr lang="en-US" noProof="0" dirty="0"/>
           </a:p>
@@ -13386,7 +13386,7 @@
           <p:nvPr>
             <p:extLst>
               <p:ext uri="{D42A27DB-BD31-4B8C-83A1-F6EECF244321}">
-                <p14:modId xmlns:p14="http://schemas.microsoft.com/office/powerpoint/2010/main" val="1126788479"/>
+                <p14:modId xmlns:p14="http://schemas.microsoft.com/office/powerpoint/2010/main" val="2830339552"/>
               </p:ext>
             </p:extLst>
           </p:nvPr>
@@ -13797,7 +13797,7 @@
                     <a:p>
                       <a:pPr algn="ctr"/>
                       <a:r>
-                        <a:rPr lang="en-IN" b="1" dirty="0">
+                        <a:rPr lang="en-IN" b="0" dirty="0">
                           <a:solidFill>
                             <a:srgbClr val="334155"/>
                           </a:solidFill>
@@ -13850,7 +13850,7 @@
                       <a:prstDash val="solid"/>
                     </a:lnBlToTr>
                     <a:solidFill>
-                      <a:srgbClr val="92D050"/>
+                      <a:schemeClr val="bg1"/>
                     </a:solidFill>
                   </a:tcPr>
                 </a:tc>
@@ -13932,7 +13932,7 @@
                           <a:effectLst/>
                           <a:latin typeface="Barlow Medium" panose="00000600000000000000" pitchFamily="2" charset="0"/>
                         </a:rPr>
-                        <a:t>0.1715</a:t>
+                        <a:t>0.1706</a:t>
                       </a:r>
                     </a:p>
                   </a:txBody>
@@ -13996,7 +13996,7 @@
                           <a:effectLst/>
                           <a:latin typeface="Barlow Medium" panose="00000600000000000000" pitchFamily="2" charset="0"/>
                         </a:rPr>
-                        <a:t>0.8093</a:t>
+                        <a:t>0.8023</a:t>
                       </a:r>
                     </a:p>
                   </a:txBody>
@@ -14184,7 +14184,7 @@
                           <a:effectLst/>
                           <a:latin typeface="Barlow Medium" panose="00000600000000000000" pitchFamily="2" charset="0"/>
                         </a:rPr>
-                        <a:t>0.7031</a:t>
+                        <a:t>0.6808</a:t>
                       </a:r>
                     </a:p>
                   </a:txBody>
@@ -14240,6 +14240,16 @@
                     <a:lstStyle/>
                     <a:p>
                       <a:pPr algn="ctr"/>
+                      <a:r>
+                        <a:rPr lang="en-IN" dirty="0">
+                          <a:solidFill>
+                            <a:srgbClr val="334155"/>
+                          </a:solidFill>
+                          <a:effectLst/>
+                          <a:latin typeface="Barlow Medium" panose="00000600000000000000" pitchFamily="2" charset="0"/>
+                        </a:rPr>
+                        <a:t>🏆</a:t>
+                      </a:r>
                       <a:r>
                         <a:rPr lang="en-IN" b="1" dirty="0">
                           <a:solidFill>
@@ -14312,7 +14322,7 @@
                           <a:effectLst/>
                           <a:latin typeface="Barlow Medium" panose="00000600000000000000" pitchFamily="2" charset="0"/>
                         </a:rPr>
-                        <a:t>0.1724</a:t>
+                        <a:t>0.1701</a:t>
                       </a:r>
                     </a:p>
                   </a:txBody>
@@ -14369,14 +14379,14 @@
                     <a:p>
                       <a:pPr algn="ctr"/>
                       <a:r>
-                        <a:rPr lang="en-IN">
+                        <a:rPr lang="en-IN" dirty="0">
                           <a:solidFill>
                             <a:srgbClr val="334155"/>
                           </a:solidFill>
                           <a:effectLst/>
                           <a:latin typeface="Barlow Medium" panose="00000600000000000000" pitchFamily="2" charset="0"/>
                         </a:rPr>
-                        <a:t>0.8116</a:t>
+                        <a:t>0.8023</a:t>
                       </a:r>
                     </a:p>
                   </a:txBody>
@@ -14567,7 +14577,7 @@
                     <a:p>
                       <a:pPr algn="ctr"/>
                       <a:r>
-                        <a:rPr lang="en-IN" b="1" dirty="0">
+                        <a:rPr lang="en-IN" b="0" dirty="0">
                           <a:solidFill>
                             <a:srgbClr val="334155"/>
                           </a:solidFill>
@@ -14620,7 +14630,7 @@
                       <a:prstDash val="solid"/>
                     </a:lnBlToTr>
                     <a:solidFill>
-                      <a:srgbClr val="92D050"/>
+                      <a:schemeClr val="bg1"/>
                     </a:solidFill>
                   </a:tcPr>
                 </a:tc>
@@ -14694,6 +14704,16 @@
                     <a:lstStyle/>
                     <a:p>
                       <a:pPr algn="ctr"/>
+                      <a:r>
+                        <a:rPr lang="en-IN" dirty="0">
+                          <a:solidFill>
+                            <a:srgbClr val="334155"/>
+                          </a:solidFill>
+                          <a:effectLst/>
+                          <a:latin typeface="Barlow Medium" panose="00000600000000000000" pitchFamily="2" charset="0"/>
+                        </a:rPr>
+                        <a:t>🏆</a:t>
+                      </a:r>
                       <a:r>
                         <a:rPr lang="en-IN" b="1" dirty="0">
                           <a:solidFill>
@@ -15861,7 +15881,7 @@
                     <a:p>
                       <a:pPr algn="ctr"/>
                       <a:r>
-                        <a:rPr lang="en-IN" dirty="0">
+                        <a:rPr lang="en-IN" b="1" dirty="0">
                           <a:solidFill>
                             <a:srgbClr val="334155"/>
                           </a:solidFill>
@@ -15909,7 +15929,7 @@
                       <a:prstDash val="solid"/>
                     </a:lnBlToTr>
                     <a:solidFill>
-                      <a:srgbClr val="92D050"/>
+                      <a:schemeClr val="bg1"/>
                     </a:solidFill>
                   </a:tcPr>
                 </a:tc>
@@ -18883,7 +18903,7 @@
           <p:nvPr>
             <p:extLst>
               <p:ext uri="{D42A27DB-BD31-4B8C-83A1-F6EECF244321}">
-                <p14:modId xmlns:p14="http://schemas.microsoft.com/office/powerpoint/2010/main" val="3211580055"/>
+                <p14:modId xmlns:p14="http://schemas.microsoft.com/office/powerpoint/2010/main" val="3035780364"/>
               </p:ext>
             </p:extLst>
           </p:nvPr>
@@ -19115,18 +19135,15 @@
                           <a:effectLst/>
                           <a:latin typeface="Barlow" panose="00000500000000000000" pitchFamily="2" charset="0"/>
                         </a:rPr>
-                        <a:t>A</a:t>
+                        <a:t>Lion</a:t>
                       </a:r>
-                      <a:r>
-                        <a:rPr lang="en-IN" sz="2000" dirty="0">
-                          <a:solidFill>
-                            <a:srgbClr val="334155"/>
-                          </a:solidFill>
-                          <a:effectLst/>
-                          <a:latin typeface="Barlow" panose="00000500000000000000" pitchFamily="2" charset="0"/>
-                        </a:rPr>
-                        <a:t>damW</a:t>
-                      </a:r>
+                      <a:endParaRPr lang="en-IN" sz="2000" dirty="0">
+                        <a:solidFill>
+                          <a:srgbClr val="334155"/>
+                        </a:solidFill>
+                        <a:effectLst/>
+                        <a:latin typeface="Barlow" panose="00000500000000000000" pitchFamily="2" charset="0"/>
+                      </a:endParaRPr>
                     </a:p>
                   </a:txBody>
                   <a:tcPr anchor="ctr">
@@ -19471,7 +19488,7 @@
                           <a:effectLst/>
                           <a:latin typeface="Barlow" panose="00000500000000000000" pitchFamily="2" charset="0"/>
                         </a:rPr>
-                        <a:t>Lion</a:t>
+                        <a:t>AdamW</a:t>
                       </a:r>
                     </a:p>
                   </a:txBody>
@@ -22034,23 +22051,7 @@
                   </a:extLst>
                 </a:hlinkClick>
               </a:rPr>
-              <a:t>,</a:t>
-            </a:r>
-            <a:r>
-              <a:rPr lang="en-IN" sz="2000" dirty="0">
-                <a:solidFill>
-                  <a:srgbClr val="FF0000"/>
-                </a:solidFill>
-                <a:latin typeface="Barlow" panose="00000500000000000000" pitchFamily="2" charset="0"/>
-                <a:hlinkClick r:id="rId3" action="ppaction://hlinksldjump">
-                  <a:extLst>
-                    <a:ext uri="{A12FA001-AC4F-418D-AE19-62706E023703}">
-                      <ahyp:hlinkClr xmlns:ahyp="http://schemas.microsoft.com/office/drawing/2018/hyperlinkcolor" val="tx"/>
-                    </a:ext>
-                  </a:extLst>
-                </a:hlinkClick>
-              </a:rPr>
-              <a:t> </a:t>
+              <a:t>, </a:t>
             </a:r>
             <a:r>
               <a:rPr lang="en-IN" sz="2000" dirty="0">
@@ -22434,9 +22435,25 @@
             </a:r>
             <a:r>
               <a:rPr lang="en-IN" sz="2000" b="1" baseline="30000" dirty="0">
+                <a:solidFill>
+                  <a:srgbClr val="FF0000"/>
+                </a:solidFill>
                 <a:latin typeface="Barlow" panose="00000500000000000000" pitchFamily="2" charset="0"/>
-              </a:rPr>
-              <a:t>[1]  </a:t>
+                <a:hlinkClick r:id="rId2" action="ppaction://hlinksldjump">
+                  <a:extLst>
+                    <a:ext uri="{A12FA001-AC4F-418D-AE19-62706E023703}">
+                      <ahyp:hlinkClr xmlns:ahyp="http://schemas.microsoft.com/office/drawing/2018/hyperlinkcolor" val="tx"/>
+                    </a:ext>
+                  </a:extLst>
+                </a:hlinkClick>
+              </a:rPr>
+              <a:t>[1]</a:t>
+            </a:r>
+            <a:r>
+              <a:rPr lang="en-IN" sz="2000" b="1" baseline="30000" dirty="0">
+                <a:latin typeface="Barlow" panose="00000500000000000000" pitchFamily="2" charset="0"/>
+              </a:rPr>
+              <a:t>  </a:t>
             </a:r>
             <a:r>
               <a:rPr lang="en-IN" sz="2000" dirty="0">
@@ -23442,6 +23459,15 @@
 </file>
 
 <file path=customXml/item1.xml><?xml version="1.0" encoding="utf-8"?>
+<?mso-contentType ?>
+<FormTemplates xmlns="http://schemas.microsoft.com/sharepoint/v3/contenttype/forms">
+  <Display>DocumentLibraryForm</Display>
+  <Edit>DocumentLibraryForm</Edit>
+  <New>DocumentLibraryForm</New>
+</FormTemplates>
+</file>
+
+<file path=customXml/item2.xml><?xml version="1.0" encoding="utf-8"?>
 <p:properties xmlns:p="http://schemas.microsoft.com/office/2006/metadata/properties" xmlns:xsi="http://www.w3.org/2001/XMLSchema-instance" xmlns:pc="http://schemas.microsoft.com/office/infopath/2007/PartnerControls">
   <documentManagement>
     <_ip_UnifiedCompliancePolicyUIAction xmlns="http://schemas.microsoft.com/sharepoint/v3" xsi:nil="true"/>
@@ -23459,15 +23485,6 @@
     <MediaServiceKeyPoints xmlns="71af3243-3dd4-4a8d-8c0d-dd76da1f02a5" xsi:nil="true"/>
   </documentManagement>
 </p:properties>
-</file>
-
-<file path=customXml/item2.xml><?xml version="1.0" encoding="utf-8"?>
-<?mso-contentType ?>
-<FormTemplates xmlns="http://schemas.microsoft.com/sharepoint/v3/contenttype/forms">
-  <Display>DocumentLibraryForm</Display>
-  <Edit>DocumentLibraryForm</Edit>
-  <New>DocumentLibraryForm</New>
-</FormTemplates>
 </file>
 
 <file path=customXml/item3.xml><?xml version="1.0" encoding="utf-8"?>
@@ -23759,28 +23776,28 @@
 </file>
 
 <file path=customXml/itemProps1.xml><?xml version="1.0" encoding="utf-8"?>
-<ds:datastoreItem xmlns:ds="http://schemas.openxmlformats.org/officeDocument/2006/customXml" ds:itemID="{BC8413E5-0484-489B-B293-D8720B6027F2}">
+<ds:datastoreItem xmlns:ds="http://schemas.openxmlformats.org/officeDocument/2006/customXml" ds:itemID="{019B3EA6-E2E1-4B68-B700-9432F9FC79DA}">
   <ds:schemaRefs>
-    <ds:schemaRef ds:uri="http://purl.org/dc/elements/1.1/"/>
-    <ds:schemaRef ds:uri="http://schemas.microsoft.com/office/2006/metadata/properties"/>
-    <ds:schemaRef ds:uri="http://schemas.microsoft.com/sharepoint/v3"/>
-    <ds:schemaRef ds:uri="http://schemas.microsoft.com/office/2006/documentManagement/types"/>
-    <ds:schemaRef ds:uri="230e9df3-be65-4c73-a93b-d1236ebd677e"/>
-    <ds:schemaRef ds:uri="http://schemas.microsoft.com/office/infopath/2007/PartnerControls"/>
-    <ds:schemaRef ds:uri="http://www.w3.org/XML/1998/namespace"/>
-    <ds:schemaRef ds:uri="http://schemas.openxmlformats.org/package/2006/metadata/core-properties"/>
-    <ds:schemaRef ds:uri="http://purl.org/dc/terms/"/>
-    <ds:schemaRef ds:uri="16c05727-aa75-4e4a-9b5f-8a80a1165891"/>
-    <ds:schemaRef ds:uri="71af3243-3dd4-4a8d-8c0d-dd76da1f02a5"/>
-    <ds:schemaRef ds:uri="http://purl.org/dc/dcmitype/"/>
+    <ds:schemaRef ds:uri="http://schemas.microsoft.com/sharepoint/v3/contenttype/forms"/>
   </ds:schemaRefs>
 </ds:datastoreItem>
 </file>
 
 <file path=customXml/itemProps2.xml><?xml version="1.0" encoding="utf-8"?>
-<ds:datastoreItem xmlns:ds="http://schemas.openxmlformats.org/officeDocument/2006/customXml" ds:itemID="{019B3EA6-E2E1-4B68-B700-9432F9FC79DA}">
+<ds:datastoreItem xmlns:ds="http://schemas.openxmlformats.org/officeDocument/2006/customXml" ds:itemID="{BC8413E5-0484-489B-B293-D8720B6027F2}">
   <ds:schemaRefs>
-    <ds:schemaRef ds:uri="http://schemas.microsoft.com/sharepoint/v3/contenttype/forms"/>
+    <ds:schemaRef ds:uri="http://schemas.openxmlformats.org/package/2006/metadata/core-properties"/>
+    <ds:schemaRef ds:uri="http://schemas.microsoft.com/office/2006/metadata/properties"/>
+    <ds:schemaRef ds:uri="http://purl.org/dc/dcmitype/"/>
+    <ds:schemaRef ds:uri="http://purl.org/dc/elements/1.1/"/>
+    <ds:schemaRef ds:uri="http://schemas.microsoft.com/office/2006/documentManagement/types"/>
+    <ds:schemaRef ds:uri="230e9df3-be65-4c73-a93b-d1236ebd677e"/>
+    <ds:schemaRef ds:uri="71af3243-3dd4-4a8d-8c0d-dd76da1f02a5"/>
+    <ds:schemaRef ds:uri="http://schemas.microsoft.com/sharepoint/v3"/>
+    <ds:schemaRef ds:uri="http://schemas.microsoft.com/office/infopath/2007/PartnerControls"/>
+    <ds:schemaRef ds:uri="16c05727-aa75-4e4a-9b5f-8a80a1165891"/>
+    <ds:schemaRef ds:uri="http://www.w3.org/XML/1998/namespace"/>
+    <ds:schemaRef ds:uri="http://purl.org/dc/terms/"/>
   </ds:schemaRefs>
 </ds:datastoreItem>
 </file>

</xml_diff>

<commit_message>
Update thesis presentation with revised metrics and additional loss function details
</commit_message>
<xml_diff>
--- a/cross_encoder/thesis/Thesis_presentation.pptx
+++ b/cross_encoder/thesis/Thesis_presentation.pptx
@@ -2771,7 +2771,7 @@
           </a:effectLst>
           <a:extLst>
             <a:ext uri="{91240B29-F687-4f45-9708-019B960494DF}">
-              <a14:hiddenLine xmlns="" xmlns:a14="http://schemas.microsoft.com/office/drawing/2010/main" w="9525">
+              <a14:hiddenLine xmlns:a14="http://schemas.microsoft.com/office/drawing/2010/main" xmlns="" w="9525">
                 <a:solidFill>
                   <a:srgbClr val="000000"/>
                 </a:solidFill>
@@ -3499,7 +3499,7 @@
           </a:effectLst>
           <a:extLst>
             <a:ext uri="{91240B29-F687-4f45-9708-019B960494DF}">
-              <a14:hiddenLine xmlns="" xmlns:a14="http://schemas.microsoft.com/office/drawing/2010/main" w="9525">
+              <a14:hiddenLine xmlns:a14="http://schemas.microsoft.com/office/drawing/2010/main" xmlns="" w="9525">
                 <a:solidFill>
                   <a:srgbClr val="000000"/>
                 </a:solidFill>
@@ -4004,7 +4004,7 @@
           </a:effectLst>
           <a:extLst>
             <a:ext uri="{91240B29-F687-4f45-9708-019B960494DF}">
-              <a14:hiddenLine xmlns="" xmlns:a14="http://schemas.microsoft.com/office/drawing/2010/main" w="9525">
+              <a14:hiddenLine xmlns:a14="http://schemas.microsoft.com/office/drawing/2010/main" xmlns="" w="9525">
                 <a:solidFill>
                   <a:srgbClr val="000000"/>
                 </a:solidFill>
@@ -4483,7 +4483,7 @@
           </a:effectLst>
           <a:extLst>
             <a:ext uri="{91240B29-F687-4f45-9708-019B960494DF}">
-              <a14:hiddenLine xmlns="" xmlns:a14="http://schemas.microsoft.com/office/drawing/2010/main" w="9525">
+              <a14:hiddenLine xmlns:a14="http://schemas.microsoft.com/office/drawing/2010/main" xmlns="" w="9525">
                 <a:solidFill>
                   <a:srgbClr val="000000"/>
                 </a:solidFill>
@@ -5778,7 +5778,7 @@
           </a:effectLst>
           <a:extLst>
             <a:ext uri="{91240B29-F687-4f45-9708-019B960494DF}">
-              <a14:hiddenLine xmlns="" xmlns:a14="http://schemas.microsoft.com/office/drawing/2010/main" w="9525">
+              <a14:hiddenLine xmlns:a14="http://schemas.microsoft.com/office/drawing/2010/main" xmlns="" w="9525">
                 <a:solidFill>
                   <a:srgbClr val="000000"/>
                 </a:solidFill>
@@ -6107,7 +6107,7 @@
           </a:effectLst>
           <a:extLst>
             <a:ext uri="{91240B29-F687-4f45-9708-019B960494DF}">
-              <a14:hiddenLine xmlns="" xmlns:a14="http://schemas.microsoft.com/office/drawing/2010/main" w="9525">
+              <a14:hiddenLine xmlns:a14="http://schemas.microsoft.com/office/drawing/2010/main" xmlns="" w="9525">
                 <a:solidFill>
                   <a:srgbClr val="000000"/>
                 </a:solidFill>
@@ -6757,7 +6757,7 @@
           </a:effectLst>
           <a:extLst>
             <a:ext uri="{91240B29-F687-4f45-9708-019B960494DF}">
-              <a14:hiddenLine xmlns="" xmlns:a14="http://schemas.microsoft.com/office/drawing/2010/main" w="9525">
+              <a14:hiddenLine xmlns:a14="http://schemas.microsoft.com/office/drawing/2010/main" xmlns="" w="9525">
                 <a:solidFill>
                   <a:srgbClr val="000000"/>
                 </a:solidFill>
@@ -7177,7 +7177,7 @@
           </a:effectLst>
           <a:extLst>
             <a:ext uri="{91240B29-F687-4f45-9708-019B960494DF}">
-              <a14:hiddenLine xmlns="" xmlns:a14="http://schemas.microsoft.com/office/drawing/2010/main" w="9525">
+              <a14:hiddenLine xmlns:a14="http://schemas.microsoft.com/office/drawing/2010/main" xmlns="" w="9525">
                 <a:solidFill>
                   <a:srgbClr val="000000"/>
                 </a:solidFill>
@@ -8014,7 +8014,7 @@
           </a:effectLst>
           <a:extLst>
             <a:ext uri="{91240B29-F687-4f45-9708-019B960494DF}">
-              <a14:hiddenLine xmlns="" xmlns:a14="http://schemas.microsoft.com/office/drawing/2010/main" w="9525">
+              <a14:hiddenLine xmlns:a14="http://schemas.microsoft.com/office/drawing/2010/main" xmlns="" w="9525">
                 <a:solidFill>
                   <a:srgbClr val="000000"/>
                 </a:solidFill>
@@ -8905,7 +8905,7 @@
           </a:effectLst>
           <a:extLst>
             <a:ext uri="{91240B29-F687-4f45-9708-019B960494DF}">
-              <a14:hiddenLine xmlns="" xmlns:a14="http://schemas.microsoft.com/office/drawing/2010/main" w="9525">
+              <a14:hiddenLine xmlns:a14="http://schemas.microsoft.com/office/drawing/2010/main" xmlns="" w="9525">
                 <a:solidFill>
                   <a:srgbClr val="000000"/>
                 </a:solidFill>
@@ -10320,7 +10320,7 @@
         </p:nvSpPr>
         <p:spPr>
           <a:xfrm>
-            <a:off x="582006" y="479592"/>
+            <a:off x="558560" y="292023"/>
             <a:ext cx="5399343" cy="720033"/>
           </a:xfrm>
           <a:solidFill>
@@ -10371,18 +10371,18 @@
         </p:nvSpPr>
         <p:spPr>
           <a:xfrm>
-            <a:off x="741512" y="1635853"/>
-            <a:ext cx="10953183" cy="5044557"/>
+            <a:off x="739922" y="1201615"/>
+            <a:ext cx="10953183" cy="5656385"/>
           </a:xfrm>
         </p:spPr>
         <p:txBody>
           <a:bodyPr>
-            <a:normAutofit fontScale="77500" lnSpcReduction="20000"/>
+            <a:normAutofit lnSpcReduction="10000"/>
           </a:bodyPr>
           <a:lstStyle/>
           <a:p>
             <a:r>
-              <a:rPr lang="en-IN" sz="3100" b="1" dirty="0">
+              <a:rPr lang="en-IN" b="1" dirty="0">
                 <a:solidFill>
                   <a:schemeClr val="tx2"/>
                 </a:solidFill>
@@ -10394,25 +10394,25 @@
           <a:p>
             <a:pPr lvl="1"/>
             <a:r>
-              <a:rPr lang="en-IN" sz="2400" b="1" dirty="0">
+              <a:rPr lang="en-IN" sz="1800" b="1" dirty="0">
                 <a:latin typeface="Barlow Medium" panose="00000600000000000000" pitchFamily="2" charset="0"/>
               </a:rPr>
               <a:t>T</a:t>
             </a:r>
             <a:r>
-              <a:rPr lang="en-IN" sz="2400" b="1" dirty="0">
+              <a:rPr lang="en-IN" sz="1800" b="1" dirty="0">
                 <a:latin typeface="Barlow" panose="00000500000000000000" pitchFamily="2" charset="0"/>
               </a:rPr>
               <a:t>raining:</a:t>
             </a:r>
             <a:r>
-              <a:rPr lang="en-IN" sz="2400" dirty="0">
+              <a:rPr lang="en-IN" sz="1800" dirty="0">
                 <a:latin typeface="Barlow" panose="00000500000000000000" pitchFamily="2" charset="0"/>
               </a:rPr>
               <a:t> MS MARCO</a:t>
             </a:r>
             <a:r>
-              <a:rPr lang="en-IN" sz="2400" b="1" baseline="30000" dirty="0">
+              <a:rPr lang="en-IN" sz="1800" b="1" baseline="30000" dirty="0">
                 <a:solidFill>
                   <a:srgbClr val="FF0000"/>
                 </a:solidFill>
@@ -10428,7 +10428,7 @@
               <a:t>[9]</a:t>
             </a:r>
             <a:r>
-              <a:rPr lang="en-IN" sz="2400" dirty="0">
+              <a:rPr lang="en-IN" sz="1800" dirty="0">
                 <a:solidFill>
                   <a:srgbClr val="FFC000"/>
                 </a:solidFill>
@@ -10444,7 +10444,7 @@
               <a:t> </a:t>
             </a:r>
             <a:r>
-              <a:rPr lang="en-IN" sz="2400" dirty="0">
+              <a:rPr lang="en-IN" sz="1800" dirty="0">
                 <a:latin typeface="Barlow" panose="00000500000000000000" pitchFamily="2" charset="0"/>
               </a:rPr>
               <a:t>Passage Ranking (~2M triplets)</a:t>
@@ -10453,19 +10453,19 @@
           <a:p>
             <a:pPr lvl="1"/>
             <a:r>
-              <a:rPr lang="en-IN" sz="2400" b="1" dirty="0">
+              <a:rPr lang="en-IN" sz="1800" b="1" dirty="0">
                 <a:latin typeface="Barlow" panose="00000500000000000000" pitchFamily="2" charset="0"/>
               </a:rPr>
               <a:t>Evaluation:</a:t>
             </a:r>
             <a:r>
-              <a:rPr lang="en-IN" sz="2400" dirty="0">
+              <a:rPr lang="en-IN" sz="1800" dirty="0">
                 <a:latin typeface="Barlow" panose="00000500000000000000" pitchFamily="2" charset="0"/>
               </a:rPr>
               <a:t> TREC DL</a:t>
             </a:r>
             <a:r>
-              <a:rPr lang="en-IN" sz="2400" b="1" baseline="30000" dirty="0">
+              <a:rPr lang="en-IN" sz="1800" b="1" baseline="30000" dirty="0">
                 <a:solidFill>
                   <a:srgbClr val="FF0000"/>
                 </a:solidFill>
@@ -10481,7 +10481,7 @@
               <a:t>[8]</a:t>
             </a:r>
             <a:r>
-              <a:rPr lang="en-IN" sz="2400" dirty="0">
+              <a:rPr lang="en-IN" sz="1800" dirty="0">
                 <a:solidFill>
                   <a:srgbClr val="FFC000"/>
                 </a:solidFill>
@@ -10497,7 +10497,7 @@
               <a:t> </a:t>
             </a:r>
             <a:r>
-              <a:rPr lang="en-IN" sz="2400" dirty="0">
+              <a:rPr lang="en-IN" sz="1800" dirty="0">
                 <a:latin typeface="Barlow" panose="00000500000000000000" pitchFamily="2" charset="0"/>
               </a:rPr>
               <a:t>2019 (43 queries with comprehensive relevance judgments)</a:t>
@@ -10506,19 +10506,19 @@
           <a:p>
             <a:pPr lvl="1"/>
             <a:r>
-              <a:rPr lang="en-IN" sz="2400" b="1" dirty="0">
+              <a:rPr lang="en-IN" sz="1800" b="1" dirty="0">
                 <a:latin typeface="Barlow" panose="00000500000000000000" pitchFamily="2" charset="0"/>
               </a:rPr>
               <a:t>Metrics:</a:t>
             </a:r>
             <a:r>
-              <a:rPr lang="en-IN" sz="2400" dirty="0">
+              <a:rPr lang="en-IN" sz="1800" dirty="0">
                 <a:latin typeface="Barlow" panose="00000500000000000000" pitchFamily="2" charset="0"/>
               </a:rPr>
               <a:t> NDCG@10</a:t>
             </a:r>
             <a:r>
-              <a:rPr lang="en-IN" sz="2400" baseline="30000" dirty="0">
+              <a:rPr lang="en-IN" sz="1800" b="1" baseline="30000" dirty="0">
                 <a:solidFill>
                   <a:srgbClr val="FF0000"/>
                 </a:solidFill>
@@ -10534,7 +10534,7 @@
               <a:t>[16] </a:t>
             </a:r>
             <a:r>
-              <a:rPr lang="en-IN" sz="2400" dirty="0">
+              <a:rPr lang="en-IN" sz="1800" dirty="0">
                 <a:latin typeface="Barlow" panose="00000500000000000000" pitchFamily="2" charset="0"/>
               </a:rPr>
               <a:t>, MRR@10, Recall@10, P@10</a:t>
@@ -10542,7 +10542,7 @@
           </a:p>
           <a:p>
             <a:r>
-              <a:rPr lang="en-IN" sz="3100" b="1" dirty="0">
+              <a:rPr lang="en-IN" b="1" dirty="0">
                 <a:solidFill>
                   <a:schemeClr val="tx2"/>
                 </a:solidFill>
@@ -10554,19 +10554,19 @@
           <a:p>
             <a:pPr lvl="1"/>
             <a:r>
-              <a:rPr lang="en-IN" sz="2400" b="1" dirty="0">
+              <a:rPr lang="en-IN" sz="1800" b="1" dirty="0">
                 <a:latin typeface="Barlow" panose="00000500000000000000" pitchFamily="2" charset="0"/>
               </a:rPr>
               <a:t>Platform:</a:t>
             </a:r>
             <a:r>
-              <a:rPr lang="en-IN" sz="2400" dirty="0">
+              <a:rPr lang="en-IN" sz="1800" dirty="0">
                 <a:latin typeface="Barlow" panose="00000500000000000000" pitchFamily="2" charset="0"/>
               </a:rPr>
               <a:t> Modal cloud computing</a:t>
             </a:r>
             <a:r>
-              <a:rPr lang="en-IN" sz="2400" b="1" baseline="30000" dirty="0">
+              <a:rPr lang="en-IN" sz="1800" b="1" baseline="30000" dirty="0">
                 <a:solidFill>
                   <a:srgbClr val="FF0000"/>
                 </a:solidFill>
@@ -10581,7 +10581,7 @@
               </a:rPr>
               <a:t>[10]</a:t>
             </a:r>
-            <a:endParaRPr lang="en-IN" sz="2400" b="1" baseline="30000" dirty="0">
+            <a:endParaRPr lang="en-IN" sz="1800" b="1" baseline="30000" dirty="0">
               <a:solidFill>
                 <a:srgbClr val="FF0000"/>
               </a:solidFill>
@@ -10591,34 +10591,34 @@
           <a:p>
             <a:pPr lvl="1"/>
             <a:r>
-              <a:rPr lang="en-IN" sz="2400" b="1" dirty="0">
+              <a:rPr lang="en-IN" sz="1800" b="1" dirty="0">
                 <a:latin typeface="Barlow" panose="00000500000000000000" pitchFamily="2" charset="0"/>
               </a:rPr>
               <a:t>Hardware:</a:t>
             </a:r>
             <a:r>
-              <a:rPr lang="en-IN" sz="2400" dirty="0">
+              <a:rPr lang="en-IN" sz="1800" dirty="0">
                 <a:latin typeface="Barlow" panose="00000500000000000000" pitchFamily="2" charset="0"/>
               </a:rPr>
-              <a:t> 3 × NVIDIA L40S GPUs</a:t>
+              <a:t> 3 × NVIDIA-L40S GPUs</a:t>
             </a:r>
           </a:p>
           <a:p>
             <a:pPr lvl="1"/>
             <a:r>
-              <a:rPr lang="en-IN" sz="2400" b="1" dirty="0">
+              <a:rPr lang="en-IN" sz="1800" b="1" dirty="0">
                 <a:latin typeface="Barlow" panose="00000500000000000000" pitchFamily="2" charset="0"/>
               </a:rPr>
               <a:t>Monitoring:</a:t>
             </a:r>
             <a:r>
-              <a:rPr lang="en-IN" sz="2400" dirty="0">
+              <a:rPr lang="en-IN" sz="1800" dirty="0">
                 <a:latin typeface="Barlow" panose="00000500000000000000" pitchFamily="2" charset="0"/>
               </a:rPr>
               <a:t> Weights &amp; Biases</a:t>
             </a:r>
             <a:r>
-              <a:rPr lang="en-IN" sz="2400" b="1" baseline="30000" dirty="0">
+              <a:rPr lang="en-IN" sz="1800" b="1" baseline="30000" dirty="0">
                 <a:solidFill>
                   <a:srgbClr val="FF0000"/>
                 </a:solidFill>
@@ -10633,7 +10633,7 @@
               </a:rPr>
               <a:t>[11]</a:t>
             </a:r>
-            <a:endParaRPr lang="en-IN" sz="2400" b="1" baseline="30000" dirty="0">
+            <a:endParaRPr lang="en-IN" sz="1800" b="1" baseline="30000" dirty="0">
               <a:solidFill>
                 <a:srgbClr val="FF0000"/>
               </a:solidFill>
@@ -10643,13 +10643,13 @@
           <a:p>
             <a:pPr lvl="1"/>
             <a:r>
-              <a:rPr lang="en-IN" sz="2400" b="1" dirty="0">
+              <a:rPr lang="en-IN" sz="1800" b="1" dirty="0">
                 <a:latin typeface="Barlow" panose="00000500000000000000" pitchFamily="2" charset="0"/>
               </a:rPr>
               <a:t>Training:</a:t>
             </a:r>
             <a:r>
-              <a:rPr lang="en-IN" sz="2400" dirty="0">
+              <a:rPr lang="en-IN" sz="1800" dirty="0">
                 <a:latin typeface="Barlow" panose="00000500000000000000" pitchFamily="2" charset="0"/>
               </a:rPr>
               <a:t> 3 epochs per configuration</a:t>
@@ -10657,7 +10657,7 @@
           </a:p>
           <a:p>
             <a:r>
-              <a:rPr lang="en-IN" sz="3100" b="1" dirty="0">
+              <a:rPr lang="en-IN" b="1" dirty="0">
                 <a:solidFill>
                   <a:schemeClr val="tx2"/>
                 </a:solidFill>
@@ -10669,13 +10669,13 @@
           <a:p>
             <a:pPr lvl="1"/>
             <a:r>
-              <a:rPr lang="en-IN" sz="2400" b="1" dirty="0">
+              <a:rPr lang="en-IN" sz="1800" b="1" dirty="0">
                 <a:latin typeface="Barlow" panose="00000500000000000000" pitchFamily="2" charset="0"/>
               </a:rPr>
               <a:t>Total Configurations:</a:t>
             </a:r>
             <a:r>
-              <a:rPr lang="en-IN" sz="2400" dirty="0">
+              <a:rPr lang="en-IN" sz="1800" dirty="0">
                 <a:latin typeface="Barlow" panose="00000500000000000000" pitchFamily="2" charset="0"/>
               </a:rPr>
               <a:t> 6 (3 models × 2 optimizers)</a:t>
@@ -10684,34 +10684,34 @@
           <a:p>
             <a:pPr lvl="1"/>
             <a:r>
-              <a:rPr lang="en-IN" sz="2400" b="1" dirty="0">
+              <a:rPr lang="en-IN" sz="1800" b="1" dirty="0">
                 <a:latin typeface="Barlow" panose="00000500000000000000" pitchFamily="2" charset="0"/>
               </a:rPr>
               <a:t>Controlled Variables:</a:t>
             </a:r>
             <a:r>
-              <a:rPr lang="en-IN" sz="2400" dirty="0">
+              <a:rPr lang="en-IN" sz="1800" dirty="0">
                 <a:latin typeface="Barlow" panose="00000500000000000000" pitchFamily="2" charset="0"/>
               </a:rPr>
-              <a:t> Batch size, training steps, evaluation frequency</a:t>
+              <a:t> Batch size = 64, training steps, evaluation frequency</a:t>
             </a:r>
           </a:p>
           <a:p>
             <a:pPr lvl="1"/>
             <a:r>
-              <a:rPr lang="en-IN" sz="2400" b="1" dirty="0">
+              <a:rPr lang="en-IN" sz="1800" b="1" dirty="0">
                 <a:latin typeface="Barlow" panose="00000500000000000000" pitchFamily="2" charset="0"/>
               </a:rPr>
               <a:t>Variable Parameters:</a:t>
             </a:r>
             <a:r>
-              <a:rPr lang="en-IN" sz="2400" dirty="0">
+              <a:rPr lang="en-IN" sz="1800" dirty="0">
                 <a:latin typeface="Barlow" panose="00000500000000000000" pitchFamily="2" charset="0"/>
               </a:rPr>
               <a:t> Learning rates (2e-5 standard, 2e-6 for ModernBERT</a:t>
             </a:r>
             <a:r>
-              <a:rPr lang="en-IN" sz="2400" baseline="30000" dirty="0">
+              <a:rPr lang="en-IN" sz="1800" baseline="30000" dirty="0">
                 <a:solidFill>
                   <a:srgbClr val="FF0000"/>
                 </a:solidFill>
@@ -10727,13 +10727,13 @@
               <a:t>[6]</a:t>
             </a:r>
             <a:r>
-              <a:rPr lang="en-IN" sz="2400" dirty="0">
+              <a:rPr lang="en-IN" sz="1800" dirty="0">
                 <a:latin typeface="Barlow" panose="00000500000000000000" pitchFamily="2" charset="0"/>
               </a:rPr>
               <a:t>+Lion</a:t>
             </a:r>
             <a:r>
-              <a:rPr lang="en-IN" sz="2400" baseline="30000" dirty="0">
+              <a:rPr lang="en-IN" sz="1800" baseline="30000" dirty="0">
                 <a:solidFill>
                   <a:srgbClr val="FF0000"/>
                 </a:solidFill>
@@ -10749,11 +10749,48 @@
               <a:t>[4]</a:t>
             </a:r>
             <a:r>
-              <a:rPr lang="en-IN" sz="2400" dirty="0">
+              <a:rPr lang="en-IN" sz="1800" dirty="0">
                 <a:latin typeface="Barlow" panose="00000500000000000000" pitchFamily="2" charset="0"/>
               </a:rPr>
               <a:t>)</a:t>
             </a:r>
+          </a:p>
+          <a:p>
+            <a:pPr lvl="1"/>
+            <a:r>
+              <a:rPr lang="en-IN" sz="1800" b="1" dirty="0">
+                <a:latin typeface="Barlow" panose="00000500000000000000" pitchFamily="2" charset="0"/>
+              </a:rPr>
+              <a:t>Loss Function: </a:t>
+            </a:r>
+            <a:r>
+              <a:rPr lang="en-IN" sz="1800" dirty="0">
+                <a:latin typeface="Barlow" panose="00000500000000000000" pitchFamily="2" charset="0"/>
+              </a:rPr>
+              <a:t>Binary Cross Entropy</a:t>
+            </a:r>
+            <a:r>
+              <a:rPr lang="en-IN" sz="1800" b="1" baseline="30000" dirty="0">
+                <a:solidFill>
+                  <a:srgbClr val="FF0000"/>
+                </a:solidFill>
+                <a:latin typeface="Barlow" panose="00000500000000000000" pitchFamily="2" charset="0"/>
+                <a:hlinkClick r:id="rId2" action="ppaction://hlinksldjump">
+                  <a:extLst>
+                    <a:ext uri="{A12FA001-AC4F-418D-AE19-62706E023703}">
+                      <ahyp:hlinkClr xmlns:ahyp="http://schemas.microsoft.com/office/drawing/2018/hyperlinkcolor" val="tx"/>
+                    </a:ext>
+                  </a:extLst>
+                </a:hlinkClick>
+              </a:rPr>
+              <a:t>[17]</a:t>
+            </a:r>
+            <a:endParaRPr lang="en-IN" sz="1800" b="1" baseline="30000" dirty="0">
+              <a:solidFill>
+                <a:srgbClr val="FF0000"/>
+              </a:solidFill>
+              <a:latin typeface="Barlow" panose="00000500000000000000" pitchFamily="2" charset="0"/>
+            </a:endParaRPr>
           </a:p>
         </p:txBody>
       </p:sp>
@@ -20295,13 +20332,13 @@
         </p:nvSpPr>
         <p:spPr>
           <a:xfrm>
-            <a:off x="384726" y="1106905"/>
-            <a:ext cx="11080236" cy="5329990"/>
+            <a:off x="384726" y="866582"/>
+            <a:ext cx="11080236" cy="5991418"/>
           </a:xfrm>
         </p:spPr>
         <p:txBody>
           <a:bodyPr>
-            <a:normAutofit lnSpcReduction="10000"/>
+            <a:normAutofit/>
           </a:bodyPr>
           <a:lstStyle/>
           <a:p>
@@ -20530,8 +20567,8 @@
         </p:nvSpPr>
         <p:spPr>
           <a:xfrm>
-            <a:off x="384726" y="1106905"/>
-            <a:ext cx="11080236" cy="5329990"/>
+            <a:off x="384726" y="1014046"/>
+            <a:ext cx="11080236" cy="5843954"/>
           </a:xfrm>
         </p:spPr>
         <p:txBody>
@@ -20644,9 +20681,42 @@
               </a:rPr>
               <a:t>Y. Wang et al., “A theoretical analysis of NDCG type ranking measures,” arXiv preprint arXiv:1304.6480, Apr. 2013.</a:t>
             </a:r>
-            <a:endParaRPr lang="en-IN" sz="2000" dirty="0">
-              <a:latin typeface="Barlow" panose="00000500000000000000" pitchFamily="2" charset="0"/>
-            </a:endParaRPr>
+          </a:p>
+          <a:p>
+            <a:pPr marL="457200" indent="-457200">
+              <a:buFont typeface="+mj-lt"/>
+              <a:buAutoNum type="arabicPeriod" startAt="9"/>
+            </a:pPr>
+            <a:r>
+              <a:rPr lang="en-IN" sz="2000" dirty="0">
+                <a:latin typeface="Barlow" panose="00000500000000000000" pitchFamily="2" charset="0"/>
+              </a:rPr>
+              <a:t>Ruby, Usha &amp; </a:t>
+            </a:r>
+            <a:r>
+              <a:rPr lang="en-IN" sz="2000" dirty="0" err="1">
+                <a:latin typeface="Barlow" panose="00000500000000000000" pitchFamily="2" charset="0"/>
+              </a:rPr>
+              <a:t>Yendapalli</a:t>
+            </a:r>
+            <a:r>
+              <a:rPr lang="en-IN" sz="2000" dirty="0">
+                <a:latin typeface="Barlow" panose="00000500000000000000" pitchFamily="2" charset="0"/>
+              </a:rPr>
+              <a:t>, Vamsidhar. (2020). Binary cross entropy with deep learning technique for Image classification. International Journal of Advanced Trends in Computer Science and Engineering. 9. 10.30534/</a:t>
+            </a:r>
+            <a:r>
+              <a:rPr lang="en-IN" sz="2000" dirty="0" err="1">
+                <a:latin typeface="Barlow" panose="00000500000000000000" pitchFamily="2" charset="0"/>
+              </a:rPr>
+              <a:t>ijatcse</a:t>
+            </a:r>
+            <a:r>
+              <a:rPr lang="en-IN" sz="2000" dirty="0">
+                <a:latin typeface="Barlow" panose="00000500000000000000" pitchFamily="2" charset="0"/>
+              </a:rPr>
+              <a:t>/2020/175942020. </a:t>
+            </a:r>
           </a:p>
         </p:txBody>
       </p:sp>
@@ -23459,15 +23529,6 @@
 </file>
 
 <file path=customXml/item1.xml><?xml version="1.0" encoding="utf-8"?>
-<?mso-contentType ?>
-<FormTemplates xmlns="http://schemas.microsoft.com/sharepoint/v3/contenttype/forms">
-  <Display>DocumentLibraryForm</Display>
-  <Edit>DocumentLibraryForm</Edit>
-  <New>DocumentLibraryForm</New>
-</FormTemplates>
-</file>
-
-<file path=customXml/item2.xml><?xml version="1.0" encoding="utf-8"?>
 <p:properties xmlns:p="http://schemas.microsoft.com/office/2006/metadata/properties" xmlns:xsi="http://www.w3.org/2001/XMLSchema-instance" xmlns:pc="http://schemas.microsoft.com/office/infopath/2007/PartnerControls">
   <documentManagement>
     <_ip_UnifiedCompliancePolicyUIAction xmlns="http://schemas.microsoft.com/sharepoint/v3" xsi:nil="true"/>
@@ -23485,6 +23546,15 @@
     <MediaServiceKeyPoints xmlns="71af3243-3dd4-4a8d-8c0d-dd76da1f02a5" xsi:nil="true"/>
   </documentManagement>
 </p:properties>
+</file>
+
+<file path=customXml/item2.xml><?xml version="1.0" encoding="utf-8"?>
+<?mso-contentType ?>
+<FormTemplates xmlns="http://schemas.microsoft.com/sharepoint/v3/contenttype/forms">
+  <Display>DocumentLibraryForm</Display>
+  <Edit>DocumentLibraryForm</Edit>
+  <New>DocumentLibraryForm</New>
+</FormTemplates>
 </file>
 
 <file path=customXml/item3.xml><?xml version="1.0" encoding="utf-8"?>
@@ -23776,14 +23846,6 @@
 </file>
 
 <file path=customXml/itemProps1.xml><?xml version="1.0" encoding="utf-8"?>
-<ds:datastoreItem xmlns:ds="http://schemas.openxmlformats.org/officeDocument/2006/customXml" ds:itemID="{019B3EA6-E2E1-4B68-B700-9432F9FC79DA}">
-  <ds:schemaRefs>
-    <ds:schemaRef ds:uri="http://schemas.microsoft.com/sharepoint/v3/contenttype/forms"/>
-  </ds:schemaRefs>
-</ds:datastoreItem>
-</file>
-
-<file path=customXml/itemProps2.xml><?xml version="1.0" encoding="utf-8"?>
 <ds:datastoreItem xmlns:ds="http://schemas.openxmlformats.org/officeDocument/2006/customXml" ds:itemID="{BC8413E5-0484-489B-B293-D8720B6027F2}">
   <ds:schemaRefs>
     <ds:schemaRef ds:uri="http://schemas.openxmlformats.org/package/2006/metadata/core-properties"/>
@@ -23798,6 +23860,14 @@
     <ds:schemaRef ds:uri="16c05727-aa75-4e4a-9b5f-8a80a1165891"/>
     <ds:schemaRef ds:uri="http://www.w3.org/XML/1998/namespace"/>
     <ds:schemaRef ds:uri="http://purl.org/dc/terms/"/>
+  </ds:schemaRefs>
+</ds:datastoreItem>
+</file>
+
+<file path=customXml/itemProps2.xml><?xml version="1.0" encoding="utf-8"?>
+<ds:datastoreItem xmlns:ds="http://schemas.openxmlformats.org/officeDocument/2006/customXml" ds:itemID="{019B3EA6-E2E1-4B68-B700-9432F9FC79DA}">
+  <ds:schemaRefs>
+    <ds:schemaRef ds:uri="http://schemas.microsoft.com/sharepoint/v3/contenttype/forms"/>
   </ds:schemaRefs>
 </ds:datastoreItem>
 </file>

</xml_diff>